<commit_message>
Add animations to the presentation
</commit_message>
<xml_diff>
--- a/docs/presentation/TempSafe_Elevator_Pitch.pptx
+++ b/docs/presentation/TempSafe_Elevator_Pitch.pptx
@@ -1281,7 +1281,7 @@
         <p:spPr>
           <a:xfrm>
             <a:off x="9006840" y="502920"/>
-            <a:ext cx="2651760" cy="493776"/>
+            <a:ext cx="2651760" cy="340360"/>
           </a:xfrm>
           <a:prstGeom prst="roundRect">
             <a:avLst>
@@ -1478,7 +1478,7 @@
         </p:nvSpPr>
         <p:spPr>
           <a:xfrm>
-            <a:off x="713232" y="1572768"/>
+            <a:off x="690372" y="1517904"/>
             <a:ext cx="2423160" cy="384048"/>
           </a:xfrm>
           <a:prstGeom prst="roundRect">
@@ -1500,7 +1500,7 @@
           <a:bodyPr/>
           <a:lstStyle/>
           <a:p>
-            <a:endParaRPr lang="en-IE"/>
+            <a:endParaRPr lang="en-IE" dirty="0"/>
           </a:p>
         </p:txBody>
       </p:sp>
@@ -5972,7 +5972,7 @@
         </p:nvSpPr>
         <p:spPr>
           <a:xfrm>
-            <a:off x="8553450" y="4600575"/>
+            <a:off x="9544050" y="4601441"/>
             <a:ext cx="1714500" cy="247650"/>
           </a:xfrm>
           <a:prstGeom prst="rect">
@@ -6009,7 +6009,7 @@
               </a:defRPr>
             </a:pPr>
             <a:r>
-              <a:rPr sz="1200" b="0">
+              <a:rPr sz="1200" b="0" dirty="0">
                 <a:solidFill>
                   <a:srgbClr val="5D647A"/>
                 </a:solidFill>
@@ -6191,7 +6191,7 @@
               </a:defRPr>
             </a:pPr>
             <a:r>
-              <a:rPr sz="1125" b="1">
+              <a:rPr sz="1125" b="1" dirty="0">
                 <a:solidFill>
                   <a:srgbClr val="737B91"/>
                 </a:solidFill>
@@ -6257,7 +6257,7 @@
               </a:defRPr>
             </a:pPr>
             <a:r>
-              <a:rPr sz="1650" b="1">
+              <a:rPr sz="1650" b="1" dirty="0">
                 <a:solidFill>
                   <a:srgbClr val="986317"/>
                 </a:solidFill>
@@ -7083,6 +7083,1284 @@
   <p:clrMapOvr>
     <a:masterClrMapping/>
   </p:clrMapOvr>
+  <p:timing>
+    <p:tnLst>
+      <p:par>
+        <p:cTn id="1" dur="indefinite" restart="never" nodeType="tmRoot">
+          <p:childTnLst>
+            <p:seq concurrent="1" nextAc="seek">
+              <p:cTn id="2" dur="indefinite" nodeType="mainSeq">
+                <p:childTnLst>
+                  <p:par>
+                    <p:cTn id="3" fill="hold">
+                      <p:stCondLst>
+                        <p:cond delay="indefinite"/>
+                      </p:stCondLst>
+                      <p:childTnLst>
+                        <p:par>
+                          <p:cTn id="4" fill="hold">
+                            <p:stCondLst>
+                              <p:cond delay="0"/>
+                            </p:stCondLst>
+                            <p:childTnLst>
+                              <p:par>
+                                <p:cTn id="5" presetID="1" presetClass="entr" presetSubtype="0" fill="hold" grpId="0" nodeType="clickEffect">
+                                  <p:stCondLst>
+                                    <p:cond delay="0"/>
+                                  </p:stCondLst>
+                                  <p:childTnLst>
+                                    <p:set>
+                                      <p:cBhvr>
+                                        <p:cTn id="6" dur="1" fill="hold">
+                                          <p:stCondLst>
+                                            <p:cond delay="0"/>
+                                          </p:stCondLst>
+                                        </p:cTn>
+                                        <p:tgtEl>
+                                          <p:spTgt spid="25"/>
+                                        </p:tgtEl>
+                                        <p:attrNameLst>
+                                          <p:attrName>style.visibility</p:attrName>
+                                        </p:attrNameLst>
+                                      </p:cBhvr>
+                                      <p:to>
+                                        <p:strVal val="visible"/>
+                                      </p:to>
+                                    </p:set>
+                                  </p:childTnLst>
+                                </p:cTn>
+                              </p:par>
+                              <p:par>
+                                <p:cTn id="7" presetID="1" presetClass="entr" presetSubtype="0" fill="hold" grpId="0" nodeType="withEffect">
+                                  <p:stCondLst>
+                                    <p:cond delay="0"/>
+                                  </p:stCondLst>
+                                  <p:childTnLst>
+                                    <p:set>
+                                      <p:cBhvr>
+                                        <p:cTn id="8" dur="1" fill="hold">
+                                          <p:stCondLst>
+                                            <p:cond delay="0"/>
+                                          </p:stCondLst>
+                                        </p:cTn>
+                                        <p:tgtEl>
+                                          <p:spTgt spid="26"/>
+                                        </p:tgtEl>
+                                        <p:attrNameLst>
+                                          <p:attrName>style.visibility</p:attrName>
+                                        </p:attrNameLst>
+                                      </p:cBhvr>
+                                      <p:to>
+                                        <p:strVal val="visible"/>
+                                      </p:to>
+                                    </p:set>
+                                  </p:childTnLst>
+                                </p:cTn>
+                              </p:par>
+                            </p:childTnLst>
+                          </p:cTn>
+                        </p:par>
+                      </p:childTnLst>
+                    </p:cTn>
+                  </p:par>
+                  <p:par>
+                    <p:cTn id="9" fill="hold">
+                      <p:stCondLst>
+                        <p:cond delay="indefinite"/>
+                      </p:stCondLst>
+                      <p:childTnLst>
+                        <p:par>
+                          <p:cTn id="10" fill="hold">
+                            <p:stCondLst>
+                              <p:cond delay="0"/>
+                            </p:stCondLst>
+                            <p:childTnLst>
+                              <p:par>
+                                <p:cTn id="11" presetID="1" presetClass="entr" presetSubtype="0" fill="hold" grpId="0" nodeType="clickEffect">
+                                  <p:stCondLst>
+                                    <p:cond delay="0"/>
+                                  </p:stCondLst>
+                                  <p:childTnLst>
+                                    <p:set>
+                                      <p:cBhvr>
+                                        <p:cTn id="12" dur="1" fill="hold">
+                                          <p:stCondLst>
+                                            <p:cond delay="0"/>
+                                          </p:stCondLst>
+                                        </p:cTn>
+                                        <p:tgtEl>
+                                          <p:spTgt spid="27"/>
+                                        </p:tgtEl>
+                                        <p:attrNameLst>
+                                          <p:attrName>style.visibility</p:attrName>
+                                        </p:attrNameLst>
+                                      </p:cBhvr>
+                                      <p:to>
+                                        <p:strVal val="visible"/>
+                                      </p:to>
+                                    </p:set>
+                                  </p:childTnLst>
+                                </p:cTn>
+                              </p:par>
+                              <p:par>
+                                <p:cTn id="13" presetID="1" presetClass="entr" presetSubtype="0" fill="hold" grpId="0" nodeType="withEffect">
+                                  <p:stCondLst>
+                                    <p:cond delay="0"/>
+                                  </p:stCondLst>
+                                  <p:childTnLst>
+                                    <p:set>
+                                      <p:cBhvr>
+                                        <p:cTn id="14" dur="1" fill="hold">
+                                          <p:stCondLst>
+                                            <p:cond delay="0"/>
+                                          </p:stCondLst>
+                                        </p:cTn>
+                                        <p:tgtEl>
+                                          <p:spTgt spid="28"/>
+                                        </p:tgtEl>
+                                        <p:attrNameLst>
+                                          <p:attrName>style.visibility</p:attrName>
+                                        </p:attrNameLst>
+                                      </p:cBhvr>
+                                      <p:to>
+                                        <p:strVal val="visible"/>
+                                      </p:to>
+                                    </p:set>
+                                  </p:childTnLst>
+                                </p:cTn>
+                              </p:par>
+                            </p:childTnLst>
+                          </p:cTn>
+                        </p:par>
+                      </p:childTnLst>
+                    </p:cTn>
+                  </p:par>
+                  <p:par>
+                    <p:cTn id="15" fill="hold">
+                      <p:stCondLst>
+                        <p:cond delay="indefinite"/>
+                      </p:stCondLst>
+                      <p:childTnLst>
+                        <p:par>
+                          <p:cTn id="16" fill="hold">
+                            <p:stCondLst>
+                              <p:cond delay="0"/>
+                            </p:stCondLst>
+                            <p:childTnLst>
+                              <p:par>
+                                <p:cTn id="17" presetID="1" presetClass="entr" presetSubtype="0" fill="hold" grpId="0" nodeType="clickEffect">
+                                  <p:stCondLst>
+                                    <p:cond delay="0"/>
+                                  </p:stCondLst>
+                                  <p:childTnLst>
+                                    <p:set>
+                                      <p:cBhvr>
+                                        <p:cTn id="18" dur="1" fill="hold">
+                                          <p:stCondLst>
+                                            <p:cond delay="0"/>
+                                          </p:stCondLst>
+                                        </p:cTn>
+                                        <p:tgtEl>
+                                          <p:spTgt spid="29"/>
+                                        </p:tgtEl>
+                                        <p:attrNameLst>
+                                          <p:attrName>style.visibility</p:attrName>
+                                        </p:attrNameLst>
+                                      </p:cBhvr>
+                                      <p:to>
+                                        <p:strVal val="visible"/>
+                                      </p:to>
+                                    </p:set>
+                                  </p:childTnLst>
+                                </p:cTn>
+                              </p:par>
+                              <p:par>
+                                <p:cTn id="19" presetID="1" presetClass="entr" presetSubtype="0" fill="hold" grpId="0" nodeType="withEffect">
+                                  <p:stCondLst>
+                                    <p:cond delay="0"/>
+                                  </p:stCondLst>
+                                  <p:childTnLst>
+                                    <p:set>
+                                      <p:cBhvr>
+                                        <p:cTn id="20" dur="1" fill="hold">
+                                          <p:stCondLst>
+                                            <p:cond delay="0"/>
+                                          </p:stCondLst>
+                                        </p:cTn>
+                                        <p:tgtEl>
+                                          <p:spTgt spid="30"/>
+                                        </p:tgtEl>
+                                        <p:attrNameLst>
+                                          <p:attrName>style.visibility</p:attrName>
+                                        </p:attrNameLst>
+                                      </p:cBhvr>
+                                      <p:to>
+                                        <p:strVal val="visible"/>
+                                      </p:to>
+                                    </p:set>
+                                  </p:childTnLst>
+                                </p:cTn>
+                              </p:par>
+                            </p:childTnLst>
+                          </p:cTn>
+                        </p:par>
+                      </p:childTnLst>
+                    </p:cTn>
+                  </p:par>
+                  <p:par>
+                    <p:cTn id="21" fill="hold">
+                      <p:stCondLst>
+                        <p:cond delay="indefinite"/>
+                      </p:stCondLst>
+                      <p:childTnLst>
+                        <p:par>
+                          <p:cTn id="22" fill="hold">
+                            <p:stCondLst>
+                              <p:cond delay="0"/>
+                            </p:stCondLst>
+                            <p:childTnLst>
+                              <p:par>
+                                <p:cTn id="23" presetID="1" presetClass="entr" presetSubtype="0" fill="hold" grpId="0" nodeType="clickEffect">
+                                  <p:stCondLst>
+                                    <p:cond delay="0"/>
+                                  </p:stCondLst>
+                                  <p:childTnLst>
+                                    <p:set>
+                                      <p:cBhvr>
+                                        <p:cTn id="24" dur="1" fill="hold">
+                                          <p:stCondLst>
+                                            <p:cond delay="0"/>
+                                          </p:stCondLst>
+                                        </p:cTn>
+                                        <p:tgtEl>
+                                          <p:spTgt spid="31"/>
+                                        </p:tgtEl>
+                                        <p:attrNameLst>
+                                          <p:attrName>style.visibility</p:attrName>
+                                        </p:attrNameLst>
+                                      </p:cBhvr>
+                                      <p:to>
+                                        <p:strVal val="visible"/>
+                                      </p:to>
+                                    </p:set>
+                                  </p:childTnLst>
+                                </p:cTn>
+                              </p:par>
+                              <p:par>
+                                <p:cTn id="25" presetID="1" presetClass="entr" presetSubtype="0" fill="hold" grpId="0" nodeType="withEffect">
+                                  <p:stCondLst>
+                                    <p:cond delay="0"/>
+                                  </p:stCondLst>
+                                  <p:childTnLst>
+                                    <p:set>
+                                      <p:cBhvr>
+                                        <p:cTn id="26" dur="1" fill="hold">
+                                          <p:stCondLst>
+                                            <p:cond delay="0"/>
+                                          </p:stCondLst>
+                                        </p:cTn>
+                                        <p:tgtEl>
+                                          <p:spTgt spid="32"/>
+                                        </p:tgtEl>
+                                        <p:attrNameLst>
+                                          <p:attrName>style.visibility</p:attrName>
+                                        </p:attrNameLst>
+                                      </p:cBhvr>
+                                      <p:to>
+                                        <p:strVal val="visible"/>
+                                      </p:to>
+                                    </p:set>
+                                  </p:childTnLst>
+                                </p:cTn>
+                              </p:par>
+                            </p:childTnLst>
+                          </p:cTn>
+                        </p:par>
+                      </p:childTnLst>
+                    </p:cTn>
+                  </p:par>
+                  <p:par>
+                    <p:cTn id="27" fill="hold">
+                      <p:stCondLst>
+                        <p:cond delay="indefinite"/>
+                      </p:stCondLst>
+                      <p:childTnLst>
+                        <p:par>
+                          <p:cTn id="28" fill="hold">
+                            <p:stCondLst>
+                              <p:cond delay="0"/>
+                            </p:stCondLst>
+                            <p:childTnLst>
+                              <p:par>
+                                <p:cTn id="29" presetID="1" presetClass="entr" presetSubtype="0" fill="hold" nodeType="clickEffect">
+                                  <p:stCondLst>
+                                    <p:cond delay="0"/>
+                                  </p:stCondLst>
+                                  <p:childTnLst>
+                                    <p:set>
+                                      <p:cBhvr>
+                                        <p:cTn id="30" dur="1" fill="hold">
+                                          <p:stCondLst>
+                                            <p:cond delay="0"/>
+                                          </p:stCondLst>
+                                        </p:cTn>
+                                        <p:tgtEl>
+                                          <p:spTgt spid="3"/>
+                                        </p:tgtEl>
+                                        <p:attrNameLst>
+                                          <p:attrName>style.visibility</p:attrName>
+                                        </p:attrNameLst>
+                                      </p:cBhvr>
+                                      <p:to>
+                                        <p:strVal val="visible"/>
+                                      </p:to>
+                                    </p:set>
+                                  </p:childTnLst>
+                                </p:cTn>
+                              </p:par>
+                              <p:par>
+                                <p:cTn id="31" presetID="1" presetClass="entr" presetSubtype="0" fill="hold" grpId="0" nodeType="withEffect">
+                                  <p:stCondLst>
+                                    <p:cond delay="0"/>
+                                  </p:stCondLst>
+                                  <p:childTnLst>
+                                    <p:set>
+                                      <p:cBhvr>
+                                        <p:cTn id="32" dur="1" fill="hold">
+                                          <p:stCondLst>
+                                            <p:cond delay="0"/>
+                                          </p:stCondLst>
+                                        </p:cTn>
+                                        <p:tgtEl>
+                                          <p:spTgt spid="4"/>
+                                        </p:tgtEl>
+                                        <p:attrNameLst>
+                                          <p:attrName>style.visibility</p:attrName>
+                                        </p:attrNameLst>
+                                      </p:cBhvr>
+                                      <p:to>
+                                        <p:strVal val="visible"/>
+                                      </p:to>
+                                    </p:set>
+                                  </p:childTnLst>
+                                </p:cTn>
+                              </p:par>
+                              <p:par>
+                                <p:cTn id="33" presetID="1" presetClass="entr" presetSubtype="0" fill="hold" grpId="0" nodeType="withEffect">
+                                  <p:stCondLst>
+                                    <p:cond delay="0"/>
+                                  </p:stCondLst>
+                                  <p:childTnLst>
+                                    <p:set>
+                                      <p:cBhvr>
+                                        <p:cTn id="34" dur="1" fill="hold">
+                                          <p:stCondLst>
+                                            <p:cond delay="0"/>
+                                          </p:stCondLst>
+                                        </p:cTn>
+                                        <p:tgtEl>
+                                          <p:spTgt spid="5"/>
+                                        </p:tgtEl>
+                                        <p:attrNameLst>
+                                          <p:attrName>style.visibility</p:attrName>
+                                        </p:attrNameLst>
+                                      </p:cBhvr>
+                                      <p:to>
+                                        <p:strVal val="visible"/>
+                                      </p:to>
+                                    </p:set>
+                                  </p:childTnLst>
+                                </p:cTn>
+                              </p:par>
+                            </p:childTnLst>
+                          </p:cTn>
+                        </p:par>
+                      </p:childTnLst>
+                    </p:cTn>
+                  </p:par>
+                  <p:par>
+                    <p:cTn id="35" fill="hold">
+                      <p:stCondLst>
+                        <p:cond delay="indefinite"/>
+                      </p:stCondLst>
+                      <p:childTnLst>
+                        <p:par>
+                          <p:cTn id="36" fill="hold">
+                            <p:stCondLst>
+                              <p:cond delay="0"/>
+                            </p:stCondLst>
+                            <p:childTnLst>
+                              <p:par>
+                                <p:cTn id="37" presetID="1" presetClass="entr" presetSubtype="0" fill="hold" grpId="0" nodeType="clickEffect">
+                                  <p:stCondLst>
+                                    <p:cond delay="0"/>
+                                  </p:stCondLst>
+                                  <p:childTnLst>
+                                    <p:set>
+                                      <p:cBhvr>
+                                        <p:cTn id="38" dur="1" fill="hold">
+                                          <p:stCondLst>
+                                            <p:cond delay="0"/>
+                                          </p:stCondLst>
+                                        </p:cTn>
+                                        <p:tgtEl>
+                                          <p:spTgt spid="6"/>
+                                        </p:tgtEl>
+                                        <p:attrNameLst>
+                                          <p:attrName>style.visibility</p:attrName>
+                                        </p:attrNameLst>
+                                      </p:cBhvr>
+                                      <p:to>
+                                        <p:strVal val="visible"/>
+                                      </p:to>
+                                    </p:set>
+                                  </p:childTnLst>
+                                </p:cTn>
+                              </p:par>
+                              <p:par>
+                                <p:cTn id="39" presetID="1" presetClass="entr" presetSubtype="0" fill="hold" grpId="0" nodeType="withEffect">
+                                  <p:stCondLst>
+                                    <p:cond delay="0"/>
+                                  </p:stCondLst>
+                                  <p:childTnLst>
+                                    <p:set>
+                                      <p:cBhvr>
+                                        <p:cTn id="40" dur="1" fill="hold">
+                                          <p:stCondLst>
+                                            <p:cond delay="0"/>
+                                          </p:stCondLst>
+                                        </p:cTn>
+                                        <p:tgtEl>
+                                          <p:spTgt spid="7"/>
+                                        </p:tgtEl>
+                                        <p:attrNameLst>
+                                          <p:attrName>style.visibility</p:attrName>
+                                        </p:attrNameLst>
+                                      </p:cBhvr>
+                                      <p:to>
+                                        <p:strVal val="visible"/>
+                                      </p:to>
+                                    </p:set>
+                                  </p:childTnLst>
+                                </p:cTn>
+                              </p:par>
+                              <p:par>
+                                <p:cTn id="41" presetID="1" presetClass="entr" presetSubtype="0" fill="hold" grpId="0" nodeType="withEffect">
+                                  <p:stCondLst>
+                                    <p:cond delay="0"/>
+                                  </p:stCondLst>
+                                  <p:childTnLst>
+                                    <p:set>
+                                      <p:cBhvr>
+                                        <p:cTn id="42" dur="1" fill="hold">
+                                          <p:stCondLst>
+                                            <p:cond delay="0"/>
+                                          </p:stCondLst>
+                                        </p:cTn>
+                                        <p:tgtEl>
+                                          <p:spTgt spid="8"/>
+                                        </p:tgtEl>
+                                        <p:attrNameLst>
+                                          <p:attrName>style.visibility</p:attrName>
+                                        </p:attrNameLst>
+                                      </p:cBhvr>
+                                      <p:to>
+                                        <p:strVal val="visible"/>
+                                      </p:to>
+                                    </p:set>
+                                  </p:childTnLst>
+                                </p:cTn>
+                              </p:par>
+                              <p:par>
+                                <p:cTn id="43" presetID="1" presetClass="entr" presetSubtype="0" fill="hold" grpId="0" nodeType="withEffect">
+                                  <p:stCondLst>
+                                    <p:cond delay="0"/>
+                                  </p:stCondLst>
+                                  <p:childTnLst>
+                                    <p:set>
+                                      <p:cBhvr>
+                                        <p:cTn id="44" dur="1" fill="hold">
+                                          <p:stCondLst>
+                                            <p:cond delay="0"/>
+                                          </p:stCondLst>
+                                        </p:cTn>
+                                        <p:tgtEl>
+                                          <p:spTgt spid="9"/>
+                                        </p:tgtEl>
+                                        <p:attrNameLst>
+                                          <p:attrName>style.visibility</p:attrName>
+                                        </p:attrNameLst>
+                                      </p:cBhvr>
+                                      <p:to>
+                                        <p:strVal val="visible"/>
+                                      </p:to>
+                                    </p:set>
+                                  </p:childTnLst>
+                                </p:cTn>
+                              </p:par>
+                              <p:par>
+                                <p:cTn id="45" presetID="1" presetClass="entr" presetSubtype="0" fill="hold" grpId="0" nodeType="withEffect">
+                                  <p:stCondLst>
+                                    <p:cond delay="0"/>
+                                  </p:stCondLst>
+                                  <p:childTnLst>
+                                    <p:set>
+                                      <p:cBhvr>
+                                        <p:cTn id="46" dur="1" fill="hold">
+                                          <p:stCondLst>
+                                            <p:cond delay="0"/>
+                                          </p:stCondLst>
+                                        </p:cTn>
+                                        <p:tgtEl>
+                                          <p:spTgt spid="10"/>
+                                        </p:tgtEl>
+                                        <p:attrNameLst>
+                                          <p:attrName>style.visibility</p:attrName>
+                                        </p:attrNameLst>
+                                      </p:cBhvr>
+                                      <p:to>
+                                        <p:strVal val="visible"/>
+                                      </p:to>
+                                    </p:set>
+                                  </p:childTnLst>
+                                </p:cTn>
+                              </p:par>
+                            </p:childTnLst>
+                          </p:cTn>
+                        </p:par>
+                      </p:childTnLst>
+                    </p:cTn>
+                  </p:par>
+                  <p:par>
+                    <p:cTn id="47" fill="hold">
+                      <p:stCondLst>
+                        <p:cond delay="indefinite"/>
+                      </p:stCondLst>
+                      <p:childTnLst>
+                        <p:par>
+                          <p:cTn id="48" fill="hold">
+                            <p:stCondLst>
+                              <p:cond delay="0"/>
+                            </p:stCondLst>
+                            <p:childTnLst>
+                              <p:par>
+                                <p:cTn id="49" presetID="1" presetClass="entr" presetSubtype="0" fill="hold" grpId="0" nodeType="clickEffect">
+                                  <p:stCondLst>
+                                    <p:cond delay="0"/>
+                                  </p:stCondLst>
+                                  <p:childTnLst>
+                                    <p:set>
+                                      <p:cBhvr>
+                                        <p:cTn id="50" dur="1" fill="hold">
+                                          <p:stCondLst>
+                                            <p:cond delay="0"/>
+                                          </p:stCondLst>
+                                        </p:cTn>
+                                        <p:tgtEl>
+                                          <p:spTgt spid="20"/>
+                                        </p:tgtEl>
+                                        <p:attrNameLst>
+                                          <p:attrName>style.visibility</p:attrName>
+                                        </p:attrNameLst>
+                                      </p:cBhvr>
+                                      <p:to>
+                                        <p:strVal val="visible"/>
+                                      </p:to>
+                                    </p:set>
+                                  </p:childTnLst>
+                                </p:cTn>
+                              </p:par>
+                              <p:par>
+                                <p:cTn id="51" presetID="1" presetClass="entr" presetSubtype="0" fill="hold" nodeType="withEffect">
+                                  <p:stCondLst>
+                                    <p:cond delay="0"/>
+                                  </p:stCondLst>
+                                  <p:childTnLst>
+                                    <p:set>
+                                      <p:cBhvr>
+                                        <p:cTn id="52" dur="1" fill="hold">
+                                          <p:stCondLst>
+                                            <p:cond delay="0"/>
+                                          </p:stCondLst>
+                                        </p:cTn>
+                                        <p:tgtEl>
+                                          <p:spTgt spid="15"/>
+                                        </p:tgtEl>
+                                        <p:attrNameLst>
+                                          <p:attrName>style.visibility</p:attrName>
+                                        </p:attrNameLst>
+                                      </p:cBhvr>
+                                      <p:to>
+                                        <p:strVal val="visible"/>
+                                      </p:to>
+                                    </p:set>
+                                  </p:childTnLst>
+                                </p:cTn>
+                              </p:par>
+                              <p:par>
+                                <p:cTn id="53" presetID="1" presetClass="entr" presetSubtype="0" fill="hold" nodeType="withEffect">
+                                  <p:stCondLst>
+                                    <p:cond delay="0"/>
+                                  </p:stCondLst>
+                                  <p:childTnLst>
+                                    <p:set>
+                                      <p:cBhvr>
+                                        <p:cTn id="54" dur="1" fill="hold">
+                                          <p:stCondLst>
+                                            <p:cond delay="0"/>
+                                          </p:stCondLst>
+                                        </p:cTn>
+                                        <p:tgtEl>
+                                          <p:spTgt spid="16"/>
+                                        </p:tgtEl>
+                                        <p:attrNameLst>
+                                          <p:attrName>style.visibility</p:attrName>
+                                        </p:attrNameLst>
+                                      </p:cBhvr>
+                                      <p:to>
+                                        <p:strVal val="visible"/>
+                                      </p:to>
+                                    </p:set>
+                                  </p:childTnLst>
+                                </p:cTn>
+                              </p:par>
+                              <p:par>
+                                <p:cTn id="55" presetID="1" presetClass="entr" presetSubtype="0" fill="hold" grpId="0" nodeType="withEffect">
+                                  <p:stCondLst>
+                                    <p:cond delay="0"/>
+                                  </p:stCondLst>
+                                  <p:childTnLst>
+                                    <p:set>
+                                      <p:cBhvr>
+                                        <p:cTn id="56" dur="1" fill="hold">
+                                          <p:stCondLst>
+                                            <p:cond delay="0"/>
+                                          </p:stCondLst>
+                                        </p:cTn>
+                                        <p:tgtEl>
+                                          <p:spTgt spid="21"/>
+                                        </p:tgtEl>
+                                        <p:attrNameLst>
+                                          <p:attrName>style.visibility</p:attrName>
+                                        </p:attrNameLst>
+                                      </p:cBhvr>
+                                      <p:to>
+                                        <p:strVal val="visible"/>
+                                      </p:to>
+                                    </p:set>
+                                  </p:childTnLst>
+                                </p:cTn>
+                              </p:par>
+                              <p:par>
+                                <p:cTn id="57" presetID="1" presetClass="entr" presetSubtype="0" fill="hold" grpId="0" nodeType="withEffect">
+                                  <p:stCondLst>
+                                    <p:cond delay="0"/>
+                                  </p:stCondLst>
+                                  <p:childTnLst>
+                                    <p:set>
+                                      <p:cBhvr>
+                                        <p:cTn id="58" dur="1" fill="hold">
+                                          <p:stCondLst>
+                                            <p:cond delay="0"/>
+                                          </p:stCondLst>
+                                        </p:cTn>
+                                        <p:tgtEl>
+                                          <p:spTgt spid="11"/>
+                                        </p:tgtEl>
+                                        <p:attrNameLst>
+                                          <p:attrName>style.visibility</p:attrName>
+                                        </p:attrNameLst>
+                                      </p:cBhvr>
+                                      <p:to>
+                                        <p:strVal val="visible"/>
+                                      </p:to>
+                                    </p:set>
+                                  </p:childTnLst>
+                                </p:cTn>
+                              </p:par>
+                            </p:childTnLst>
+                          </p:cTn>
+                        </p:par>
+                      </p:childTnLst>
+                    </p:cTn>
+                  </p:par>
+                  <p:par>
+                    <p:cTn id="59" fill="hold">
+                      <p:stCondLst>
+                        <p:cond delay="indefinite"/>
+                      </p:stCondLst>
+                      <p:childTnLst>
+                        <p:par>
+                          <p:cTn id="60" fill="hold">
+                            <p:stCondLst>
+                              <p:cond delay="0"/>
+                            </p:stCondLst>
+                            <p:childTnLst>
+                              <p:par>
+                                <p:cTn id="61" presetID="1" presetClass="entr" presetSubtype="0" fill="hold" nodeType="clickEffect">
+                                  <p:stCondLst>
+                                    <p:cond delay="0"/>
+                                  </p:stCondLst>
+                                  <p:childTnLst>
+                                    <p:set>
+                                      <p:cBhvr>
+                                        <p:cTn id="62" dur="1" fill="hold">
+                                          <p:stCondLst>
+                                            <p:cond delay="0"/>
+                                          </p:stCondLst>
+                                        </p:cTn>
+                                        <p:tgtEl>
+                                          <p:spTgt spid="17"/>
+                                        </p:tgtEl>
+                                        <p:attrNameLst>
+                                          <p:attrName>style.visibility</p:attrName>
+                                        </p:attrNameLst>
+                                      </p:cBhvr>
+                                      <p:to>
+                                        <p:strVal val="visible"/>
+                                      </p:to>
+                                    </p:set>
+                                  </p:childTnLst>
+                                </p:cTn>
+                              </p:par>
+                              <p:par>
+                                <p:cTn id="63" presetID="1" presetClass="entr" presetSubtype="0" fill="hold" nodeType="withEffect">
+                                  <p:stCondLst>
+                                    <p:cond delay="0"/>
+                                  </p:stCondLst>
+                                  <p:childTnLst>
+                                    <p:set>
+                                      <p:cBhvr>
+                                        <p:cTn id="64" dur="1" fill="hold">
+                                          <p:stCondLst>
+                                            <p:cond delay="0"/>
+                                          </p:stCondLst>
+                                        </p:cTn>
+                                        <p:tgtEl>
+                                          <p:spTgt spid="18"/>
+                                        </p:tgtEl>
+                                        <p:attrNameLst>
+                                          <p:attrName>style.visibility</p:attrName>
+                                        </p:attrNameLst>
+                                      </p:cBhvr>
+                                      <p:to>
+                                        <p:strVal val="visible"/>
+                                      </p:to>
+                                    </p:set>
+                                  </p:childTnLst>
+                                </p:cTn>
+                              </p:par>
+                              <p:par>
+                                <p:cTn id="65" presetID="1" presetClass="entr" presetSubtype="0" fill="hold" grpId="0" nodeType="withEffect">
+                                  <p:stCondLst>
+                                    <p:cond delay="0"/>
+                                  </p:stCondLst>
+                                  <p:childTnLst>
+                                    <p:set>
+                                      <p:cBhvr>
+                                        <p:cTn id="66" dur="1" fill="hold">
+                                          <p:stCondLst>
+                                            <p:cond delay="0"/>
+                                          </p:stCondLst>
+                                        </p:cTn>
+                                        <p:tgtEl>
+                                          <p:spTgt spid="13"/>
+                                        </p:tgtEl>
+                                        <p:attrNameLst>
+                                          <p:attrName>style.visibility</p:attrName>
+                                        </p:attrNameLst>
+                                      </p:cBhvr>
+                                      <p:to>
+                                        <p:strVal val="visible"/>
+                                      </p:to>
+                                    </p:set>
+                                  </p:childTnLst>
+                                </p:cTn>
+                              </p:par>
+                              <p:par>
+                                <p:cTn id="67" presetID="1" presetClass="entr" presetSubtype="0" fill="hold" grpId="0" nodeType="withEffect">
+                                  <p:stCondLst>
+                                    <p:cond delay="0"/>
+                                  </p:stCondLst>
+                                  <p:childTnLst>
+                                    <p:set>
+                                      <p:cBhvr>
+                                        <p:cTn id="68" dur="1" fill="hold">
+                                          <p:stCondLst>
+                                            <p:cond delay="0"/>
+                                          </p:stCondLst>
+                                        </p:cTn>
+                                        <p:tgtEl>
+                                          <p:spTgt spid="22"/>
+                                        </p:tgtEl>
+                                        <p:attrNameLst>
+                                          <p:attrName>style.visibility</p:attrName>
+                                        </p:attrNameLst>
+                                      </p:cBhvr>
+                                      <p:to>
+                                        <p:strVal val="visible"/>
+                                      </p:to>
+                                    </p:set>
+                                  </p:childTnLst>
+                                </p:cTn>
+                              </p:par>
+                              <p:par>
+                                <p:cTn id="69" presetID="1" presetClass="entr" presetSubtype="0" fill="hold" grpId="0" nodeType="withEffect">
+                                  <p:stCondLst>
+                                    <p:cond delay="0"/>
+                                  </p:stCondLst>
+                                  <p:childTnLst>
+                                    <p:set>
+                                      <p:cBhvr>
+                                        <p:cTn id="70" dur="1" fill="hold">
+                                          <p:stCondLst>
+                                            <p:cond delay="0"/>
+                                          </p:stCondLst>
+                                        </p:cTn>
+                                        <p:tgtEl>
+                                          <p:spTgt spid="12"/>
+                                        </p:tgtEl>
+                                        <p:attrNameLst>
+                                          <p:attrName>style.visibility</p:attrName>
+                                        </p:attrNameLst>
+                                      </p:cBhvr>
+                                      <p:to>
+                                        <p:strVal val="visible"/>
+                                      </p:to>
+                                    </p:set>
+                                  </p:childTnLst>
+                                </p:cTn>
+                              </p:par>
+                            </p:childTnLst>
+                          </p:cTn>
+                        </p:par>
+                      </p:childTnLst>
+                    </p:cTn>
+                  </p:par>
+                  <p:par>
+                    <p:cTn id="71" fill="hold">
+                      <p:stCondLst>
+                        <p:cond delay="indefinite"/>
+                      </p:stCondLst>
+                      <p:childTnLst>
+                        <p:par>
+                          <p:cTn id="72" fill="hold">
+                            <p:stCondLst>
+                              <p:cond delay="0"/>
+                            </p:stCondLst>
+                            <p:childTnLst>
+                              <p:par>
+                                <p:cTn id="73" presetID="1" presetClass="entr" presetSubtype="0" fill="hold" grpId="0" nodeType="clickEffect">
+                                  <p:stCondLst>
+                                    <p:cond delay="0"/>
+                                  </p:stCondLst>
+                                  <p:childTnLst>
+                                    <p:set>
+                                      <p:cBhvr>
+                                        <p:cTn id="74" dur="1" fill="hold">
+                                          <p:stCondLst>
+                                            <p:cond delay="0"/>
+                                          </p:stCondLst>
+                                        </p:cTn>
+                                        <p:tgtEl>
+                                          <p:spTgt spid="23"/>
+                                        </p:tgtEl>
+                                        <p:attrNameLst>
+                                          <p:attrName>style.visibility</p:attrName>
+                                        </p:attrNameLst>
+                                      </p:cBhvr>
+                                      <p:to>
+                                        <p:strVal val="visible"/>
+                                      </p:to>
+                                    </p:set>
+                                  </p:childTnLst>
+                                </p:cTn>
+                              </p:par>
+                              <p:par>
+                                <p:cTn id="75" presetID="1" presetClass="entr" presetSubtype="0" fill="hold" nodeType="withEffect">
+                                  <p:stCondLst>
+                                    <p:cond delay="0"/>
+                                  </p:stCondLst>
+                                  <p:childTnLst>
+                                    <p:set>
+                                      <p:cBhvr>
+                                        <p:cTn id="76" dur="1" fill="hold">
+                                          <p:stCondLst>
+                                            <p:cond delay="0"/>
+                                          </p:stCondLst>
+                                        </p:cTn>
+                                        <p:tgtEl>
+                                          <p:spTgt spid="19"/>
+                                        </p:tgtEl>
+                                        <p:attrNameLst>
+                                          <p:attrName>style.visibility</p:attrName>
+                                        </p:attrNameLst>
+                                      </p:cBhvr>
+                                      <p:to>
+                                        <p:strVal val="visible"/>
+                                      </p:to>
+                                    </p:set>
+                                  </p:childTnLst>
+                                </p:cTn>
+                              </p:par>
+                              <p:par>
+                                <p:cTn id="77" presetID="1" presetClass="entr" presetSubtype="0" fill="hold" grpId="0" nodeType="withEffect">
+                                  <p:stCondLst>
+                                    <p:cond delay="0"/>
+                                  </p:stCondLst>
+                                  <p:childTnLst>
+                                    <p:set>
+                                      <p:cBhvr>
+                                        <p:cTn id="78" dur="1" fill="hold">
+                                          <p:stCondLst>
+                                            <p:cond delay="0"/>
+                                          </p:stCondLst>
+                                        </p:cTn>
+                                        <p:tgtEl>
+                                          <p:spTgt spid="14"/>
+                                        </p:tgtEl>
+                                        <p:attrNameLst>
+                                          <p:attrName>style.visibility</p:attrName>
+                                        </p:attrNameLst>
+                                      </p:cBhvr>
+                                      <p:to>
+                                        <p:strVal val="visible"/>
+                                      </p:to>
+                                    </p:set>
+                                  </p:childTnLst>
+                                </p:cTn>
+                              </p:par>
+                            </p:childTnLst>
+                          </p:cTn>
+                        </p:par>
+                      </p:childTnLst>
+                    </p:cTn>
+                  </p:par>
+                  <p:par>
+                    <p:cTn id="79" fill="hold">
+                      <p:stCondLst>
+                        <p:cond delay="indefinite"/>
+                      </p:stCondLst>
+                      <p:childTnLst>
+                        <p:par>
+                          <p:cTn id="80" fill="hold">
+                            <p:stCondLst>
+                              <p:cond delay="0"/>
+                            </p:stCondLst>
+                            <p:childTnLst>
+                              <p:par>
+                                <p:cTn id="81" presetID="1" presetClass="entr" presetSubtype="0" fill="hold" grpId="0" nodeType="clickEffect">
+                                  <p:stCondLst>
+                                    <p:cond delay="0"/>
+                                  </p:stCondLst>
+                                  <p:childTnLst>
+                                    <p:set>
+                                      <p:cBhvr>
+                                        <p:cTn id="82" dur="1" fill="hold">
+                                          <p:stCondLst>
+                                            <p:cond delay="0"/>
+                                          </p:stCondLst>
+                                        </p:cTn>
+                                        <p:tgtEl>
+                                          <p:spTgt spid="33"/>
+                                        </p:tgtEl>
+                                        <p:attrNameLst>
+                                          <p:attrName>style.visibility</p:attrName>
+                                        </p:attrNameLst>
+                                      </p:cBhvr>
+                                      <p:to>
+                                        <p:strVal val="visible"/>
+                                      </p:to>
+                                    </p:set>
+                                  </p:childTnLst>
+                                </p:cTn>
+                              </p:par>
+                              <p:par>
+                                <p:cTn id="83" presetID="1" presetClass="entr" presetSubtype="0" fill="hold" grpId="0" nodeType="withEffect">
+                                  <p:stCondLst>
+                                    <p:cond delay="0"/>
+                                  </p:stCondLst>
+                                  <p:childTnLst>
+                                    <p:set>
+                                      <p:cBhvr>
+                                        <p:cTn id="84" dur="1" fill="hold">
+                                          <p:stCondLst>
+                                            <p:cond delay="0"/>
+                                          </p:stCondLst>
+                                        </p:cTn>
+                                        <p:tgtEl>
+                                          <p:spTgt spid="34"/>
+                                        </p:tgtEl>
+                                        <p:attrNameLst>
+                                          <p:attrName>style.visibility</p:attrName>
+                                        </p:attrNameLst>
+                                      </p:cBhvr>
+                                      <p:to>
+                                        <p:strVal val="visible"/>
+                                      </p:to>
+                                    </p:set>
+                                  </p:childTnLst>
+                                </p:cTn>
+                              </p:par>
+                            </p:childTnLst>
+                          </p:cTn>
+                        </p:par>
+                      </p:childTnLst>
+                    </p:cTn>
+                  </p:par>
+                  <p:par>
+                    <p:cTn id="85" fill="hold">
+                      <p:stCondLst>
+                        <p:cond delay="indefinite"/>
+                      </p:stCondLst>
+                      <p:childTnLst>
+                        <p:par>
+                          <p:cTn id="86" fill="hold">
+                            <p:stCondLst>
+                              <p:cond delay="0"/>
+                            </p:stCondLst>
+                            <p:childTnLst>
+                              <p:par>
+                                <p:cTn id="87" presetID="1" presetClass="entr" presetSubtype="0" fill="hold" grpId="0" nodeType="clickEffect">
+                                  <p:stCondLst>
+                                    <p:cond delay="0"/>
+                                  </p:stCondLst>
+                                  <p:childTnLst>
+                                    <p:set>
+                                      <p:cBhvr>
+                                        <p:cTn id="88" dur="1" fill="hold">
+                                          <p:stCondLst>
+                                            <p:cond delay="0"/>
+                                          </p:stCondLst>
+                                        </p:cTn>
+                                        <p:tgtEl>
+                                          <p:spTgt spid="35"/>
+                                        </p:tgtEl>
+                                        <p:attrNameLst>
+                                          <p:attrName>style.visibility</p:attrName>
+                                        </p:attrNameLst>
+                                      </p:cBhvr>
+                                      <p:to>
+                                        <p:strVal val="visible"/>
+                                      </p:to>
+                                    </p:set>
+                                  </p:childTnLst>
+                                </p:cTn>
+                              </p:par>
+                              <p:par>
+                                <p:cTn id="89" presetID="1" presetClass="entr" presetSubtype="0" fill="hold" grpId="0" nodeType="withEffect">
+                                  <p:stCondLst>
+                                    <p:cond delay="0"/>
+                                  </p:stCondLst>
+                                  <p:childTnLst>
+                                    <p:set>
+                                      <p:cBhvr>
+                                        <p:cTn id="90" dur="1" fill="hold">
+                                          <p:stCondLst>
+                                            <p:cond delay="0"/>
+                                          </p:stCondLst>
+                                        </p:cTn>
+                                        <p:tgtEl>
+                                          <p:spTgt spid="36"/>
+                                        </p:tgtEl>
+                                        <p:attrNameLst>
+                                          <p:attrName>style.visibility</p:attrName>
+                                        </p:attrNameLst>
+                                      </p:cBhvr>
+                                      <p:to>
+                                        <p:strVal val="visible"/>
+                                      </p:to>
+                                    </p:set>
+                                  </p:childTnLst>
+                                </p:cTn>
+                              </p:par>
+                              <p:par>
+                                <p:cTn id="91" presetID="1" presetClass="entr" presetSubtype="0" fill="hold" grpId="0" nodeType="withEffect">
+                                  <p:stCondLst>
+                                    <p:cond delay="0"/>
+                                  </p:stCondLst>
+                                  <p:childTnLst>
+                                    <p:set>
+                                      <p:cBhvr>
+                                        <p:cTn id="92" dur="1" fill="hold">
+                                          <p:stCondLst>
+                                            <p:cond delay="0"/>
+                                          </p:stCondLst>
+                                        </p:cTn>
+                                        <p:tgtEl>
+                                          <p:spTgt spid="37"/>
+                                        </p:tgtEl>
+                                        <p:attrNameLst>
+                                          <p:attrName>style.visibility</p:attrName>
+                                        </p:attrNameLst>
+                                      </p:cBhvr>
+                                      <p:to>
+                                        <p:strVal val="visible"/>
+                                      </p:to>
+                                    </p:set>
+                                  </p:childTnLst>
+                                </p:cTn>
+                              </p:par>
+                            </p:childTnLst>
+                          </p:cTn>
+                        </p:par>
+                      </p:childTnLst>
+                    </p:cTn>
+                  </p:par>
+                  <p:par>
+                    <p:cTn id="93" fill="hold">
+                      <p:stCondLst>
+                        <p:cond delay="indefinite"/>
+                      </p:stCondLst>
+                      <p:childTnLst>
+                        <p:par>
+                          <p:cTn id="94" fill="hold">
+                            <p:stCondLst>
+                              <p:cond delay="0"/>
+                            </p:stCondLst>
+                            <p:childTnLst>
+                              <p:par>
+                                <p:cTn id="95" presetID="1" presetClass="entr" presetSubtype="0" fill="hold" grpId="0" nodeType="clickEffect">
+                                  <p:stCondLst>
+                                    <p:cond delay="0"/>
+                                  </p:stCondLst>
+                                  <p:childTnLst>
+                                    <p:set>
+                                      <p:cBhvr>
+                                        <p:cTn id="96" dur="1" fill="hold">
+                                          <p:stCondLst>
+                                            <p:cond delay="0"/>
+                                          </p:stCondLst>
+                                        </p:cTn>
+                                        <p:tgtEl>
+                                          <p:spTgt spid="38"/>
+                                        </p:tgtEl>
+                                        <p:attrNameLst>
+                                          <p:attrName>style.visibility</p:attrName>
+                                        </p:attrNameLst>
+                                      </p:cBhvr>
+                                      <p:to>
+                                        <p:strVal val="visible"/>
+                                      </p:to>
+                                    </p:set>
+                                  </p:childTnLst>
+                                </p:cTn>
+                              </p:par>
+                              <p:par>
+                                <p:cTn id="97" presetID="1" presetClass="entr" presetSubtype="0" fill="hold" grpId="0" nodeType="withEffect">
+                                  <p:stCondLst>
+                                    <p:cond delay="0"/>
+                                  </p:stCondLst>
+                                  <p:childTnLst>
+                                    <p:set>
+                                      <p:cBhvr>
+                                        <p:cTn id="98" dur="1" fill="hold">
+                                          <p:stCondLst>
+                                            <p:cond delay="0"/>
+                                          </p:stCondLst>
+                                        </p:cTn>
+                                        <p:tgtEl>
+                                          <p:spTgt spid="39"/>
+                                        </p:tgtEl>
+                                        <p:attrNameLst>
+                                          <p:attrName>style.visibility</p:attrName>
+                                        </p:attrNameLst>
+                                      </p:cBhvr>
+                                      <p:to>
+                                        <p:strVal val="visible"/>
+                                      </p:to>
+                                    </p:set>
+                                  </p:childTnLst>
+                                </p:cTn>
+                              </p:par>
+                              <p:par>
+                                <p:cTn id="99" presetID="1" presetClass="entr" presetSubtype="0" fill="hold" grpId="0" nodeType="withEffect">
+                                  <p:stCondLst>
+                                    <p:cond delay="0"/>
+                                  </p:stCondLst>
+                                  <p:childTnLst>
+                                    <p:set>
+                                      <p:cBhvr>
+                                        <p:cTn id="100" dur="1" fill="hold">
+                                          <p:stCondLst>
+                                            <p:cond delay="0"/>
+                                          </p:stCondLst>
+                                        </p:cTn>
+                                        <p:tgtEl>
+                                          <p:spTgt spid="40"/>
+                                        </p:tgtEl>
+                                        <p:attrNameLst>
+                                          <p:attrName>style.visibility</p:attrName>
+                                        </p:attrNameLst>
+                                      </p:cBhvr>
+                                      <p:to>
+                                        <p:strVal val="visible"/>
+                                      </p:to>
+                                    </p:set>
+                                  </p:childTnLst>
+                                </p:cTn>
+                              </p:par>
+                            </p:childTnLst>
+                          </p:cTn>
+                        </p:par>
+                      </p:childTnLst>
+                    </p:cTn>
+                  </p:par>
+                </p:childTnLst>
+              </p:cTn>
+              <p:prevCondLst>
+                <p:cond evt="onPrev" delay="0">
+                  <p:tgtEl>
+                    <p:sldTgt/>
+                  </p:tgtEl>
+                </p:cond>
+              </p:prevCondLst>
+              <p:nextCondLst>
+                <p:cond evt="onNext" delay="0">
+                  <p:tgtEl>
+                    <p:sldTgt/>
+                  </p:tgtEl>
+                </p:cond>
+              </p:nextCondLst>
+            </p:seq>
+          </p:childTnLst>
+        </p:cTn>
+      </p:par>
+    </p:tnLst>
+    <p:bldLst>
+      <p:bldP spid="4" grpId="0"/>
+      <p:bldP spid="5" grpId="0"/>
+      <p:bldP spid="6" grpId="0"/>
+      <p:bldP spid="7" grpId="0" animBg="1"/>
+      <p:bldP spid="8" grpId="0"/>
+      <p:bldP spid="9" grpId="0" animBg="1"/>
+      <p:bldP spid="10" grpId="0" animBg="1"/>
+      <p:bldP spid="11" grpId="0" animBg="1"/>
+      <p:bldP spid="12" grpId="0" animBg="1"/>
+      <p:bldP spid="13" grpId="0" animBg="1"/>
+      <p:bldP spid="14" grpId="0" animBg="1"/>
+      <p:bldP spid="20" grpId="0"/>
+      <p:bldP spid="21" grpId="0"/>
+      <p:bldP spid="22" grpId="0"/>
+      <p:bldP spid="23" grpId="0"/>
+      <p:bldP spid="25" grpId="0" animBg="1"/>
+      <p:bldP spid="26" grpId="0"/>
+      <p:bldP spid="27" grpId="0"/>
+      <p:bldP spid="28" grpId="0"/>
+      <p:bldP spid="29" grpId="0"/>
+      <p:bldP spid="30" grpId="0"/>
+      <p:bldP spid="31" grpId="0"/>
+      <p:bldP spid="32" grpId="0"/>
+      <p:bldP spid="33" grpId="0"/>
+      <p:bldP spid="34" grpId="0"/>
+      <p:bldP spid="35" grpId="0"/>
+      <p:bldP spid="36" grpId="0"/>
+      <p:bldP spid="37" grpId="0"/>
+      <p:bldP spid="38" grpId="0"/>
+      <p:bldP spid="39" grpId="0"/>
+      <p:bldP spid="40" grpId="0"/>
+    </p:bldLst>
+  </p:timing>
 </p:sld>
 </file>
 
@@ -8038,50 +9316,677 @@
           </a:p>
         </p:txBody>
       </p:sp>
-      <p:sp>
-        <p:nvSpPr>
-          <p:cNvPr id="27" name="Text 19"/>
-          <p:cNvSpPr txBox="1"/>
-          <p:nvPr/>
-        </p:nvSpPr>
-        <p:spPr>
-          <a:xfrm>
-            <a:off x="8686800" y="384048"/>
-            <a:ext cx="3200400" cy="274320"/>
-          </a:xfrm>
-          <a:prstGeom prst="rect">
-            <a:avLst/>
-          </a:prstGeom>
-          <a:noFill/>
-          <a:ln/>
-        </p:spPr>
-        <p:txBody>
-          <a:bodyPr wrap="square" lIns="0" tIns="0" rIns="0" bIns="0" rtlCol="0" anchor="ctr"/>
-          <a:lstStyle/>
-          <a:p>
-            <a:pPr marL="0" indent="0" algn="r">
-              <a:buNone/>
-            </a:pPr>
-            <a:r>
-              <a:rPr lang="en-US" sz="900" dirty="0">
-                <a:solidFill>
-                  <a:srgbClr val="8C8FA0"/>
-                </a:solidFill>
-                <a:latin typeface="Aptos" pitchFamily="34" charset="0"/>
-                <a:ea typeface="Aptos" pitchFamily="34" charset="-122"/>
-                <a:cs typeface="Aptos" pitchFamily="34" charset="-120"/>
-              </a:rPr>
-              <a:t>Mock-up · sample data</a:t>
-            </a:r>
-            <a:endParaRPr lang="en-US" sz="900" dirty="0"/>
-          </a:p>
-        </p:txBody>
-      </p:sp>
     </p:spTree>
   </p:cSld>
   <p:clrMapOvr>
     <a:masterClrMapping/>
   </p:clrMapOvr>
+  <p:timing>
+    <p:tnLst>
+      <p:par>
+        <p:cTn id="1" dur="indefinite" restart="never" nodeType="tmRoot">
+          <p:childTnLst>
+            <p:seq concurrent="1" nextAc="seek">
+              <p:cTn id="2" dur="indefinite" nodeType="mainSeq">
+                <p:childTnLst>
+                  <p:par>
+                    <p:cTn id="3" fill="hold">
+                      <p:stCondLst>
+                        <p:cond delay="indefinite"/>
+                      </p:stCondLst>
+                      <p:childTnLst>
+                        <p:par>
+                          <p:cTn id="4" fill="hold">
+                            <p:stCondLst>
+                              <p:cond delay="0"/>
+                            </p:stCondLst>
+                            <p:childTnLst>
+                              <p:par>
+                                <p:cTn id="5" presetID="1" presetClass="entr" presetSubtype="0" fill="hold" grpId="0" nodeType="clickEffect">
+                                  <p:stCondLst>
+                                    <p:cond delay="0"/>
+                                  </p:stCondLst>
+                                  <p:childTnLst>
+                                    <p:set>
+                                      <p:cBhvr>
+                                        <p:cTn id="6" dur="1" fill="hold">
+                                          <p:stCondLst>
+                                            <p:cond delay="0"/>
+                                          </p:stCondLst>
+                                        </p:cTn>
+                                        <p:tgtEl>
+                                          <p:spTgt spid="7"/>
+                                        </p:tgtEl>
+                                        <p:attrNameLst>
+                                          <p:attrName>style.visibility</p:attrName>
+                                        </p:attrNameLst>
+                                      </p:cBhvr>
+                                      <p:to>
+                                        <p:strVal val="visible"/>
+                                      </p:to>
+                                    </p:set>
+                                  </p:childTnLst>
+                                </p:cTn>
+                              </p:par>
+                              <p:par>
+                                <p:cTn id="7" presetID="1" presetClass="entr" presetSubtype="0" fill="hold" grpId="0" nodeType="withEffect">
+                                  <p:stCondLst>
+                                    <p:cond delay="0"/>
+                                  </p:stCondLst>
+                                  <p:childTnLst>
+                                    <p:set>
+                                      <p:cBhvr>
+                                        <p:cTn id="8" dur="1" fill="hold">
+                                          <p:stCondLst>
+                                            <p:cond delay="0"/>
+                                          </p:stCondLst>
+                                        </p:cTn>
+                                        <p:tgtEl>
+                                          <p:spTgt spid="6"/>
+                                        </p:tgtEl>
+                                        <p:attrNameLst>
+                                          <p:attrName>style.visibility</p:attrName>
+                                        </p:attrNameLst>
+                                      </p:cBhvr>
+                                      <p:to>
+                                        <p:strVal val="visible"/>
+                                      </p:to>
+                                    </p:set>
+                                  </p:childTnLst>
+                                </p:cTn>
+                              </p:par>
+                              <p:par>
+                                <p:cTn id="9" presetID="1" presetClass="entr" presetSubtype="0" fill="hold" nodeType="withEffect">
+                                  <p:stCondLst>
+                                    <p:cond delay="0"/>
+                                  </p:stCondLst>
+                                  <p:childTnLst>
+                                    <p:set>
+                                      <p:cBhvr>
+                                        <p:cTn id="10" dur="1" fill="hold">
+                                          <p:stCondLst>
+                                            <p:cond delay="0"/>
+                                          </p:stCondLst>
+                                        </p:cTn>
+                                        <p:tgtEl>
+                                          <p:spTgt spid="14"/>
+                                        </p:tgtEl>
+                                        <p:attrNameLst>
+                                          <p:attrName>style.visibility</p:attrName>
+                                        </p:attrNameLst>
+                                      </p:cBhvr>
+                                      <p:to>
+                                        <p:strVal val="visible"/>
+                                      </p:to>
+                                    </p:set>
+                                  </p:childTnLst>
+                                </p:cTn>
+                              </p:par>
+                            </p:childTnLst>
+                          </p:cTn>
+                        </p:par>
+                      </p:childTnLst>
+                    </p:cTn>
+                  </p:par>
+                  <p:par>
+                    <p:cTn id="11" fill="hold">
+                      <p:stCondLst>
+                        <p:cond delay="indefinite"/>
+                      </p:stCondLst>
+                      <p:childTnLst>
+                        <p:par>
+                          <p:cTn id="12" fill="hold">
+                            <p:stCondLst>
+                              <p:cond delay="0"/>
+                            </p:stCondLst>
+                            <p:childTnLst>
+                              <p:par>
+                                <p:cTn id="13" presetID="1" presetClass="entr" presetSubtype="0" fill="hold" grpId="0" nodeType="clickEffect">
+                                  <p:stCondLst>
+                                    <p:cond delay="0"/>
+                                  </p:stCondLst>
+                                  <p:childTnLst>
+                                    <p:set>
+                                      <p:cBhvr>
+                                        <p:cTn id="14" dur="1" fill="hold">
+                                          <p:stCondLst>
+                                            <p:cond delay="0"/>
+                                          </p:stCondLst>
+                                        </p:cTn>
+                                        <p:tgtEl>
+                                          <p:spTgt spid="9"/>
+                                        </p:tgtEl>
+                                        <p:attrNameLst>
+                                          <p:attrName>style.visibility</p:attrName>
+                                        </p:attrNameLst>
+                                      </p:cBhvr>
+                                      <p:to>
+                                        <p:strVal val="visible"/>
+                                      </p:to>
+                                    </p:set>
+                                  </p:childTnLst>
+                                </p:cTn>
+                              </p:par>
+                              <p:par>
+                                <p:cTn id="15" presetID="1" presetClass="entr" presetSubtype="0" fill="hold" grpId="0" nodeType="withEffect">
+                                  <p:stCondLst>
+                                    <p:cond delay="0"/>
+                                  </p:stCondLst>
+                                  <p:childTnLst>
+                                    <p:set>
+                                      <p:cBhvr>
+                                        <p:cTn id="16" dur="1" fill="hold">
+                                          <p:stCondLst>
+                                            <p:cond delay="0"/>
+                                          </p:stCondLst>
+                                        </p:cTn>
+                                        <p:tgtEl>
+                                          <p:spTgt spid="10"/>
+                                        </p:tgtEl>
+                                        <p:attrNameLst>
+                                          <p:attrName>style.visibility</p:attrName>
+                                        </p:attrNameLst>
+                                      </p:cBhvr>
+                                      <p:to>
+                                        <p:strVal val="visible"/>
+                                      </p:to>
+                                    </p:set>
+                                  </p:childTnLst>
+                                </p:cTn>
+                              </p:par>
+                              <p:par>
+                                <p:cTn id="17" presetID="1" presetClass="entr" presetSubtype="0" fill="hold" nodeType="withEffect">
+                                  <p:stCondLst>
+                                    <p:cond delay="0"/>
+                                  </p:stCondLst>
+                                  <p:childTnLst>
+                                    <p:set>
+                                      <p:cBhvr>
+                                        <p:cTn id="18" dur="1" fill="hold">
+                                          <p:stCondLst>
+                                            <p:cond delay="0"/>
+                                          </p:stCondLst>
+                                        </p:cTn>
+                                        <p:tgtEl>
+                                          <p:spTgt spid="15"/>
+                                        </p:tgtEl>
+                                        <p:attrNameLst>
+                                          <p:attrName>style.visibility</p:attrName>
+                                        </p:attrNameLst>
+                                      </p:cBhvr>
+                                      <p:to>
+                                        <p:strVal val="visible"/>
+                                      </p:to>
+                                    </p:set>
+                                  </p:childTnLst>
+                                </p:cTn>
+                              </p:par>
+                            </p:childTnLst>
+                          </p:cTn>
+                        </p:par>
+                      </p:childTnLst>
+                    </p:cTn>
+                  </p:par>
+                  <p:par>
+                    <p:cTn id="19" fill="hold">
+                      <p:stCondLst>
+                        <p:cond delay="indefinite"/>
+                      </p:stCondLst>
+                      <p:childTnLst>
+                        <p:par>
+                          <p:cTn id="20" fill="hold">
+                            <p:stCondLst>
+                              <p:cond delay="0"/>
+                            </p:stCondLst>
+                            <p:childTnLst>
+                              <p:par>
+                                <p:cTn id="21" presetID="1" presetClass="entr" presetSubtype="0" fill="hold" grpId="0" nodeType="clickEffect">
+                                  <p:stCondLst>
+                                    <p:cond delay="0"/>
+                                  </p:stCondLst>
+                                  <p:childTnLst>
+                                    <p:set>
+                                      <p:cBhvr>
+                                        <p:cTn id="22" dur="1" fill="hold">
+                                          <p:stCondLst>
+                                            <p:cond delay="0"/>
+                                          </p:stCondLst>
+                                        </p:cTn>
+                                        <p:tgtEl>
+                                          <p:spTgt spid="12"/>
+                                        </p:tgtEl>
+                                        <p:attrNameLst>
+                                          <p:attrName>style.visibility</p:attrName>
+                                        </p:attrNameLst>
+                                      </p:cBhvr>
+                                      <p:to>
+                                        <p:strVal val="visible"/>
+                                      </p:to>
+                                    </p:set>
+                                  </p:childTnLst>
+                                </p:cTn>
+                              </p:par>
+                              <p:par>
+                                <p:cTn id="23" presetID="1" presetClass="entr" presetSubtype="0" fill="hold" grpId="0" nodeType="withEffect">
+                                  <p:stCondLst>
+                                    <p:cond delay="0"/>
+                                  </p:stCondLst>
+                                  <p:childTnLst>
+                                    <p:set>
+                                      <p:cBhvr>
+                                        <p:cTn id="24" dur="1" fill="hold">
+                                          <p:stCondLst>
+                                            <p:cond delay="0"/>
+                                          </p:stCondLst>
+                                        </p:cTn>
+                                        <p:tgtEl>
+                                          <p:spTgt spid="13"/>
+                                        </p:tgtEl>
+                                        <p:attrNameLst>
+                                          <p:attrName>style.visibility</p:attrName>
+                                        </p:attrNameLst>
+                                      </p:cBhvr>
+                                      <p:to>
+                                        <p:strVal val="visible"/>
+                                      </p:to>
+                                    </p:set>
+                                  </p:childTnLst>
+                                </p:cTn>
+                              </p:par>
+                              <p:par>
+                                <p:cTn id="25" presetID="1" presetClass="entr" presetSubtype="0" fill="hold" nodeType="withEffect">
+                                  <p:stCondLst>
+                                    <p:cond delay="0"/>
+                                  </p:stCondLst>
+                                  <p:childTnLst>
+                                    <p:set>
+                                      <p:cBhvr>
+                                        <p:cTn id="26" dur="1" fill="hold">
+                                          <p:stCondLst>
+                                            <p:cond delay="0"/>
+                                          </p:stCondLst>
+                                        </p:cTn>
+                                        <p:tgtEl>
+                                          <p:spTgt spid="16"/>
+                                        </p:tgtEl>
+                                        <p:attrNameLst>
+                                          <p:attrName>style.visibility</p:attrName>
+                                        </p:attrNameLst>
+                                      </p:cBhvr>
+                                      <p:to>
+                                        <p:strVal val="visible"/>
+                                      </p:to>
+                                    </p:set>
+                                  </p:childTnLst>
+                                </p:cTn>
+                              </p:par>
+                            </p:childTnLst>
+                          </p:cTn>
+                        </p:par>
+                      </p:childTnLst>
+                    </p:cTn>
+                  </p:par>
+                  <p:par>
+                    <p:cTn id="27" fill="hold">
+                      <p:stCondLst>
+                        <p:cond delay="indefinite"/>
+                      </p:stCondLst>
+                      <p:childTnLst>
+                        <p:par>
+                          <p:cTn id="28" fill="hold">
+                            <p:stCondLst>
+                              <p:cond delay="0"/>
+                            </p:stCondLst>
+                            <p:childTnLst>
+                              <p:par>
+                                <p:cTn id="29" presetID="1" presetClass="entr" presetSubtype="0" fill="hold" grpId="0" nodeType="clickEffect">
+                                  <p:stCondLst>
+                                    <p:cond delay="0"/>
+                                  </p:stCondLst>
+                                  <p:childTnLst>
+                                    <p:set>
+                                      <p:cBhvr>
+                                        <p:cTn id="30" dur="1" fill="hold">
+                                          <p:stCondLst>
+                                            <p:cond delay="0"/>
+                                          </p:stCondLst>
+                                        </p:cTn>
+                                        <p:tgtEl>
+                                          <p:spTgt spid="20"/>
+                                        </p:tgtEl>
+                                        <p:attrNameLst>
+                                          <p:attrName>style.visibility</p:attrName>
+                                        </p:attrNameLst>
+                                      </p:cBhvr>
+                                      <p:to>
+                                        <p:strVal val="visible"/>
+                                      </p:to>
+                                    </p:set>
+                                  </p:childTnLst>
+                                </p:cTn>
+                              </p:par>
+                              <p:par>
+                                <p:cTn id="31" presetID="1" presetClass="entr" presetSubtype="0" fill="hold" grpId="0" nodeType="withEffect">
+                                  <p:stCondLst>
+                                    <p:cond delay="0"/>
+                                  </p:stCondLst>
+                                  <p:childTnLst>
+                                    <p:set>
+                                      <p:cBhvr>
+                                        <p:cTn id="32" dur="1" fill="hold">
+                                          <p:stCondLst>
+                                            <p:cond delay="0"/>
+                                          </p:stCondLst>
+                                        </p:cTn>
+                                        <p:tgtEl>
+                                          <p:spTgt spid="17"/>
+                                        </p:tgtEl>
+                                        <p:attrNameLst>
+                                          <p:attrName>style.visibility</p:attrName>
+                                        </p:attrNameLst>
+                                      </p:cBhvr>
+                                      <p:to>
+                                        <p:strVal val="visible"/>
+                                      </p:to>
+                                    </p:set>
+                                  </p:childTnLst>
+                                </p:cTn>
+                              </p:par>
+                              <p:par>
+                                <p:cTn id="33" presetID="1" presetClass="entr" presetSubtype="0" fill="hold" grpId="0" nodeType="withEffect">
+                                  <p:stCondLst>
+                                    <p:cond delay="0"/>
+                                  </p:stCondLst>
+                                  <p:childTnLst>
+                                    <p:set>
+                                      <p:cBhvr>
+                                        <p:cTn id="34" dur="1" fill="hold">
+                                          <p:stCondLst>
+                                            <p:cond delay="0"/>
+                                          </p:stCondLst>
+                                        </p:cTn>
+                                        <p:tgtEl>
+                                          <p:spTgt spid="18"/>
+                                        </p:tgtEl>
+                                        <p:attrNameLst>
+                                          <p:attrName>style.visibility</p:attrName>
+                                        </p:attrNameLst>
+                                      </p:cBhvr>
+                                      <p:to>
+                                        <p:strVal val="visible"/>
+                                      </p:to>
+                                    </p:set>
+                                  </p:childTnLst>
+                                </p:cTn>
+                              </p:par>
+                              <p:par>
+                                <p:cTn id="35" presetID="1" presetClass="entr" presetSubtype="0" fill="hold" nodeType="withEffect">
+                                  <p:stCondLst>
+                                    <p:cond delay="0"/>
+                                  </p:stCondLst>
+                                  <p:childTnLst>
+                                    <p:set>
+                                      <p:cBhvr>
+                                        <p:cTn id="36" dur="1" fill="hold">
+                                          <p:stCondLst>
+                                            <p:cond delay="0"/>
+                                          </p:stCondLst>
+                                        </p:cTn>
+                                        <p:tgtEl>
+                                          <p:spTgt spid="19"/>
+                                        </p:tgtEl>
+                                        <p:attrNameLst>
+                                          <p:attrName>style.visibility</p:attrName>
+                                        </p:attrNameLst>
+                                      </p:cBhvr>
+                                      <p:to>
+                                        <p:strVal val="visible"/>
+                                      </p:to>
+                                    </p:set>
+                                  </p:childTnLst>
+                                </p:cTn>
+                              </p:par>
+                            </p:childTnLst>
+                          </p:cTn>
+                        </p:par>
+                      </p:childTnLst>
+                    </p:cTn>
+                  </p:par>
+                  <p:par>
+                    <p:cTn id="37" fill="hold">
+                      <p:stCondLst>
+                        <p:cond delay="indefinite"/>
+                      </p:stCondLst>
+                      <p:childTnLst>
+                        <p:par>
+                          <p:cTn id="38" fill="hold">
+                            <p:stCondLst>
+                              <p:cond delay="0"/>
+                            </p:stCondLst>
+                            <p:childTnLst>
+                              <p:par>
+                                <p:cTn id="39" presetID="1" presetClass="entr" presetSubtype="0" fill="hold" nodeType="clickEffect">
+                                  <p:stCondLst>
+                                    <p:cond delay="0"/>
+                                  </p:stCondLst>
+                                  <p:childTnLst>
+                                    <p:set>
+                                      <p:cBhvr>
+                                        <p:cTn id="40" dur="1" fill="hold">
+                                          <p:stCondLst>
+                                            <p:cond delay="0"/>
+                                          </p:stCondLst>
+                                        </p:cTn>
+                                        <p:tgtEl>
+                                          <p:spTgt spid="22"/>
+                                        </p:tgtEl>
+                                        <p:attrNameLst>
+                                          <p:attrName>style.visibility</p:attrName>
+                                        </p:attrNameLst>
+                                      </p:cBhvr>
+                                      <p:to>
+                                        <p:strVal val="visible"/>
+                                      </p:to>
+                                    </p:set>
+                                  </p:childTnLst>
+                                </p:cTn>
+                              </p:par>
+                              <p:par>
+                                <p:cTn id="41" presetID="1" presetClass="entr" presetSubtype="0" fill="hold" grpId="0" nodeType="withEffect">
+                                  <p:stCondLst>
+                                    <p:cond delay="0"/>
+                                  </p:stCondLst>
+                                  <p:childTnLst>
+                                    <p:set>
+                                      <p:cBhvr>
+                                        <p:cTn id="42" dur="1" fill="hold">
+                                          <p:stCondLst>
+                                            <p:cond delay="0"/>
+                                          </p:stCondLst>
+                                        </p:cTn>
+                                        <p:tgtEl>
+                                          <p:spTgt spid="21"/>
+                                        </p:tgtEl>
+                                        <p:attrNameLst>
+                                          <p:attrName>style.visibility</p:attrName>
+                                        </p:attrNameLst>
+                                      </p:cBhvr>
+                                      <p:to>
+                                        <p:strVal val="visible"/>
+                                      </p:to>
+                                    </p:set>
+                                  </p:childTnLst>
+                                </p:cTn>
+                              </p:par>
+                              <p:par>
+                                <p:cTn id="43" presetID="1" presetClass="entr" presetSubtype="0" fill="hold" grpId="0" nodeType="withEffect">
+                                  <p:stCondLst>
+                                    <p:cond delay="0"/>
+                                  </p:stCondLst>
+                                  <p:childTnLst>
+                                    <p:set>
+                                      <p:cBhvr>
+                                        <p:cTn id="44" dur="1" fill="hold">
+                                          <p:stCondLst>
+                                            <p:cond delay="0"/>
+                                          </p:stCondLst>
+                                        </p:cTn>
+                                        <p:tgtEl>
+                                          <p:spTgt spid="23"/>
+                                        </p:tgtEl>
+                                        <p:attrNameLst>
+                                          <p:attrName>style.visibility</p:attrName>
+                                        </p:attrNameLst>
+                                      </p:cBhvr>
+                                      <p:to>
+                                        <p:strVal val="visible"/>
+                                      </p:to>
+                                    </p:set>
+                                  </p:childTnLst>
+                                </p:cTn>
+                              </p:par>
+                            </p:childTnLst>
+                          </p:cTn>
+                        </p:par>
+                      </p:childTnLst>
+                    </p:cTn>
+                  </p:par>
+                  <p:par>
+                    <p:cTn id="45" fill="hold">
+                      <p:stCondLst>
+                        <p:cond delay="indefinite"/>
+                      </p:stCondLst>
+                      <p:childTnLst>
+                        <p:par>
+                          <p:cTn id="46" fill="hold">
+                            <p:stCondLst>
+                              <p:cond delay="0"/>
+                            </p:stCondLst>
+                            <p:childTnLst>
+                              <p:par>
+                                <p:cTn id="47" presetID="1" presetClass="entr" presetSubtype="0" fill="hold" nodeType="clickEffect">
+                                  <p:stCondLst>
+                                    <p:cond delay="0"/>
+                                  </p:stCondLst>
+                                  <p:childTnLst>
+                                    <p:set>
+                                      <p:cBhvr>
+                                        <p:cTn id="48" dur="1" fill="hold">
+                                          <p:stCondLst>
+                                            <p:cond delay="0"/>
+                                          </p:stCondLst>
+                                        </p:cTn>
+                                        <p:tgtEl>
+                                          <p:spTgt spid="25"/>
+                                        </p:tgtEl>
+                                        <p:attrNameLst>
+                                          <p:attrName>style.visibility</p:attrName>
+                                        </p:attrNameLst>
+                                      </p:cBhvr>
+                                      <p:to>
+                                        <p:strVal val="visible"/>
+                                      </p:to>
+                                    </p:set>
+                                  </p:childTnLst>
+                                </p:cTn>
+                              </p:par>
+                              <p:par>
+                                <p:cTn id="49" presetID="1" presetClass="entr" presetSubtype="0" fill="hold" grpId="0" nodeType="withEffect">
+                                  <p:stCondLst>
+                                    <p:cond delay="0"/>
+                                  </p:stCondLst>
+                                  <p:childTnLst>
+                                    <p:set>
+                                      <p:cBhvr>
+                                        <p:cTn id="50" dur="1" fill="hold">
+                                          <p:stCondLst>
+                                            <p:cond delay="0"/>
+                                          </p:stCondLst>
+                                        </p:cTn>
+                                        <p:tgtEl>
+                                          <p:spTgt spid="26"/>
+                                        </p:tgtEl>
+                                        <p:attrNameLst>
+                                          <p:attrName>style.visibility</p:attrName>
+                                        </p:attrNameLst>
+                                      </p:cBhvr>
+                                      <p:to>
+                                        <p:strVal val="visible"/>
+                                      </p:to>
+                                    </p:set>
+                                  </p:childTnLst>
+                                </p:cTn>
+                              </p:par>
+                              <p:par>
+                                <p:cTn id="51" presetID="1" presetClass="entr" presetSubtype="0" fill="hold" grpId="0" nodeType="withEffect">
+                                  <p:stCondLst>
+                                    <p:cond delay="0"/>
+                                  </p:stCondLst>
+                                  <p:childTnLst>
+                                    <p:set>
+                                      <p:cBhvr>
+                                        <p:cTn id="52" dur="1" fill="hold">
+                                          <p:stCondLst>
+                                            <p:cond delay="0"/>
+                                          </p:stCondLst>
+                                        </p:cTn>
+                                        <p:tgtEl>
+                                          <p:spTgt spid="24"/>
+                                        </p:tgtEl>
+                                        <p:attrNameLst>
+                                          <p:attrName>style.visibility</p:attrName>
+                                        </p:attrNameLst>
+                                      </p:cBhvr>
+                                      <p:to>
+                                        <p:strVal val="visible"/>
+                                      </p:to>
+                                    </p:set>
+                                  </p:childTnLst>
+                                </p:cTn>
+                              </p:par>
+                            </p:childTnLst>
+                          </p:cTn>
+                        </p:par>
+                      </p:childTnLst>
+                    </p:cTn>
+                  </p:par>
+                </p:childTnLst>
+              </p:cTn>
+              <p:prevCondLst>
+                <p:cond evt="onPrev" delay="0">
+                  <p:tgtEl>
+                    <p:sldTgt/>
+                  </p:tgtEl>
+                </p:cond>
+              </p:prevCondLst>
+              <p:nextCondLst>
+                <p:cond evt="onNext" delay="0">
+                  <p:tgtEl>
+                    <p:sldTgt/>
+                  </p:tgtEl>
+                </p:cond>
+              </p:nextCondLst>
+            </p:seq>
+          </p:childTnLst>
+        </p:cTn>
+      </p:par>
+    </p:tnLst>
+    <p:bldLst>
+      <p:bldP spid="6" grpId="0" animBg="1"/>
+      <p:bldP spid="7" grpId="0" animBg="1"/>
+      <p:bldP spid="9" grpId="0" animBg="1"/>
+      <p:bldP spid="10" grpId="0" animBg="1"/>
+      <p:bldP spid="12" grpId="0" animBg="1"/>
+      <p:bldP spid="13" grpId="0" animBg="1"/>
+      <p:bldP spid="17" grpId="0" animBg="1"/>
+      <p:bldP spid="18" grpId="0" animBg="1"/>
+      <p:bldP spid="20" grpId="0" animBg="1"/>
+      <p:bldP spid="21" grpId="0" animBg="1"/>
+      <p:bldP spid="23" grpId="0" animBg="1"/>
+      <p:bldP spid="24" grpId="0" animBg="1"/>
+      <p:bldP spid="26" grpId="0" animBg="1"/>
+    </p:bldLst>
+  </p:timing>
 </p:sld>
 </file>
 

</xml_diff>

<commit_message>
Align project documentation and presentation with the IoT design
</commit_message>
<xml_diff>
--- a/docs/presentation/TempSafe_Elevator_Pitch.pptx
+++ b/docs/presentation/TempSafe_Elevator_Pitch.pptx
@@ -721,7 +721,7 @@
           <a:lstStyle/>
           <a:p>
             <a:r>
-              <a:t>Planned student prototype, demonstrated on a bench with no medicines. One physical box, with multiple users assigned to the same box ID. The existing SCD-41 provides the temperature measurement for this release. Its humidity and CO2 capabilities are outside the application scope. The photographed white dome module is not the temperature sensor used for this project. The physical LED is single-colour and lights for Warning or Alert, with distinct blinking for sensor failure. Application colours are separate. Phone notifications are Must Have and require connectivity, permission and a delivery channel to be selected and tested. Buzzer is Should Have. During an outage the Pi stores sample attempts locally and uploads them with original times after reconnection. Shannon follows her service procedures; the prototype makes no clinical decisions. Hardware: Raspberry Pi 400 powered from mains and connected over Wi-Fi. A separate computer accesses it using https://connect.raspberrypi.com/devices for remote desktop or shell access. This development access is separate from the TempSafe application and device API data flow. The simple plastic or wooden box is still to be selected; the image illustrates a plastic option. Source: https://www.raspberrypi.com/documentation/services/connect.html and https://www.adafruit.com/product/5190. Image: generated using OpenAI image generation on 8 October 2026 as a concept illustration, not a photo of completed hardware. Sources: project functional requirements, hardware parts list and initial test plan in this repository.</a:t>
+              <a:t>Planned student prototype, demonstrated on a bench with no medicines. One physical box, with multiple users assigned to the same box ID. The existing SCD-41 provides the temperature measurement for this release. Its humidity and CO2 capabilities are outside the application scope. The photographed white dome module is not the temperature sensor used for this project. The physical LED is single-colour and lights for Warning or Alert, with distinct blinking for sensor failure. Application colours are separate. Phone notifications are Must Have and require connectivity, permission and a delivery channel to be selected and tested. Buzzer is Should Have. During an outage the Pi stores sample attempts locally and uploads them with original times after reconnection. Shannon follows her service procedures; the prototype makes no clinical decisions. Hardware: Raspberry Pi 400 powered from mains and connected over Wi-Fi. A separate computer accesses it using https://connect.raspberrypi.com/devices for remote desktop or shell access. This development access is separate from the TempSafe application and device data flow. The simple plastic or wooden box is still to be selected; the image illustrates a plastic option. Source: https://www.raspberrypi.com/documentation/services/connect.html and https://www.adafruit.com/product/5190. Image: generated using OpenAI image generation on 8 October 2026 as a concept illustration, not a photo of completed hardware. Device observations are published to a cloud MQTT broker over TLS. The ingestion worker stores them in MySQL and acknowledges committed sample IDs; the browser accesses FastAPI over HTTPS. This pub-sub design follows the IoT G-CA1 brief. Sources: project functional requirements, hardware parts list and initial test plan in this repository.</a:t>
             </a:r>
           </a:p>
         </p:txBody>
@@ -800,10 +800,10 @@
             <a:r>
               <a:rPr lang="en-US" dirty="0"/>
               <a:t>(~45 seconds)
-This is how Shannon actually sees TempSafe.
-One: she is with a patient. At 14:04 she gets a quiet warning at 24 degrees. At 14:05 the box goes above 25: the red LED and buzzer come on, and she gets one urgent alert. Only two notifications, nothing else.
-Two: when she has a free second, one glance at the app tells her everything: EXCURSION, and a big timer — 12 minutes above the limit, maximum 27.4 degrees. The status is never just colour: there is always an icon, a word and the temperature.
-Three: after the call she opens the web dashboard. She sees the temperature over time and the full record our database tracked: start 14:05, end 14:23, 18 minutes, maximum 27.4 degrees. With this she can follow her service's policy and decide if the medicine is still safe. TempSafe gives her the facts; Shannon makes the decision.</a:t>
+This is the proposed interface journey using synthetic demonstration data. The application is not yet implemented.
+One: she is with a patient. At 14:04 she gets a quiet warning at 24 degrees. At 14:05 the box goes above 25: the single-colour LED remains lit and the optional buzzer sounds if implemented, and she gets one urgent alert. Repeated unchanged states are suppressed; delivery requires connectivity, permission and supported Web Push.
+Two: when she has a free second, one glance at the app tells her everything: Alert, freshness and the latest temperature; an optional estimated excursion summary can show 12 minutes and a maximum of 27.4 degrees. The status is never just colour: there is always an icon, a word and the temperature.
+Three: after the call she opens the web dashboard. She sees the temperature over time and the recorded observations, including gaps and errors. If implemented, the estimated summary can show a period from 14:05 to 14:23 and a maximum of 27.4 degrees; it does not prove continuous exposure. With this she can follow her service's policy and seek the appropriate review of the medicine. TempSafe gives her the facts; Shannon makes the decision.</a:t>
             </a:r>
           </a:p>
         </p:txBody>
@@ -3397,7 +3397,7 @@
                   <a:ea typeface="Aptos" pitchFamily="34" charset="-122"/>
                   <a:cs typeface="Aptos" pitchFamily="34" charset="-120"/>
                 </a:rPr>
-                <a:t>Tracks temperature inside the Controlled Drug Box in real time</a:t>
+                <a:t>Samples box temperature every 30 seconds</a:t>
               </a:r>
               <a:r>
                 <a:rPr lang="en-US" sz="1260" dirty="0">
@@ -3643,7 +3643,7 @@
                   <a:ea typeface="Aptos" pitchFamily="34" charset="-122"/>
                   <a:cs typeface="Aptos" pitchFamily="34" charset="-120"/>
                 </a:rPr>
-                <a:t>Records how long temperature remains above the safe limit.</a:t>
+                <a:t>Logs out-of-range readings; estimated duration is optional.</a:t>
               </a:r>
               <a:endParaRPr lang="en-US" sz="1600" dirty="0"/>
             </a:p>
@@ -3862,7 +3862,7 @@
                   <a:ea typeface="Aptos" pitchFamily="34" charset="-122"/>
                   <a:cs typeface="Aptos" pitchFamily="34" charset="-120"/>
                 </a:rPr>
-                <a:t>Uses LED visual feedback, a buzzer, and phone notifications.</a:t>
+                <a:t>Uses a single-colour LED and online phone alerts; buzzer optional.</a:t>
               </a:r>
               <a:endParaRPr lang="en-US" sz="1600" dirty="0"/>
             </a:p>
@@ -6793,7 +6793,7 @@
                 <a:ea typeface="Arial"/>
                 <a:cs typeface="Arial"/>
               </a:rPr>
-              <a:t>HTTPS API</a:t>
+              <a:t>MQTT over TLS</a:t>
             </a:r>
           </a:p>
         </p:txBody>
@@ -6859,7 +6859,7 @@
                 <a:ea typeface="Arial"/>
                 <a:cs typeface="Arial"/>
               </a:rPr>
-              <a:t>FastAPI + MySQL</a:t>
+              <a:t>Broker → backend + MySQL</a:t>
             </a:r>
           </a:p>
         </p:txBody>
@@ -8487,7 +8487,7 @@
                 <a:ea typeface="Aptos" pitchFamily="34" charset="-122"/>
                 <a:cs typeface="Aptos" pitchFamily="34" charset="-120"/>
               </a:rPr>
-              <a:t>From the alert to the decision — what she sees, when she needs it</a:t>
+              <a:t>Early UI concepts: optional summaries; red LED wording superseded</a:t>
             </a:r>
             <a:endParaRPr lang="en-US" sz="1800" dirty="0"/>
           </a:p>
@@ -8741,7 +8741,7 @@
                 <a:ea typeface="Aptos" pitchFamily="34" charset="-122"/>
                 <a:cs typeface="Aptos" pitchFamily="34" charset="-120"/>
               </a:rPr>
-              <a:t>Status + exposure timer</a:t>
+              <a:t>Status + optional estimate</a:t>
             </a:r>
             <a:endParaRPr lang="en-US" sz="1000" dirty="0"/>
           </a:p>
@@ -9181,7 +9181,7 @@
                 <a:ea typeface="Aptos" pitchFamily="34" charset="-122"/>
                 <a:cs typeface="Aptos" pitchFamily="34" charset="-120"/>
               </a:rPr>
-              <a:t>Only 2 alerts</a:t>
+              <a:t>State-change alerts</a:t>
             </a:r>
             <a:endParaRPr lang="en-US" sz="1250" dirty="0"/>
           </a:p>
@@ -9293,7 +9293,7 @@
                 <a:ea typeface="Aptos" pitchFamily="34" charset="-122"/>
                 <a:cs typeface="Aptos" pitchFamily="34" charset="-120"/>
               </a:rPr>
-              <a:t>Nothing lost</a:t>
+              <a:t>Recorded observations</a:t>
             </a:r>
             <a:endParaRPr lang="en-US" sz="1250" dirty="0"/>
           </a:p>
@@ -9310,7 +9310,7 @@
                 <a:ea typeface="Aptos" pitchFamily="34" charset="-122"/>
                 <a:cs typeface="Aptos" pitchFamily="34" charset="-120"/>
               </a:rPr>
-              <a:t>start · end · max</a:t>
+              <a:t>gaps shown · estimates optional</a:t>
             </a:r>
             <a:endParaRPr lang="en-US" sz="1250" dirty="0"/>
           </a:p>

</xml_diff>

<commit_message>
Update title slide with photos
Improved the overall appearance of the slide
</commit_message>
<xml_diff>
--- a/docs/presentation/TempSafe_Elevator_Pitch.pptx
+++ b/docs/presentation/TempSafe_Elevator_Pitch.pptx
@@ -3,15 +3,16 @@
 <p:presentation xmlns:a="http://schemas.openxmlformats.org/drawingml/2006/main" xmlns:r="http://schemas.openxmlformats.org/officeDocument/2006/relationships" xmlns:p="http://schemas.openxmlformats.org/presentationml/2006/main" saveSubsetFonts="1" autoCompressPictures="0">
   <p:sldMasterIdLst>
     <p:sldMasterId id="2147483648" r:id="rId1"/>
+    <p:sldMasterId id="2147483651" r:id="rId2"/>
   </p:sldMasterIdLst>
   <p:notesMasterIdLst>
-    <p:notesMasterId r:id="rId6"/>
+    <p:notesMasterId r:id="rId7"/>
   </p:notesMasterIdLst>
   <p:sldIdLst>
-    <p:sldId id="258" r:id="rId2"/>
-    <p:sldId id="256" r:id="rId3"/>
-    <p:sldId id="257" r:id="rId4"/>
-    <p:sldId id="259" r:id="rId5"/>
+    <p:sldId id="260" r:id="rId3"/>
+    <p:sldId id="256" r:id="rId4"/>
+    <p:sldId id="257" r:id="rId5"/>
+    <p:sldId id="259" r:id="rId6"/>
   </p:sldIdLst>
   <p:sldSz cx="12192000" cy="6858000"/>
   <p:notesSz cx="6858000" cy="12192000"/>
@@ -571,11 +572,71 @@
           <a:bodyPr/>
           <a:lstStyle/>
           <a:p>
+            <a:pPr marL="0" marR="0" lvl="0" indent="0" algn="l" defTabSz="914400" rtl="0" eaLnBrk="1" fontAlgn="auto" latinLnBrk="0" hangingPunct="1">
+              <a:lnSpc>
+                <a:spcPct val="100000"/>
+              </a:lnSpc>
+              <a:spcBef>
+                <a:spcPts val="0"/>
+              </a:spcBef>
+              <a:spcAft>
+                <a:spcPts val="0"/>
+              </a:spcAft>
+              <a:buClrTx/>
+              <a:buSzTx/>
+              <a:buFontTx/>
+              <a:buNone/>
+              <a:tabLst/>
+              <a:defRPr/>
+            </a:pPr>
             <a:fld id="{F7021451-1387-4CA6-816F-3879F97B5CBC}" type="slidenum">
-              <a:rPr lang="en-US"/>
+              <a:rPr kumimoji="0" lang="en-US" sz="1800" b="0" i="0" u="none" strike="noStrike" kern="1200" cap="none" spc="0" normalizeH="0" baseline="0" noProof="0">
+                <a:ln>
+                  <a:noFill/>
+                </a:ln>
+                <a:solidFill>
+                  <a:prstClr val="black"/>
+                </a:solidFill>
+                <a:effectLst/>
+                <a:uLnTx/>
+                <a:uFillTx/>
+                <a:latin typeface="Aptos" panose="02110004020202020204"/>
+                <a:ea typeface="+mn-ea"/>
+                <a:cs typeface="+mn-cs"/>
+              </a:rPr>
+              <a:pPr marL="0" marR="0" lvl="0" indent="0" algn="l" defTabSz="914400" rtl="0" eaLnBrk="1" fontAlgn="auto" latinLnBrk="0" hangingPunct="1">
+                <a:lnSpc>
+                  <a:spcPct val="100000"/>
+                </a:lnSpc>
+                <a:spcBef>
+                  <a:spcPts val="0"/>
+                </a:spcBef>
+                <a:spcAft>
+                  <a:spcPts val="0"/>
+                </a:spcAft>
+                <a:buClrTx/>
+                <a:buSzTx/>
+                <a:buFontTx/>
+                <a:buNone/>
+                <a:tabLst/>
+                <a:defRPr/>
+              </a:pPr>
               <a:t>1</a:t>
             </a:fld>
-            <a:endParaRPr lang="en-US"/>
+            <a:endParaRPr kumimoji="0" lang="en-US" sz="1800" b="0" i="0" u="none" strike="noStrike" kern="1200" cap="none" spc="0" normalizeH="0" baseline="0" noProof="0">
+              <a:ln>
+                <a:noFill/>
+              </a:ln>
+              <a:solidFill>
+                <a:prstClr val="black"/>
+              </a:solidFill>
+              <a:effectLst/>
+              <a:uLnTx/>
+              <a:uFillTx/>
+              <a:latin typeface="Aptos" panose="02110004020202020204"/>
+              <a:ea typeface="+mn-ea"/>
+              <a:cs typeface="+mn-cs"/>
+            </a:endParaRPr>
           </a:p>
         </p:txBody>
       </p:sp>
@@ -904,6 +965,41 @@
 </p:sldLayout>
 </file>
 
+<file path=ppt/slideLayouts/slideLayout3.xml><?xml version="1.0" encoding="utf-8"?>
+<p:sldLayout xmlns:a="http://schemas.openxmlformats.org/drawingml/2006/main" xmlns:r="http://schemas.openxmlformats.org/officeDocument/2006/relationships" xmlns:p="http://schemas.openxmlformats.org/presentationml/2006/main" preserve="1">
+  <p:cSld name="DEFAULT">
+    <p:bg>
+      <p:bgRef idx="1001">
+        <a:schemeClr val="bg1"/>
+      </p:bgRef>
+    </p:bg>
+    <p:spTree>
+      <p:nvGrpSpPr>
+        <p:cNvPr id="1" name=""/>
+        <p:cNvGrpSpPr/>
+        <p:nvPr/>
+      </p:nvGrpSpPr>
+      <p:grpSpPr>
+        <a:xfrm>
+          <a:off x="0" y="0"/>
+          <a:ext cx="0" cy="0"/>
+          <a:chOff x="0" y="0"/>
+          <a:chExt cx="0" cy="0"/>
+        </a:xfrm>
+      </p:grpSpPr>
+    </p:spTree>
+    <p:extLst>
+      <p:ext uri="{BB962C8B-B14F-4D97-AF65-F5344CB8AC3E}">
+        <p14:creationId xmlns:p14="http://schemas.microsoft.com/office/powerpoint/2010/main" val="2147589254"/>
+      </p:ext>
+    </p:extLst>
+  </p:cSld>
+  <p:clrMapOvr>
+    <a:masterClrMapping/>
+  </p:clrMapOvr>
+</p:sldLayout>
+</file>
+
 <file path=ppt/slideMasters/slideMaster1.xml><?xml version="1.0" encoding="utf-8"?>
 <p:sldMaster xmlns:a="http://schemas.openxmlformats.org/drawingml/2006/main" xmlns:r="http://schemas.openxmlformats.org/officeDocument/2006/relationships" xmlns:p="http://schemas.openxmlformats.org/presentationml/2006/main">
   <p:cSld>
@@ -1187,9 +1283,304 @@
 </p:sldMaster>
 </file>
 
+<file path=ppt/slideMasters/slideMaster2.xml><?xml version="1.0" encoding="utf-8"?>
+<p:sldMaster xmlns:a="http://schemas.openxmlformats.org/drawingml/2006/main" xmlns:r="http://schemas.openxmlformats.org/officeDocument/2006/relationships" xmlns:p="http://schemas.openxmlformats.org/presentationml/2006/main">
+  <p:cSld>
+    <p:bg>
+      <p:bgRef idx="1001">
+        <a:schemeClr val="bg1"/>
+      </p:bgRef>
+    </p:bg>
+    <p:spTree>
+      <p:nvGrpSpPr>
+        <p:cNvPr id="1" name=""/>
+        <p:cNvGrpSpPr/>
+        <p:nvPr/>
+      </p:nvGrpSpPr>
+      <p:grpSpPr>
+        <a:xfrm>
+          <a:off x="0" y="0"/>
+          <a:ext cx="0" cy="0"/>
+          <a:chOff x="0" y="0"/>
+          <a:chExt cx="0" cy="0"/>
+        </a:xfrm>
+      </p:grpSpPr>
+    </p:spTree>
+    <p:extLst>
+      <p:ext uri="{BB962C8B-B14F-4D97-AF65-F5344CB8AC3E}">
+        <p14:creationId xmlns:p14="http://schemas.microsoft.com/office/powerpoint/2010/main" val="1262425243"/>
+      </p:ext>
+    </p:extLst>
+  </p:cSld>
+  <p:clrMap bg1="lt1" tx1="dk1" bg2="lt2" tx2="dk2" accent1="accent1" accent2="accent2" accent3="accent3" accent4="accent4" accent5="accent5" accent6="accent6" hlink="hlink" folHlink="folHlink"/>
+  <p:sldLayoutIdLst>
+    <p:sldLayoutId id="2147483652" r:id="rId1"/>
+  </p:sldLayoutIdLst>
+  <p:hf sldNum="0" hdr="0" ftr="0" dt="0"/>
+  <p:txStyles>
+    <p:titleStyle>
+      <a:lvl1pPr algn="ctr" defTabSz="914400" rtl="0" eaLnBrk="1" latinLnBrk="0" hangingPunct="1">
+        <a:spcBef>
+          <a:spcPct val="0"/>
+        </a:spcBef>
+        <a:buNone/>
+        <a:defRPr sz="4400" kern="1200">
+          <a:solidFill>
+            <a:schemeClr val="tx1"/>
+          </a:solidFill>
+          <a:latin typeface="+mj-lt"/>
+          <a:ea typeface="+mj-ea"/>
+          <a:cs typeface="+mj-cs"/>
+        </a:defRPr>
+      </a:lvl1pPr>
+    </p:titleStyle>
+    <p:bodyStyle>
+      <a:lvl1pPr marL="342900" indent="-342900" algn="l" defTabSz="914400" rtl="0" eaLnBrk="1" latinLnBrk="0" hangingPunct="1">
+        <a:spcBef>
+          <a:spcPct val="20000"/>
+        </a:spcBef>
+        <a:buFont typeface="Arial" pitchFamily="34" charset="0"/>
+        <a:buChar char="•"/>
+        <a:defRPr sz="3200" kern="1200">
+          <a:solidFill>
+            <a:schemeClr val="tx1"/>
+          </a:solidFill>
+          <a:latin typeface="+mn-lt"/>
+          <a:ea typeface="+mn-ea"/>
+          <a:cs typeface="+mn-cs"/>
+        </a:defRPr>
+      </a:lvl1pPr>
+      <a:lvl2pPr marL="742950" indent="-285750" algn="l" defTabSz="914400" rtl="0" eaLnBrk="1" latinLnBrk="0" hangingPunct="1">
+        <a:spcBef>
+          <a:spcPct val="20000"/>
+        </a:spcBef>
+        <a:buFont typeface="Arial" pitchFamily="34" charset="0"/>
+        <a:buChar char="–"/>
+        <a:defRPr sz="2800" kern="1200">
+          <a:solidFill>
+            <a:schemeClr val="tx1"/>
+          </a:solidFill>
+          <a:latin typeface="+mn-lt"/>
+          <a:ea typeface="+mn-ea"/>
+          <a:cs typeface="+mn-cs"/>
+        </a:defRPr>
+      </a:lvl2pPr>
+      <a:lvl3pPr marL="1143000" indent="-228600" algn="l" defTabSz="914400" rtl="0" eaLnBrk="1" latinLnBrk="0" hangingPunct="1">
+        <a:spcBef>
+          <a:spcPct val="20000"/>
+        </a:spcBef>
+        <a:buFont typeface="Arial" pitchFamily="34" charset="0"/>
+        <a:buChar char="•"/>
+        <a:defRPr sz="2400" kern="1200">
+          <a:solidFill>
+            <a:schemeClr val="tx1"/>
+          </a:solidFill>
+          <a:latin typeface="+mn-lt"/>
+          <a:ea typeface="+mn-ea"/>
+          <a:cs typeface="+mn-cs"/>
+        </a:defRPr>
+      </a:lvl3pPr>
+      <a:lvl4pPr marL="1600200" indent="-228600" algn="l" defTabSz="914400" rtl="0" eaLnBrk="1" latinLnBrk="0" hangingPunct="1">
+        <a:spcBef>
+          <a:spcPct val="20000"/>
+        </a:spcBef>
+        <a:buFont typeface="Arial" pitchFamily="34" charset="0"/>
+        <a:buChar char="–"/>
+        <a:defRPr sz="2000" kern="1200">
+          <a:solidFill>
+            <a:schemeClr val="tx1"/>
+          </a:solidFill>
+          <a:latin typeface="+mn-lt"/>
+          <a:ea typeface="+mn-ea"/>
+          <a:cs typeface="+mn-cs"/>
+        </a:defRPr>
+      </a:lvl4pPr>
+      <a:lvl5pPr marL="2057400" indent="-228600" algn="l" defTabSz="914400" rtl="0" eaLnBrk="1" latinLnBrk="0" hangingPunct="1">
+        <a:spcBef>
+          <a:spcPct val="20000"/>
+        </a:spcBef>
+        <a:buFont typeface="Arial" pitchFamily="34" charset="0"/>
+        <a:buChar char="»"/>
+        <a:defRPr sz="2000" kern="1200">
+          <a:solidFill>
+            <a:schemeClr val="tx1"/>
+          </a:solidFill>
+          <a:latin typeface="+mn-lt"/>
+          <a:ea typeface="+mn-ea"/>
+          <a:cs typeface="+mn-cs"/>
+        </a:defRPr>
+      </a:lvl5pPr>
+      <a:lvl6pPr marL="2514600" indent="-228600" algn="l" defTabSz="914400" rtl="0" eaLnBrk="1" latinLnBrk="0" hangingPunct="1">
+        <a:spcBef>
+          <a:spcPct val="20000"/>
+        </a:spcBef>
+        <a:buFont typeface="Arial" pitchFamily="34" charset="0"/>
+        <a:buChar char="•"/>
+        <a:defRPr sz="2000" kern="1200">
+          <a:solidFill>
+            <a:schemeClr val="tx1"/>
+          </a:solidFill>
+          <a:latin typeface="+mn-lt"/>
+          <a:ea typeface="+mn-ea"/>
+          <a:cs typeface="+mn-cs"/>
+        </a:defRPr>
+      </a:lvl6pPr>
+      <a:lvl7pPr marL="2971800" indent="-228600" algn="l" defTabSz="914400" rtl="0" eaLnBrk="1" latinLnBrk="0" hangingPunct="1">
+        <a:spcBef>
+          <a:spcPct val="20000"/>
+        </a:spcBef>
+        <a:buFont typeface="Arial" pitchFamily="34" charset="0"/>
+        <a:buChar char="•"/>
+        <a:defRPr sz="2000" kern="1200">
+          <a:solidFill>
+            <a:schemeClr val="tx1"/>
+          </a:solidFill>
+          <a:latin typeface="+mn-lt"/>
+          <a:ea typeface="+mn-ea"/>
+          <a:cs typeface="+mn-cs"/>
+        </a:defRPr>
+      </a:lvl7pPr>
+      <a:lvl8pPr marL="3429000" indent="-228600" algn="l" defTabSz="914400" rtl="0" eaLnBrk="1" latinLnBrk="0" hangingPunct="1">
+        <a:spcBef>
+          <a:spcPct val="20000"/>
+        </a:spcBef>
+        <a:buFont typeface="Arial" pitchFamily="34" charset="0"/>
+        <a:buChar char="•"/>
+        <a:defRPr sz="2000" kern="1200">
+          <a:solidFill>
+            <a:schemeClr val="tx1"/>
+          </a:solidFill>
+          <a:latin typeface="+mn-lt"/>
+          <a:ea typeface="+mn-ea"/>
+          <a:cs typeface="+mn-cs"/>
+        </a:defRPr>
+      </a:lvl8pPr>
+      <a:lvl9pPr marL="3886200" indent="-228600" algn="l" defTabSz="914400" rtl="0" eaLnBrk="1" latinLnBrk="0" hangingPunct="1">
+        <a:spcBef>
+          <a:spcPct val="20000"/>
+        </a:spcBef>
+        <a:buFont typeface="Arial" pitchFamily="34" charset="0"/>
+        <a:buChar char="•"/>
+        <a:defRPr sz="2000" kern="1200">
+          <a:solidFill>
+            <a:schemeClr val="tx1"/>
+          </a:solidFill>
+          <a:latin typeface="+mn-lt"/>
+          <a:ea typeface="+mn-ea"/>
+          <a:cs typeface="+mn-cs"/>
+        </a:defRPr>
+      </a:lvl9pPr>
+    </p:bodyStyle>
+    <p:otherStyle>
+      <a:defPPr>
+        <a:defRPr lang="en-US"/>
+      </a:defPPr>
+      <a:lvl1pPr marL="0" algn="l" defTabSz="914400" rtl="0" eaLnBrk="1" latinLnBrk="0" hangingPunct="1">
+        <a:defRPr sz="1800" kern="1200">
+          <a:solidFill>
+            <a:schemeClr val="tx1"/>
+          </a:solidFill>
+          <a:latin typeface="+mn-lt"/>
+          <a:ea typeface="+mn-ea"/>
+          <a:cs typeface="+mn-cs"/>
+        </a:defRPr>
+      </a:lvl1pPr>
+      <a:lvl2pPr marL="457200" algn="l" defTabSz="914400" rtl="0" eaLnBrk="1" latinLnBrk="0" hangingPunct="1">
+        <a:defRPr sz="1800" kern="1200">
+          <a:solidFill>
+            <a:schemeClr val="tx1"/>
+          </a:solidFill>
+          <a:latin typeface="+mn-lt"/>
+          <a:ea typeface="+mn-ea"/>
+          <a:cs typeface="+mn-cs"/>
+        </a:defRPr>
+      </a:lvl2pPr>
+      <a:lvl3pPr marL="914400" algn="l" defTabSz="914400" rtl="0" eaLnBrk="1" latinLnBrk="0" hangingPunct="1">
+        <a:defRPr sz="1800" kern="1200">
+          <a:solidFill>
+            <a:schemeClr val="tx1"/>
+          </a:solidFill>
+          <a:latin typeface="+mn-lt"/>
+          <a:ea typeface="+mn-ea"/>
+          <a:cs typeface="+mn-cs"/>
+        </a:defRPr>
+      </a:lvl3pPr>
+      <a:lvl4pPr marL="1371600" algn="l" defTabSz="914400" rtl="0" eaLnBrk="1" latinLnBrk="0" hangingPunct="1">
+        <a:defRPr sz="1800" kern="1200">
+          <a:solidFill>
+            <a:schemeClr val="tx1"/>
+          </a:solidFill>
+          <a:latin typeface="+mn-lt"/>
+          <a:ea typeface="+mn-ea"/>
+          <a:cs typeface="+mn-cs"/>
+        </a:defRPr>
+      </a:lvl4pPr>
+      <a:lvl5pPr marL="1828800" algn="l" defTabSz="914400" rtl="0" eaLnBrk="1" latinLnBrk="0" hangingPunct="1">
+        <a:defRPr sz="1800" kern="1200">
+          <a:solidFill>
+            <a:schemeClr val="tx1"/>
+          </a:solidFill>
+          <a:latin typeface="+mn-lt"/>
+          <a:ea typeface="+mn-ea"/>
+          <a:cs typeface="+mn-cs"/>
+        </a:defRPr>
+      </a:lvl5pPr>
+      <a:lvl6pPr marL="2286000" algn="l" defTabSz="914400" rtl="0" eaLnBrk="1" latinLnBrk="0" hangingPunct="1">
+        <a:defRPr sz="1800" kern="1200">
+          <a:solidFill>
+            <a:schemeClr val="tx1"/>
+          </a:solidFill>
+          <a:latin typeface="+mn-lt"/>
+          <a:ea typeface="+mn-ea"/>
+          <a:cs typeface="+mn-cs"/>
+        </a:defRPr>
+      </a:lvl6pPr>
+      <a:lvl7pPr marL="2743200" algn="l" defTabSz="914400" rtl="0" eaLnBrk="1" latinLnBrk="0" hangingPunct="1">
+        <a:defRPr sz="1800" kern="1200">
+          <a:solidFill>
+            <a:schemeClr val="tx1"/>
+          </a:solidFill>
+          <a:latin typeface="+mn-lt"/>
+          <a:ea typeface="+mn-ea"/>
+          <a:cs typeface="+mn-cs"/>
+        </a:defRPr>
+      </a:lvl7pPr>
+      <a:lvl8pPr marL="3200400" algn="l" defTabSz="914400" rtl="0" eaLnBrk="1" latinLnBrk="0" hangingPunct="1">
+        <a:defRPr sz="1800" kern="1200">
+          <a:solidFill>
+            <a:schemeClr val="tx1"/>
+          </a:solidFill>
+          <a:latin typeface="+mn-lt"/>
+          <a:ea typeface="+mn-ea"/>
+          <a:cs typeface="+mn-cs"/>
+        </a:defRPr>
+      </a:lvl8pPr>
+      <a:lvl9pPr marL="3657600" algn="l" defTabSz="914400" rtl="0" eaLnBrk="1" latinLnBrk="0" hangingPunct="1">
+        <a:defRPr sz="1800" kern="1200">
+          <a:solidFill>
+            <a:schemeClr val="tx1"/>
+          </a:solidFill>
+          <a:latin typeface="+mn-lt"/>
+          <a:ea typeface="+mn-ea"/>
+          <a:cs typeface="+mn-cs"/>
+        </a:defRPr>
+      </a:lvl9pPr>
+    </p:otherStyle>
+  </p:txStyles>
+</p:sldMaster>
+</file>
+
 <file path=ppt/slides/slide1.xml><?xml version="1.0" encoding="utf-8"?>
 <p:sld xmlns:a="http://schemas.openxmlformats.org/drawingml/2006/main" xmlns:r="http://schemas.openxmlformats.org/officeDocument/2006/relationships" xmlns:p="http://schemas.openxmlformats.org/presentationml/2006/main">
   <p:cSld>
+    <p:bg>
+      <p:bgPr>
+        <a:solidFill>
+          <a:srgbClr val="F7F3FF"/>
+        </a:solidFill>
+        <a:effectLst/>
+      </p:bgPr>
+    </p:bg>
     <p:spTree>
       <p:nvGrpSpPr>
         <p:cNvPr id="1" name=""/>
@@ -1212,8 +1603,8 @@
         </p:nvSpPr>
         <p:spPr>
           <a:xfrm>
-            <a:off x="164592" y="137160"/>
-            <a:ext cx="11862511" cy="6583680"/>
+            <a:off x="345949" y="283464"/>
+            <a:ext cx="11500104" cy="6217920"/>
           </a:xfrm>
           <a:prstGeom prst="roundRect">
             <a:avLst>
@@ -1234,7 +1625,37 @@
           <a:bodyPr/>
           <a:lstStyle/>
           <a:p>
-            <a:endParaRPr lang="en-IE"/>
+            <a:pPr marL="0" marR="0" lvl="0" indent="0" algn="l" defTabSz="914400" rtl="0" eaLnBrk="1" fontAlgn="auto" latinLnBrk="0" hangingPunct="1">
+              <a:lnSpc>
+                <a:spcPct val="100000"/>
+              </a:lnSpc>
+              <a:spcBef>
+                <a:spcPts val="0"/>
+              </a:spcBef>
+              <a:spcAft>
+                <a:spcPts val="0"/>
+              </a:spcAft>
+              <a:buClrTx/>
+              <a:buSzTx/>
+              <a:buFontTx/>
+              <a:buNone/>
+              <a:tabLst/>
+              <a:defRPr/>
+            </a:pPr>
+            <a:endParaRPr kumimoji="0" lang="en-IE" sz="1800" b="0" i="0" u="none" strike="noStrike" kern="1200" cap="none" spc="0" normalizeH="0" baseline="0" noProof="0">
+              <a:ln>
+                <a:noFill/>
+              </a:ln>
+              <a:solidFill>
+                <a:prstClr val="black"/>
+              </a:solidFill>
+              <a:effectLst/>
+              <a:uLnTx/>
+              <a:uFillTx/>
+              <a:latin typeface="Aptos"/>
+              <a:ea typeface="+mn-ea"/>
+              <a:cs typeface="+mn-cs"/>
+            </a:endParaRPr>
           </a:p>
         </p:txBody>
       </p:sp>
@@ -1268,7 +1689,37 @@
           <a:bodyPr/>
           <a:lstStyle/>
           <a:p>
-            <a:endParaRPr lang="en-IE"/>
+            <a:pPr marL="0" marR="0" lvl="0" indent="0" algn="l" defTabSz="914400" rtl="0" eaLnBrk="1" fontAlgn="auto" latinLnBrk="0" hangingPunct="1">
+              <a:lnSpc>
+                <a:spcPct val="100000"/>
+              </a:lnSpc>
+              <a:spcBef>
+                <a:spcPts val="0"/>
+              </a:spcBef>
+              <a:spcAft>
+                <a:spcPts val="0"/>
+              </a:spcAft>
+              <a:buClrTx/>
+              <a:buSzTx/>
+              <a:buFontTx/>
+              <a:buNone/>
+              <a:tabLst/>
+              <a:defRPr/>
+            </a:pPr>
+            <a:endParaRPr kumimoji="0" lang="en-IE" sz="1800" b="0" i="0" u="none" strike="noStrike" kern="1200" cap="none" spc="0" normalizeH="0" baseline="0" noProof="0">
+              <a:ln>
+                <a:noFill/>
+              </a:ln>
+              <a:solidFill>
+                <a:prstClr val="black"/>
+              </a:solidFill>
+              <a:effectLst/>
+              <a:uLnTx/>
+              <a:uFillTx/>
+              <a:latin typeface="Aptos"/>
+              <a:ea typeface="+mn-ea"/>
+              <a:cs typeface="+mn-cs"/>
+            </a:endParaRPr>
           </a:p>
         </p:txBody>
       </p:sp>
@@ -1280,8 +1731,8 @@
         </p:nvSpPr>
         <p:spPr>
           <a:xfrm>
-            <a:off x="9006840" y="502920"/>
-            <a:ext cx="2651760" cy="340360"/>
+            <a:off x="7461227" y="438912"/>
+            <a:ext cx="4170218" cy="548640"/>
           </a:xfrm>
           <a:prstGeom prst="roundRect">
             <a:avLst>
@@ -1302,7 +1753,37 @@
           <a:bodyPr/>
           <a:lstStyle/>
           <a:p>
-            <a:endParaRPr lang="en-IE"/>
+            <a:pPr marL="0" marR="0" lvl="0" indent="0" algn="l" defTabSz="914400" rtl="0" eaLnBrk="1" fontAlgn="auto" latinLnBrk="0" hangingPunct="1">
+              <a:lnSpc>
+                <a:spcPct val="100000"/>
+              </a:lnSpc>
+              <a:spcBef>
+                <a:spcPts val="0"/>
+              </a:spcBef>
+              <a:spcAft>
+                <a:spcPts val="0"/>
+              </a:spcAft>
+              <a:buClrTx/>
+              <a:buSzTx/>
+              <a:buFontTx/>
+              <a:buNone/>
+              <a:tabLst/>
+              <a:defRPr/>
+            </a:pPr>
+            <a:endParaRPr kumimoji="0" lang="en-IE" sz="1800" b="0" i="0" u="none" strike="noStrike" kern="1200" cap="none" spc="0" normalizeH="0" baseline="0" noProof="0">
+              <a:ln>
+                <a:noFill/>
+              </a:ln>
+              <a:solidFill>
+                <a:prstClr val="black"/>
+              </a:solidFill>
+              <a:effectLst/>
+              <a:uLnTx/>
+              <a:uFillTx/>
+              <a:latin typeface="Aptos"/>
+              <a:ea typeface="+mn-ea"/>
+              <a:cs typeface="+mn-cs"/>
+            </a:endParaRPr>
           </a:p>
         </p:txBody>
       </p:sp>
@@ -1314,7 +1795,7 @@
         </p:nvSpPr>
         <p:spPr>
           <a:xfrm>
-            <a:off x="9171432" y="585216"/>
+            <a:off x="9262872" y="475698"/>
             <a:ext cx="566928" cy="182880"/>
           </a:xfrm>
           <a:prstGeom prst="rect">
@@ -1329,21 +1810,54 @@
           </a:bodyPr>
           <a:lstStyle/>
           <a:p>
-            <a:pPr marL="0" indent="0" algn="l">
+            <a:pPr marL="0" marR="0" lvl="0" indent="0" algn="l" defTabSz="914400" rtl="0" eaLnBrk="1" fontAlgn="auto" latinLnBrk="0" hangingPunct="1">
+              <a:lnSpc>
+                <a:spcPct val="100000"/>
+              </a:lnSpc>
+              <a:spcBef>
+                <a:spcPts val="0"/>
+              </a:spcBef>
+              <a:spcAft>
+                <a:spcPts val="0"/>
+              </a:spcAft>
+              <a:buClrTx/>
+              <a:buSzTx/>
+              <a:buFontTx/>
               <a:buNone/>
+              <a:tabLst/>
+              <a:defRPr/>
             </a:pPr>
             <a:r>
-              <a:rPr lang="en-US" sz="1700" b="1" dirty="0">
+              <a:rPr kumimoji="0" lang="en-US" sz="1700" b="1" i="0" u="none" strike="noStrike" kern="1200" cap="none" spc="0" normalizeH="0" baseline="0" noProof="0" dirty="0">
+                <a:ln>
+                  <a:noFill/>
+                </a:ln>
                 <a:solidFill>
                   <a:srgbClr val="143A9D"/>
                 </a:solidFill>
+                <a:effectLst/>
+                <a:uLnTx/>
+                <a:uFillTx/>
                 <a:latin typeface="Aptos" pitchFamily="34" charset="0"/>
                 <a:ea typeface="Aptos" pitchFamily="34" charset="-122"/>
                 <a:cs typeface="Aptos" pitchFamily="34" charset="-120"/>
               </a:rPr>
               <a:t>DkIT</a:t>
             </a:r>
-            <a:endParaRPr lang="en-US" sz="1700" dirty="0"/>
+            <a:endParaRPr kumimoji="0" lang="en-US" sz="1700" b="0" i="0" u="none" strike="noStrike" kern="1200" cap="none" spc="0" normalizeH="0" baseline="0" noProof="0" dirty="0">
+              <a:ln>
+                <a:noFill/>
+              </a:ln>
+              <a:solidFill>
+                <a:prstClr val="black"/>
+              </a:solidFill>
+              <a:effectLst/>
+              <a:uLnTx/>
+              <a:uFillTx/>
+              <a:latin typeface="Aptos"/>
+              <a:ea typeface="+mn-ea"/>
+              <a:cs typeface="+mn-cs"/>
+            </a:endParaRPr>
           </a:p>
         </p:txBody>
       </p:sp>
@@ -1355,8 +1869,8 @@
         </p:nvSpPr>
         <p:spPr>
           <a:xfrm>
-            <a:off x="9857232" y="594360"/>
-            <a:ext cx="1591056" cy="164592"/>
+            <a:off x="7824182" y="462096"/>
+            <a:ext cx="3617382" cy="507562"/>
           </a:xfrm>
           <a:prstGeom prst="rect">
             <a:avLst/>
@@ -1366,66 +1880,58 @@
         </p:spPr>
         <p:txBody>
           <a:bodyPr wrap="square" lIns="254" tIns="254" rIns="254" bIns="254" rtlCol="0" anchor="ctr">
-            <a:normAutofit/>
+            <a:noAutofit/>
           </a:bodyPr>
           <a:lstStyle/>
           <a:p>
-            <a:pPr marL="0" indent="0" algn="l">
+            <a:pPr marL="0" marR="0" lvl="0" indent="0" algn="l" defTabSz="914400" rtl="0" eaLnBrk="1" fontAlgn="auto" latinLnBrk="0" hangingPunct="1">
+              <a:lnSpc>
+                <a:spcPct val="100000"/>
+              </a:lnSpc>
+              <a:spcBef>
+                <a:spcPts val="0"/>
+              </a:spcBef>
+              <a:spcAft>
+                <a:spcPts val="0"/>
+              </a:spcAft>
+              <a:buClrTx/>
+              <a:buSzTx/>
+              <a:buFontTx/>
               <a:buNone/>
+              <a:tabLst/>
+              <a:defRPr/>
             </a:pPr>
             <a:r>
-              <a:rPr lang="en-US" sz="820" dirty="0">
+              <a:rPr kumimoji="0" lang="en-US" sz="2000" b="0" i="0" u="none" strike="noStrike" kern="1200" cap="none" spc="0" normalizeH="0" baseline="0" noProof="0" dirty="0">
+                <a:ln>
+                  <a:noFill/>
+                </a:ln>
                 <a:solidFill>
                   <a:srgbClr val="758198"/>
                 </a:solidFill>
+                <a:effectLst/>
+                <a:uLnTx/>
+                <a:uFillTx/>
                 <a:latin typeface="Aptos" pitchFamily="34" charset="0"/>
                 <a:ea typeface="Aptos" pitchFamily="34" charset="-122"/>
                 <a:cs typeface="Aptos" pitchFamily="34" charset="-120"/>
               </a:rPr>
               <a:t>Dundalk Institute of Technology</a:t>
             </a:r>
-            <a:endParaRPr lang="en-US" sz="820" dirty="0"/>
-          </a:p>
-        </p:txBody>
-      </p:sp>
-      <p:sp>
-        <p:nvSpPr>
-          <p:cNvPr id="7" name="Text 5"/>
-          <p:cNvSpPr/>
-          <p:nvPr/>
-        </p:nvSpPr>
-        <p:spPr>
-          <a:xfrm>
-            <a:off x="685800" y="457200"/>
-            <a:ext cx="4480560" cy="530352"/>
-          </a:xfrm>
-          <a:prstGeom prst="rect">
-            <a:avLst/>
-          </a:prstGeom>
-          <a:noFill/>
-          <a:ln/>
-        </p:spPr>
-        <p:txBody>
-          <a:bodyPr wrap="square" lIns="254" tIns="254" rIns="254" bIns="254" rtlCol="0" anchor="ctr">
-            <a:normAutofit fontScale="92500" lnSpcReduction="10000"/>
-          </a:bodyPr>
-          <a:lstStyle/>
-          <a:p>
-            <a:pPr marL="0" indent="0" algn="l">
-              <a:buNone/>
-            </a:pPr>
-            <a:r>
-              <a:rPr lang="en-US" sz="4000" b="1" dirty="0">
-                <a:solidFill>
-                  <a:srgbClr val="143A9D"/>
-                </a:solidFill>
-                <a:latin typeface="Aptos Display" pitchFamily="34" charset="0"/>
-                <a:ea typeface="Aptos Display" pitchFamily="34" charset="-122"/>
-                <a:cs typeface="Aptos Display" pitchFamily="34" charset="-120"/>
-              </a:rPr>
-              <a:t>TempSafe</a:t>
-            </a:r>
-            <a:endParaRPr lang="en-US" sz="4000" dirty="0"/>
+            <a:endParaRPr kumimoji="0" lang="en-US" sz="2000" b="0" i="0" u="none" strike="noStrike" kern="1200" cap="none" spc="0" normalizeH="0" baseline="0" noProof="0" dirty="0">
+              <a:ln>
+                <a:noFill/>
+              </a:ln>
+              <a:solidFill>
+                <a:prstClr val="black"/>
+              </a:solidFill>
+              <a:effectLst/>
+              <a:uLnTx/>
+              <a:uFillTx/>
+              <a:latin typeface="Aptos"/>
+              <a:ea typeface="+mn-ea"/>
+              <a:cs typeface="+mn-cs"/>
+            </a:endParaRPr>
           </a:p>
         </p:txBody>
       </p:sp>
@@ -1437,7 +1943,7 @@
         </p:nvSpPr>
         <p:spPr>
           <a:xfrm>
-            <a:off x="713232" y="1161288"/>
+            <a:off x="2738628" y="1202921"/>
             <a:ext cx="5806440" cy="256032"/>
           </a:xfrm>
           <a:prstGeom prst="rect">
@@ -1452,21 +1958,54 @@
           </a:bodyPr>
           <a:lstStyle/>
           <a:p>
-            <a:pPr marL="0" indent="0" algn="l">
+            <a:pPr marL="0" marR="0" lvl="0" indent="0" algn="l" defTabSz="914400" rtl="0" eaLnBrk="1" fontAlgn="auto" latinLnBrk="0" hangingPunct="1">
+              <a:lnSpc>
+                <a:spcPct val="100000"/>
+              </a:lnSpc>
+              <a:spcBef>
+                <a:spcPts val="0"/>
+              </a:spcBef>
+              <a:spcAft>
+                <a:spcPts val="0"/>
+              </a:spcAft>
+              <a:buClrTx/>
+              <a:buSzTx/>
+              <a:buFontTx/>
               <a:buNone/>
+              <a:tabLst/>
+              <a:defRPr/>
             </a:pPr>
             <a:r>
-              <a:rPr lang="en-US" sz="1800" b="1" dirty="0">
+              <a:rPr kumimoji="0" lang="en-US" sz="1800" b="1" i="0" u="none" strike="noStrike" kern="1200" cap="none" spc="0" normalizeH="0" baseline="0" noProof="0" dirty="0">
+                <a:ln>
+                  <a:noFill/>
+                </a:ln>
                 <a:solidFill>
                   <a:srgbClr val="2447A6"/>
                 </a:solidFill>
+                <a:effectLst/>
+                <a:uLnTx/>
+                <a:uFillTx/>
                 <a:latin typeface="Aptos" pitchFamily="34" charset="0"/>
                 <a:ea typeface="Aptos" pitchFamily="34" charset="-122"/>
                 <a:cs typeface="Aptos" pitchFamily="34" charset="-120"/>
               </a:rPr>
               <a:t>Smart Temperature Monitoring for a Controlled Drug Box</a:t>
             </a:r>
-            <a:endParaRPr lang="en-US" sz="1800" dirty="0"/>
+            <a:endParaRPr kumimoji="0" lang="en-US" sz="1800" b="0" i="0" u="none" strike="noStrike" kern="1200" cap="none" spc="0" normalizeH="0" baseline="0" noProof="0" dirty="0">
+              <a:ln>
+                <a:noFill/>
+              </a:ln>
+              <a:solidFill>
+                <a:prstClr val="black"/>
+              </a:solidFill>
+              <a:effectLst/>
+              <a:uLnTx/>
+              <a:uFillTx/>
+              <a:latin typeface="Aptos"/>
+              <a:ea typeface="+mn-ea"/>
+              <a:cs typeface="+mn-cs"/>
+            </a:endParaRPr>
           </a:p>
         </p:txBody>
       </p:sp>
@@ -1478,8 +2017,8 @@
         </p:nvSpPr>
         <p:spPr>
           <a:xfrm>
-            <a:off x="690372" y="1517904"/>
-            <a:ext cx="2423160" cy="384048"/>
+            <a:off x="4100251" y="436949"/>
+            <a:ext cx="2761489" cy="546034"/>
           </a:xfrm>
           <a:prstGeom prst="roundRect">
             <a:avLst>
@@ -1500,7 +2039,37 @@
           <a:bodyPr/>
           <a:lstStyle/>
           <a:p>
-            <a:endParaRPr lang="en-IE" dirty="0"/>
+            <a:pPr marL="0" marR="0" lvl="0" indent="0" algn="l" defTabSz="914400" rtl="0" eaLnBrk="1" fontAlgn="auto" latinLnBrk="0" hangingPunct="1">
+              <a:lnSpc>
+                <a:spcPct val="100000"/>
+              </a:lnSpc>
+              <a:spcBef>
+                <a:spcPts val="0"/>
+              </a:spcBef>
+              <a:spcAft>
+                <a:spcPts val="0"/>
+              </a:spcAft>
+              <a:buClrTx/>
+              <a:buSzTx/>
+              <a:buFontTx/>
+              <a:buNone/>
+              <a:tabLst/>
+              <a:defRPr/>
+            </a:pPr>
+            <a:endParaRPr kumimoji="0" lang="en-IE" sz="1800" b="0" i="0" u="none" strike="noStrike" kern="1200" cap="none" spc="0" normalizeH="0" baseline="0" noProof="0" dirty="0">
+              <a:ln>
+                <a:noFill/>
+              </a:ln>
+              <a:solidFill>
+                <a:prstClr val="black"/>
+              </a:solidFill>
+              <a:effectLst/>
+              <a:uLnTx/>
+              <a:uFillTx/>
+              <a:latin typeface="Aptos"/>
+              <a:ea typeface="+mn-ea"/>
+              <a:cs typeface="+mn-cs"/>
+            </a:endParaRPr>
           </a:p>
         </p:txBody>
       </p:sp>
@@ -1512,8 +2081,8 @@
         </p:nvSpPr>
         <p:spPr>
           <a:xfrm>
-            <a:off x="868680" y="1627632"/>
-            <a:ext cx="1828800" cy="201168"/>
+            <a:off x="4480560" y="566077"/>
+            <a:ext cx="2041468" cy="343752"/>
           </a:xfrm>
           <a:prstGeom prst="rect">
             <a:avLst/>
@@ -1525,14 +2094,34 @@
           <a:bodyPr wrap="square" lIns="254" tIns="254" rIns="254" bIns="254" rtlCol="0" anchor="ctr"/>
           <a:lstStyle/>
           <a:p>
-            <a:pPr marL="0" indent="0">
+            <a:pPr marL="0" marR="0" lvl="0" indent="0" algn="l" defTabSz="914400" rtl="0" eaLnBrk="1" fontAlgn="auto" latinLnBrk="0" hangingPunct="1">
+              <a:lnSpc>
+                <a:spcPct val="100000"/>
+              </a:lnSpc>
+              <a:spcBef>
+                <a:spcPts val="0"/>
+              </a:spcBef>
+              <a:spcAft>
+                <a:spcPts val="0"/>
+              </a:spcAft>
+              <a:buClrTx/>
+              <a:buSzTx/>
+              <a:buFontTx/>
               <a:buNone/>
+              <a:tabLst/>
+              <a:defRPr/>
             </a:pPr>
             <a:r>
-              <a:rPr lang="en-US" sz="1350" b="1" dirty="0">
+              <a:rPr kumimoji="0" lang="en-US" sz="2000" b="1" i="0" u="none" strike="noStrike" kern="1200" cap="none" spc="0" normalizeH="0" baseline="0" noProof="0" dirty="0">
+                <a:ln>
+                  <a:noFill/>
+                </a:ln>
                 <a:solidFill>
                   <a:srgbClr val="143A9D"/>
                 </a:solidFill>
+                <a:effectLst/>
+                <a:uLnTx/>
+                <a:uFillTx/>
                 <a:latin typeface="Aptos" pitchFamily="34" charset="0"/>
                 <a:ea typeface="Aptos" pitchFamily="34" charset="-122"/>
                 <a:cs typeface="Aptos" pitchFamily="34" charset="-120"/>
@@ -1540,17 +2129,36 @@
               <a:t>Team: </a:t>
             </a:r>
             <a:r>
-              <a:rPr lang="en-US" sz="1350" dirty="0">
+              <a:rPr kumimoji="0" lang="en-US" sz="2000" b="0" i="0" u="none" strike="noStrike" kern="1200" cap="none" spc="0" normalizeH="0" baseline="0" noProof="0" dirty="0">
+                <a:ln>
+                  <a:noFill/>
+                </a:ln>
                 <a:solidFill>
                   <a:srgbClr val="143A9D"/>
                 </a:solidFill>
+                <a:effectLst/>
+                <a:uLnTx/>
+                <a:uFillTx/>
                 <a:latin typeface="Aptos" pitchFamily="34" charset="0"/>
                 <a:ea typeface="Aptos" pitchFamily="34" charset="-122"/>
                 <a:cs typeface="Aptos" pitchFamily="34" charset="-120"/>
               </a:rPr>
               <a:t>Smart box</a:t>
             </a:r>
-            <a:endParaRPr lang="en-US" sz="1350" dirty="0"/>
+            <a:endParaRPr kumimoji="0" lang="en-US" sz="2000" b="0" i="0" u="none" strike="noStrike" kern="1200" cap="none" spc="0" normalizeH="0" baseline="0" noProof="0" dirty="0">
+              <a:ln>
+                <a:noFill/>
+              </a:ln>
+              <a:solidFill>
+                <a:prstClr val="black"/>
+              </a:solidFill>
+              <a:effectLst/>
+              <a:uLnTx/>
+              <a:uFillTx/>
+              <a:latin typeface="Aptos"/>
+              <a:ea typeface="+mn-ea"/>
+              <a:cs typeface="+mn-cs"/>
+            </a:endParaRPr>
           </a:p>
         </p:txBody>
       </p:sp>
@@ -1562,8 +2170,8 @@
         </p:nvSpPr>
         <p:spPr>
           <a:xfrm>
-            <a:off x="713232" y="2240280"/>
-            <a:ext cx="3154680" cy="1965960"/>
+            <a:off x="713231" y="1770215"/>
+            <a:ext cx="3497255" cy="2473452"/>
           </a:xfrm>
           <a:prstGeom prst="roundRect">
             <a:avLst>
@@ -1591,7 +2199,37 @@
           <a:bodyPr/>
           <a:lstStyle/>
           <a:p>
-            <a:endParaRPr lang="en-IE"/>
+            <a:pPr marL="0" marR="0" lvl="0" indent="0" algn="l" defTabSz="914400" rtl="0" eaLnBrk="1" fontAlgn="auto" latinLnBrk="0" hangingPunct="1">
+              <a:lnSpc>
+                <a:spcPct val="100000"/>
+              </a:lnSpc>
+              <a:spcBef>
+                <a:spcPts val="0"/>
+              </a:spcBef>
+              <a:spcAft>
+                <a:spcPts val="0"/>
+              </a:spcAft>
+              <a:buClrTx/>
+              <a:buSzTx/>
+              <a:buFontTx/>
+              <a:buNone/>
+              <a:tabLst/>
+              <a:defRPr/>
+            </a:pPr>
+            <a:endParaRPr kumimoji="0" lang="en-IE" sz="1800" b="0" i="0" u="none" strike="noStrike" kern="1200" cap="none" spc="0" normalizeH="0" baseline="0" noProof="0" dirty="0">
+              <a:ln>
+                <a:noFill/>
+              </a:ln>
+              <a:solidFill>
+                <a:prstClr val="black"/>
+              </a:solidFill>
+              <a:effectLst/>
+              <a:uLnTx/>
+              <a:uFillTx/>
+              <a:latin typeface="Aptos"/>
+              <a:ea typeface="+mn-ea"/>
+              <a:cs typeface="+mn-cs"/>
+            </a:endParaRPr>
           </a:p>
         </p:txBody>
       </p:sp>
@@ -1603,8 +2241,8 @@
         </p:nvSpPr>
         <p:spPr>
           <a:xfrm>
-            <a:off x="969264" y="2496312"/>
-            <a:ext cx="1078992" cy="1078992"/>
+            <a:off x="812815" y="1787118"/>
+            <a:ext cx="1381745" cy="2043796"/>
           </a:xfrm>
           <a:prstGeom prst="ellipse">
             <a:avLst/>
@@ -1623,20 +2261,50 @@
           <a:bodyPr/>
           <a:lstStyle/>
           <a:p>
-            <a:endParaRPr lang="en-IE"/>
+            <a:pPr marL="0" marR="0" lvl="0" indent="0" algn="l" defTabSz="914400" rtl="0" eaLnBrk="1" fontAlgn="auto" latinLnBrk="0" hangingPunct="1">
+              <a:lnSpc>
+                <a:spcPct val="100000"/>
+              </a:lnSpc>
+              <a:spcBef>
+                <a:spcPts val="0"/>
+              </a:spcBef>
+              <a:spcAft>
+                <a:spcPts val="0"/>
+              </a:spcAft>
+              <a:buClrTx/>
+              <a:buSzTx/>
+              <a:buFontTx/>
+              <a:buNone/>
+              <a:tabLst/>
+              <a:defRPr/>
+            </a:pPr>
+            <a:endParaRPr kumimoji="0" lang="en-IE" sz="1800" b="0" i="0" u="none" strike="noStrike" kern="1200" cap="none" spc="0" normalizeH="0" baseline="0" noProof="0">
+              <a:ln>
+                <a:noFill/>
+              </a:ln>
+              <a:solidFill>
+                <a:prstClr val="black"/>
+              </a:solidFill>
+              <a:effectLst/>
+              <a:uLnTx/>
+              <a:uFillTx/>
+              <a:latin typeface="Aptos"/>
+              <a:ea typeface="+mn-ea"/>
+              <a:cs typeface="+mn-cs"/>
+            </a:endParaRPr>
           </a:p>
         </p:txBody>
       </p:sp>
       <p:sp>
         <p:nvSpPr>
-          <p:cNvPr id="13" name="Text 11"/>
+          <p:cNvPr id="14" name="Text 12"/>
           <p:cNvSpPr/>
           <p:nvPr/>
         </p:nvSpPr>
         <p:spPr>
           <a:xfrm>
-            <a:off x="1207008" y="2862072"/>
-            <a:ext cx="594360" cy="146304"/>
+            <a:off x="2194559" y="2283659"/>
+            <a:ext cx="1920239" cy="888953"/>
           </a:xfrm>
           <a:prstGeom prst="rect">
             <a:avLst/>
@@ -1650,62 +2318,54 @@
           </a:bodyPr>
           <a:lstStyle/>
           <a:p>
-            <a:pPr marL="0" indent="0" algn="ctr">
+            <a:pPr marL="0" marR="0" lvl="0" indent="0" algn="ctr" defTabSz="914400" rtl="0" eaLnBrk="1" fontAlgn="auto" latinLnBrk="0" hangingPunct="1">
+              <a:lnSpc>
+                <a:spcPct val="100000"/>
+              </a:lnSpc>
+              <a:spcBef>
+                <a:spcPts val="0"/>
+              </a:spcBef>
+              <a:spcAft>
+                <a:spcPts val="0"/>
+              </a:spcAft>
+              <a:buClrTx/>
+              <a:buSzTx/>
+              <a:buFontTx/>
               <a:buNone/>
+              <a:tabLst/>
+              <a:defRPr/>
             </a:pPr>
             <a:r>
-              <a:rPr lang="en-US" sz="900" dirty="0">
-                <a:solidFill>
-                  <a:srgbClr val="758198"/>
-                </a:solidFill>
-                <a:latin typeface="Aptos" pitchFamily="34" charset="0"/>
-                <a:ea typeface="Aptos" pitchFamily="34" charset="-122"/>
-                <a:cs typeface="Aptos" pitchFamily="34" charset="-120"/>
-              </a:rPr>
-              <a:t>Photo</a:t>
-            </a:r>
-            <a:endParaRPr lang="en-US" sz="900" dirty="0"/>
-          </a:p>
-        </p:txBody>
-      </p:sp>
-      <p:sp>
-        <p:nvSpPr>
-          <p:cNvPr id="14" name="Text 12"/>
-          <p:cNvSpPr/>
-          <p:nvPr/>
-        </p:nvSpPr>
-        <p:spPr>
-          <a:xfrm>
-            <a:off x="2194560" y="2679192"/>
-            <a:ext cx="1481328" cy="228600"/>
-          </a:xfrm>
-          <a:prstGeom prst="rect">
-            <a:avLst/>
-          </a:prstGeom>
-          <a:noFill/>
-          <a:ln/>
-        </p:spPr>
-        <p:txBody>
-          <a:bodyPr wrap="square" lIns="254" tIns="254" rIns="254" bIns="254" rtlCol="0" anchor="ctr">
-            <a:normAutofit lnSpcReduction="10000"/>
-          </a:bodyPr>
-          <a:lstStyle/>
-          <a:p>
-            <a:pPr marL="0" indent="0" algn="l">
-              <a:buNone/>
-            </a:pPr>
-            <a:r>
-              <a:rPr lang="en-US" sz="1600" b="1" dirty="0">
+              <a:rPr kumimoji="0" lang="en-US" sz="2400" b="1" i="0" u="none" strike="noStrike" kern="1200" cap="none" spc="0" normalizeH="0" baseline="0" noProof="0" dirty="0">
+                <a:ln>
+                  <a:noFill/>
+                </a:ln>
                 <a:solidFill>
                   <a:srgbClr val="143A9D"/>
                 </a:solidFill>
+                <a:effectLst/>
+                <a:uLnTx/>
+                <a:uFillTx/>
                 <a:latin typeface="Aptos" pitchFamily="34" charset="0"/>
                 <a:ea typeface="Aptos" pitchFamily="34" charset="-122"/>
                 <a:cs typeface="Aptos" pitchFamily="34" charset="-120"/>
               </a:rPr>
               <a:t>Nikita Smiichyk</a:t>
             </a:r>
-            <a:endParaRPr lang="en-US" sz="1600" dirty="0"/>
+            <a:endParaRPr kumimoji="0" lang="en-US" sz="2400" b="0" i="0" u="none" strike="noStrike" kern="1200" cap="none" spc="0" normalizeH="0" baseline="0" noProof="0" dirty="0">
+              <a:ln>
+                <a:noFill/>
+              </a:ln>
+              <a:solidFill>
+                <a:prstClr val="black"/>
+              </a:solidFill>
+              <a:effectLst/>
+              <a:uLnTx/>
+              <a:uFillTx/>
+              <a:latin typeface="Aptos"/>
+              <a:ea typeface="+mn-ea"/>
+              <a:cs typeface="+mn-cs"/>
+            </a:endParaRPr>
           </a:p>
         </p:txBody>
       </p:sp>
@@ -1717,8 +2377,8 @@
         </p:nvSpPr>
         <p:spPr>
           <a:xfrm>
-            <a:off x="2194560" y="3044952"/>
-            <a:ext cx="1481328" cy="365760"/>
+            <a:off x="2180012" y="3320866"/>
+            <a:ext cx="1920239" cy="365760"/>
           </a:xfrm>
           <a:prstGeom prst="rect">
             <a:avLst/>
@@ -1728,25 +2388,58 @@
         </p:spPr>
         <p:txBody>
           <a:bodyPr wrap="square" lIns="254" tIns="254" rIns="254" bIns="254" rtlCol="0" anchor="ctr">
-            <a:normAutofit lnSpcReduction="10000"/>
+            <a:noAutofit/>
           </a:bodyPr>
           <a:lstStyle/>
           <a:p>
-            <a:pPr marL="0" indent="0" algn="l">
+            <a:pPr marL="0" marR="0" lvl="0" indent="0" algn="ctr" defTabSz="914400" rtl="0" eaLnBrk="1" fontAlgn="auto" latinLnBrk="0" hangingPunct="1">
+              <a:lnSpc>
+                <a:spcPct val="100000"/>
+              </a:lnSpc>
+              <a:spcBef>
+                <a:spcPts val="0"/>
+              </a:spcBef>
+              <a:spcAft>
+                <a:spcPts val="0"/>
+              </a:spcAft>
+              <a:buClrTx/>
+              <a:buSzTx/>
+              <a:buFontTx/>
               <a:buNone/>
+              <a:tabLst/>
+              <a:defRPr/>
             </a:pPr>
             <a:r>
-              <a:rPr lang="en-US" sz="1230" dirty="0">
+              <a:rPr kumimoji="0" lang="en-US" sz="1400" b="0" i="0" u="none" strike="noStrike" kern="1200" cap="none" spc="0" normalizeH="0" baseline="0" noProof="0" dirty="0">
+                <a:ln>
+                  <a:noFill/>
+                </a:ln>
                 <a:solidFill>
                   <a:srgbClr val="53617A"/>
                 </a:solidFill>
+                <a:effectLst/>
+                <a:uLnTx/>
+                <a:uFillTx/>
                 <a:latin typeface="Aptos" pitchFamily="34" charset="0"/>
                 <a:ea typeface="Aptos" pitchFamily="34" charset="-122"/>
                 <a:cs typeface="Aptos" pitchFamily="34" charset="-120"/>
               </a:rPr>
               <a:t>Backend/Database, Testing</a:t>
             </a:r>
-            <a:endParaRPr lang="en-US" sz="1230" dirty="0"/>
+            <a:endParaRPr kumimoji="0" lang="en-US" sz="1400" b="0" i="0" u="none" strike="noStrike" kern="1200" cap="none" spc="0" normalizeH="0" baseline="0" noProof="0" dirty="0">
+              <a:ln>
+                <a:noFill/>
+              </a:ln>
+              <a:solidFill>
+                <a:prstClr val="black"/>
+              </a:solidFill>
+              <a:effectLst/>
+              <a:uLnTx/>
+              <a:uFillTx/>
+              <a:latin typeface="Aptos"/>
+              <a:ea typeface="+mn-ea"/>
+              <a:cs typeface="+mn-cs"/>
+            </a:endParaRPr>
           </a:p>
         </p:txBody>
       </p:sp>
@@ -1758,8 +2451,8 @@
         </p:nvSpPr>
         <p:spPr>
           <a:xfrm>
-            <a:off x="950976" y="3849624"/>
-            <a:ext cx="2679192" cy="0"/>
+            <a:off x="941832" y="3878650"/>
+            <a:ext cx="3158420" cy="25416"/>
           </a:xfrm>
           <a:prstGeom prst="line">
             <a:avLst/>
@@ -1776,7 +2469,37 @@
           <a:bodyPr/>
           <a:lstStyle/>
           <a:p>
-            <a:endParaRPr lang="en-IE"/>
+            <a:pPr marL="0" marR="0" lvl="0" indent="0" algn="l" defTabSz="914400" rtl="0" eaLnBrk="1" fontAlgn="auto" latinLnBrk="0" hangingPunct="1">
+              <a:lnSpc>
+                <a:spcPct val="100000"/>
+              </a:lnSpc>
+              <a:spcBef>
+                <a:spcPts val="0"/>
+              </a:spcBef>
+              <a:spcAft>
+                <a:spcPts val="0"/>
+              </a:spcAft>
+              <a:buClrTx/>
+              <a:buSzTx/>
+              <a:buFontTx/>
+              <a:buNone/>
+              <a:tabLst/>
+              <a:defRPr/>
+            </a:pPr>
+            <a:endParaRPr kumimoji="0" lang="en-IE" sz="1800" b="0" i="0" u="none" strike="noStrike" kern="1200" cap="none" spc="0" normalizeH="0" baseline="0" noProof="0">
+              <a:ln>
+                <a:noFill/>
+              </a:ln>
+              <a:solidFill>
+                <a:prstClr val="black"/>
+              </a:solidFill>
+              <a:effectLst/>
+              <a:uLnTx/>
+              <a:uFillTx/>
+              <a:latin typeface="Aptos"/>
+              <a:ea typeface="+mn-ea"/>
+              <a:cs typeface="+mn-cs"/>
+            </a:endParaRPr>
           </a:p>
         </p:txBody>
       </p:sp>
@@ -1788,8 +2511,8 @@
         </p:nvSpPr>
         <p:spPr>
           <a:xfrm>
-            <a:off x="969264" y="3959352"/>
-            <a:ext cx="2651760" cy="146304"/>
+            <a:off x="1079497" y="3959352"/>
+            <a:ext cx="3130989" cy="212563"/>
           </a:xfrm>
           <a:prstGeom prst="rect">
             <a:avLst/>
@@ -1799,25 +2522,58 @@
         </p:spPr>
         <p:txBody>
           <a:bodyPr wrap="square" lIns="254" tIns="254" rIns="254" bIns="254" rtlCol="0" anchor="ctr">
-            <a:normAutofit/>
+            <a:noAutofit/>
           </a:bodyPr>
           <a:lstStyle/>
           <a:p>
-            <a:pPr marL="0" indent="0" algn="ctr">
+            <a:pPr marL="0" marR="0" lvl="0" indent="0" algn="ctr" defTabSz="914400" rtl="0" eaLnBrk="1" fontAlgn="auto" latinLnBrk="0" hangingPunct="1">
+              <a:lnSpc>
+                <a:spcPct val="100000"/>
+              </a:lnSpc>
+              <a:spcBef>
+                <a:spcPts val="0"/>
+              </a:spcBef>
+              <a:spcAft>
+                <a:spcPts val="0"/>
+              </a:spcAft>
+              <a:buClrTx/>
+              <a:buSzTx/>
+              <a:buFontTx/>
               <a:buNone/>
+              <a:tabLst/>
+              <a:defRPr/>
             </a:pPr>
             <a:r>
-              <a:rPr lang="en-US" sz="880" dirty="0">
+              <a:rPr kumimoji="0" lang="en-US" sz="1200" b="0" i="0" u="none" strike="noStrike" kern="1200" cap="none" spc="0" normalizeH="0" baseline="0" noProof="0" dirty="0">
+                <a:ln>
+                  <a:noFill/>
+                </a:ln>
                 <a:solidFill>
                   <a:srgbClr val="758198"/>
                 </a:solidFill>
+                <a:effectLst/>
+                <a:uLnTx/>
+                <a:uFillTx/>
                 <a:latin typeface="Aptos" pitchFamily="34" charset="0"/>
                 <a:ea typeface="Aptos" pitchFamily="34" charset="-122"/>
                 <a:cs typeface="Aptos" pitchFamily="34" charset="-120"/>
               </a:rPr>
               <a:t>Team member 1</a:t>
             </a:r>
-            <a:endParaRPr lang="en-US" sz="880" dirty="0"/>
+            <a:endParaRPr kumimoji="0" lang="en-US" sz="1200" b="0" i="0" u="none" strike="noStrike" kern="1200" cap="none" spc="0" normalizeH="0" baseline="0" noProof="0" dirty="0">
+              <a:ln>
+                <a:noFill/>
+              </a:ln>
+              <a:solidFill>
+                <a:prstClr val="black"/>
+              </a:solidFill>
+              <a:effectLst/>
+              <a:uLnTx/>
+              <a:uFillTx/>
+              <a:latin typeface="Aptos"/>
+              <a:ea typeface="+mn-ea"/>
+              <a:cs typeface="+mn-cs"/>
+            </a:endParaRPr>
           </a:p>
         </p:txBody>
       </p:sp>
@@ -1829,8 +2585,8 @@
         </p:nvSpPr>
         <p:spPr>
           <a:xfrm>
-            <a:off x="4160520" y="2240280"/>
-            <a:ext cx="3154680" cy="1965960"/>
+            <a:off x="4342801" y="1778310"/>
+            <a:ext cx="3320103" cy="2473452"/>
           </a:xfrm>
           <a:prstGeom prst="roundRect">
             <a:avLst>
@@ -1858,7 +2614,37 @@
           <a:bodyPr/>
           <a:lstStyle/>
           <a:p>
-            <a:endParaRPr lang="en-IE"/>
+            <a:pPr marL="0" marR="0" lvl="0" indent="0" algn="l" defTabSz="914400" rtl="0" eaLnBrk="1" fontAlgn="auto" latinLnBrk="0" hangingPunct="1">
+              <a:lnSpc>
+                <a:spcPct val="100000"/>
+              </a:lnSpc>
+              <a:spcBef>
+                <a:spcPts val="0"/>
+              </a:spcBef>
+              <a:spcAft>
+                <a:spcPts val="0"/>
+              </a:spcAft>
+              <a:buClrTx/>
+              <a:buSzTx/>
+              <a:buFontTx/>
+              <a:buNone/>
+              <a:tabLst/>
+              <a:defRPr/>
+            </a:pPr>
+            <a:endParaRPr kumimoji="0" lang="en-IE" sz="1800" b="0" i="0" u="none" strike="noStrike" kern="1200" cap="none" spc="0" normalizeH="0" baseline="0" noProof="0">
+              <a:ln>
+                <a:noFill/>
+              </a:ln>
+              <a:solidFill>
+                <a:prstClr val="black"/>
+              </a:solidFill>
+              <a:effectLst/>
+              <a:uLnTx/>
+              <a:uFillTx/>
+              <a:latin typeface="Aptos"/>
+              <a:ea typeface="+mn-ea"/>
+              <a:cs typeface="+mn-cs"/>
+            </a:endParaRPr>
           </a:p>
         </p:txBody>
       </p:sp>
@@ -1870,8 +2656,8 @@
         </p:nvSpPr>
         <p:spPr>
           <a:xfrm>
-            <a:off x="4416552" y="2496312"/>
-            <a:ext cx="1078992" cy="1078992"/>
+            <a:off x="4434743" y="1809011"/>
+            <a:ext cx="1472868" cy="2007104"/>
           </a:xfrm>
           <a:prstGeom prst="ellipse">
             <a:avLst/>
@@ -1890,48 +2676,37 @@
           <a:bodyPr/>
           <a:lstStyle/>
           <a:p>
-            <a:endParaRPr lang="en-IE"/>
-          </a:p>
-        </p:txBody>
-      </p:sp>
-      <p:sp>
-        <p:nvSpPr>
-          <p:cNvPr id="20" name="Text 18"/>
-          <p:cNvSpPr/>
-          <p:nvPr/>
-        </p:nvSpPr>
-        <p:spPr>
-          <a:xfrm>
-            <a:off x="4654296" y="2862072"/>
-            <a:ext cx="594360" cy="146304"/>
-          </a:xfrm>
-          <a:prstGeom prst="rect">
-            <a:avLst/>
-          </a:prstGeom>
-          <a:noFill/>
-          <a:ln/>
-        </p:spPr>
-        <p:txBody>
-          <a:bodyPr wrap="square" lIns="254" tIns="254" rIns="254" bIns="254" rtlCol="0" anchor="ctr">
-            <a:normAutofit/>
-          </a:bodyPr>
-          <a:lstStyle/>
-          <a:p>
-            <a:pPr marL="0" indent="0" algn="ctr">
+            <a:pPr marL="0" marR="0" lvl="0" indent="0" algn="l" defTabSz="914400" rtl="0" eaLnBrk="1" fontAlgn="auto" latinLnBrk="0" hangingPunct="1">
+              <a:lnSpc>
+                <a:spcPct val="100000"/>
+              </a:lnSpc>
+              <a:spcBef>
+                <a:spcPts val="0"/>
+              </a:spcBef>
+              <a:spcAft>
+                <a:spcPts val="0"/>
+              </a:spcAft>
+              <a:buClrTx/>
+              <a:buSzTx/>
+              <a:buFontTx/>
               <a:buNone/>
+              <a:tabLst/>
+              <a:defRPr/>
             </a:pPr>
-            <a:r>
-              <a:rPr lang="en-US" sz="900" dirty="0">
-                <a:solidFill>
-                  <a:srgbClr val="758198"/>
-                </a:solidFill>
-                <a:latin typeface="Aptos" pitchFamily="34" charset="0"/>
-                <a:ea typeface="Aptos" pitchFamily="34" charset="-122"/>
-                <a:cs typeface="Aptos" pitchFamily="34" charset="-120"/>
-              </a:rPr>
-              <a:t>Photo</a:t>
-            </a:r>
-            <a:endParaRPr lang="en-US" sz="900" dirty="0"/>
+            <a:endParaRPr kumimoji="0" lang="en-IE" sz="1800" b="0" i="0" u="none" strike="noStrike" kern="1200" cap="none" spc="0" normalizeH="0" baseline="0" noProof="0">
+              <a:ln>
+                <a:noFill/>
+              </a:ln>
+              <a:solidFill>
+                <a:prstClr val="black"/>
+              </a:solidFill>
+              <a:effectLst/>
+              <a:uLnTx/>
+              <a:uFillTx/>
+              <a:latin typeface="Aptos"/>
+              <a:ea typeface="+mn-ea"/>
+              <a:cs typeface="+mn-cs"/>
+            </a:endParaRPr>
           </a:p>
         </p:txBody>
       </p:sp>
@@ -1943,8 +2718,8 @@
         </p:nvSpPr>
         <p:spPr>
           <a:xfrm>
-            <a:off x="5641848" y="2679192"/>
-            <a:ext cx="1481328" cy="228600"/>
+            <a:off x="5850903" y="2368296"/>
+            <a:ext cx="1812001" cy="621791"/>
           </a:xfrm>
           <a:prstGeom prst="rect">
             <a:avLst/>
@@ -1954,25 +2729,58 @@
         </p:spPr>
         <p:txBody>
           <a:bodyPr wrap="square" lIns="254" tIns="254" rIns="254" bIns="254" rtlCol="0" anchor="ctr">
-            <a:normAutofit lnSpcReduction="10000"/>
+            <a:noAutofit/>
           </a:bodyPr>
           <a:lstStyle/>
           <a:p>
-            <a:pPr marL="0" indent="0" algn="l">
+            <a:pPr marL="0" marR="0" lvl="0" indent="0" algn="ctr" defTabSz="914400" rtl="0" eaLnBrk="1" fontAlgn="auto" latinLnBrk="0" hangingPunct="1">
+              <a:lnSpc>
+                <a:spcPct val="100000"/>
+              </a:lnSpc>
+              <a:spcBef>
+                <a:spcPts val="0"/>
+              </a:spcBef>
+              <a:spcAft>
+                <a:spcPts val="0"/>
+              </a:spcAft>
+              <a:buClrTx/>
+              <a:buSzTx/>
+              <a:buFontTx/>
               <a:buNone/>
+              <a:tabLst/>
+              <a:defRPr/>
             </a:pPr>
             <a:r>
-              <a:rPr lang="en-US" sz="1600" b="1" dirty="0">
+              <a:rPr kumimoji="0" lang="en-US" sz="2400" b="1" i="0" u="none" strike="noStrike" kern="1200" cap="none" spc="0" normalizeH="0" baseline="0" noProof="0" dirty="0">
+                <a:ln>
+                  <a:noFill/>
+                </a:ln>
                 <a:solidFill>
                   <a:srgbClr val="143A9D"/>
                 </a:solidFill>
+                <a:effectLst/>
+                <a:uLnTx/>
+                <a:uFillTx/>
                 <a:latin typeface="Aptos" pitchFamily="34" charset="0"/>
                 <a:ea typeface="Aptos" pitchFamily="34" charset="-122"/>
                 <a:cs typeface="Aptos" pitchFamily="34" charset="-120"/>
               </a:rPr>
               <a:t>Hanna Bokariuk</a:t>
             </a:r>
-            <a:endParaRPr lang="en-US" sz="1600" dirty="0"/>
+            <a:endParaRPr kumimoji="0" lang="en-US" sz="2400" b="0" i="0" u="none" strike="noStrike" kern="1200" cap="none" spc="0" normalizeH="0" baseline="0" noProof="0" dirty="0">
+              <a:ln>
+                <a:noFill/>
+              </a:ln>
+              <a:solidFill>
+                <a:prstClr val="black"/>
+              </a:solidFill>
+              <a:effectLst/>
+              <a:uLnTx/>
+              <a:uFillTx/>
+              <a:latin typeface="Aptos"/>
+              <a:ea typeface="+mn-ea"/>
+              <a:cs typeface="+mn-cs"/>
+            </a:endParaRPr>
           </a:p>
         </p:txBody>
       </p:sp>
@@ -1984,8 +2792,8 @@
         </p:nvSpPr>
         <p:spPr>
           <a:xfrm>
-            <a:off x="5641848" y="3044952"/>
-            <a:ext cx="1481328" cy="365760"/>
+            <a:off x="5985597" y="3293503"/>
+            <a:ext cx="1781381" cy="365759"/>
           </a:xfrm>
           <a:prstGeom prst="rect">
             <a:avLst/>
@@ -1995,25 +2803,92 @@
         </p:spPr>
         <p:txBody>
           <a:bodyPr wrap="square" lIns="254" tIns="254" rIns="254" bIns="254" rtlCol="0" anchor="ctr">
-            <a:normAutofit/>
+            <a:noAutofit/>
           </a:bodyPr>
           <a:lstStyle/>
           <a:p>
-            <a:pPr marL="0" indent="0" algn="l">
+            <a:pPr marL="0" marR="0" lvl="0" indent="0" algn="l" defTabSz="914400" rtl="0" eaLnBrk="1" fontAlgn="auto" latinLnBrk="0" hangingPunct="1">
+              <a:lnSpc>
+                <a:spcPct val="100000"/>
+              </a:lnSpc>
+              <a:spcBef>
+                <a:spcPts val="0"/>
+              </a:spcBef>
+              <a:spcAft>
+                <a:spcPts val="0"/>
+              </a:spcAft>
+              <a:buClrTx/>
+              <a:buSzTx/>
+              <a:buFontTx/>
               <a:buNone/>
+              <a:tabLst/>
+              <a:defRPr/>
             </a:pPr>
             <a:r>
-              <a:rPr lang="en-US" sz="1230" dirty="0">
+              <a:rPr kumimoji="0" lang="en-US" sz="1400" b="0" i="0" u="none" strike="noStrike" kern="1200" cap="none" spc="0" normalizeH="0" baseline="0" noProof="0" dirty="0">
+                <a:ln>
+                  <a:noFill/>
+                </a:ln>
                 <a:solidFill>
                   <a:srgbClr val="53617A"/>
                 </a:solidFill>
+                <a:effectLst/>
+                <a:uLnTx/>
+                <a:uFillTx/>
                 <a:latin typeface="Aptos" pitchFamily="34" charset="0"/>
                 <a:ea typeface="Aptos" pitchFamily="34" charset="-122"/>
                 <a:cs typeface="Aptos" pitchFamily="34" charset="-120"/>
               </a:rPr>
-              <a:t>UI/UX/UD, Hardware</a:t>
+              <a:t>Hardware</a:t>
             </a:r>
-            <a:endParaRPr lang="en-US" sz="1230" dirty="0"/>
+            <a:r>
+              <a:rPr kumimoji="0" lang="ru-RU" sz="1400" b="0" i="0" u="none" strike="noStrike" kern="1200" cap="none" spc="0" normalizeH="0" baseline="0" noProof="0" dirty="0">
+                <a:ln>
+                  <a:noFill/>
+                </a:ln>
+                <a:solidFill>
+                  <a:srgbClr val="53617A"/>
+                </a:solidFill>
+                <a:effectLst/>
+                <a:uLnTx/>
+                <a:uFillTx/>
+                <a:latin typeface="Aptos" pitchFamily="34" charset="0"/>
+                <a:ea typeface="Aptos" pitchFamily="34" charset="-122"/>
+                <a:cs typeface="Aptos" pitchFamily="34" charset="-120"/>
+              </a:rPr>
+              <a:t>,  </a:t>
+            </a:r>
+            <a:r>
+              <a:rPr kumimoji="0" lang="en-US" sz="1400" b="0" i="0" u="none" strike="noStrike" kern="1200" cap="none" spc="0" normalizeH="0" baseline="0" noProof="0" dirty="0">
+                <a:ln>
+                  <a:noFill/>
+                </a:ln>
+                <a:solidFill>
+                  <a:srgbClr val="53617A"/>
+                </a:solidFill>
+                <a:effectLst/>
+                <a:uLnTx/>
+                <a:uFillTx/>
+                <a:latin typeface="Aptos" pitchFamily="34" charset="0"/>
+                <a:ea typeface="Aptos" pitchFamily="34" charset="-122"/>
+                <a:cs typeface="Aptos" pitchFamily="34" charset="-120"/>
+              </a:rPr>
+              <a:t>UI/UX/UD</a:t>
+            </a:r>
+            <a:endParaRPr kumimoji="0" lang="en-US" sz="1400" b="0" i="0" u="none" strike="noStrike" kern="1200" cap="none" spc="0" normalizeH="0" baseline="0" noProof="0" dirty="0">
+              <a:ln>
+                <a:noFill/>
+              </a:ln>
+              <a:solidFill>
+                <a:prstClr val="black"/>
+              </a:solidFill>
+              <a:effectLst/>
+              <a:uLnTx/>
+              <a:uFillTx/>
+              <a:latin typeface="Aptos"/>
+              <a:ea typeface="+mn-ea"/>
+              <a:cs typeface="+mn-cs"/>
+            </a:endParaRPr>
           </a:p>
         </p:txBody>
       </p:sp>
@@ -2024,9 +2899,9 @@
           <p:nvPr/>
         </p:nvSpPr>
         <p:spPr>
-          <a:xfrm>
-            <a:off x="4398264" y="3849624"/>
-            <a:ext cx="2679192" cy="0"/>
+          <a:xfrm flipV="1">
+            <a:off x="4480559" y="3878650"/>
+            <a:ext cx="2980667" cy="4798"/>
           </a:xfrm>
           <a:prstGeom prst="line">
             <a:avLst/>
@@ -2043,7 +2918,37 @@
           <a:bodyPr/>
           <a:lstStyle/>
           <a:p>
-            <a:endParaRPr lang="en-IE"/>
+            <a:pPr marL="0" marR="0" lvl="0" indent="0" algn="l" defTabSz="914400" rtl="0" eaLnBrk="1" fontAlgn="auto" latinLnBrk="0" hangingPunct="1">
+              <a:lnSpc>
+                <a:spcPct val="100000"/>
+              </a:lnSpc>
+              <a:spcBef>
+                <a:spcPts val="0"/>
+              </a:spcBef>
+              <a:spcAft>
+                <a:spcPts val="0"/>
+              </a:spcAft>
+              <a:buClrTx/>
+              <a:buSzTx/>
+              <a:buFontTx/>
+              <a:buNone/>
+              <a:tabLst/>
+              <a:defRPr/>
+            </a:pPr>
+            <a:endParaRPr kumimoji="0" lang="en-IE" sz="1800" b="0" i="0" u="none" strike="noStrike" kern="1200" cap="none" spc="0" normalizeH="0" baseline="0" noProof="0">
+              <a:ln>
+                <a:noFill/>
+              </a:ln>
+              <a:solidFill>
+                <a:prstClr val="black"/>
+              </a:solidFill>
+              <a:effectLst/>
+              <a:uLnTx/>
+              <a:uFillTx/>
+              <a:latin typeface="Aptos"/>
+              <a:ea typeface="+mn-ea"/>
+              <a:cs typeface="+mn-cs"/>
+            </a:endParaRPr>
           </a:p>
         </p:txBody>
       </p:sp>
@@ -2055,7 +2960,7 @@
         </p:nvSpPr>
         <p:spPr>
           <a:xfrm>
-            <a:off x="4416552" y="3959352"/>
+            <a:off x="4768596" y="3959352"/>
             <a:ext cx="2651760" cy="146304"/>
           </a:xfrm>
           <a:prstGeom prst="rect">
@@ -2066,25 +2971,58 @@
         </p:spPr>
         <p:txBody>
           <a:bodyPr wrap="square" lIns="254" tIns="254" rIns="254" bIns="254" rtlCol="0" anchor="ctr">
-            <a:normAutofit/>
+            <a:noAutofit/>
           </a:bodyPr>
           <a:lstStyle/>
           <a:p>
-            <a:pPr marL="0" indent="0" algn="ctr">
+            <a:pPr marL="0" marR="0" lvl="0" indent="0" algn="ctr" defTabSz="914400" rtl="0" eaLnBrk="1" fontAlgn="auto" latinLnBrk="0" hangingPunct="1">
+              <a:lnSpc>
+                <a:spcPct val="100000"/>
+              </a:lnSpc>
+              <a:spcBef>
+                <a:spcPts val="0"/>
+              </a:spcBef>
+              <a:spcAft>
+                <a:spcPts val="0"/>
+              </a:spcAft>
+              <a:buClrTx/>
+              <a:buSzTx/>
+              <a:buFontTx/>
               <a:buNone/>
+              <a:tabLst/>
+              <a:defRPr/>
             </a:pPr>
             <a:r>
-              <a:rPr lang="en-US" sz="880" dirty="0">
+              <a:rPr kumimoji="0" lang="en-US" sz="1200" b="0" i="0" u="none" strike="noStrike" kern="1200" cap="none" spc="0" normalizeH="0" baseline="0" noProof="0" dirty="0">
+                <a:ln>
+                  <a:noFill/>
+                </a:ln>
                 <a:solidFill>
                   <a:srgbClr val="758198"/>
                 </a:solidFill>
+                <a:effectLst/>
+                <a:uLnTx/>
+                <a:uFillTx/>
                 <a:latin typeface="Aptos" pitchFamily="34" charset="0"/>
                 <a:ea typeface="Aptos" pitchFamily="34" charset="-122"/>
                 <a:cs typeface="Aptos" pitchFamily="34" charset="-120"/>
               </a:rPr>
               <a:t>Team member 2</a:t>
             </a:r>
-            <a:endParaRPr lang="en-US" sz="880" dirty="0"/>
+            <a:endParaRPr kumimoji="0" lang="en-US" sz="1200" b="0" i="0" u="none" strike="noStrike" kern="1200" cap="none" spc="0" normalizeH="0" baseline="0" noProof="0" dirty="0">
+              <a:ln>
+                <a:noFill/>
+              </a:ln>
+              <a:solidFill>
+                <a:prstClr val="black"/>
+              </a:solidFill>
+              <a:effectLst/>
+              <a:uLnTx/>
+              <a:uFillTx/>
+              <a:latin typeface="Aptos"/>
+              <a:ea typeface="+mn-ea"/>
+              <a:cs typeface="+mn-cs"/>
+            </a:endParaRPr>
           </a:p>
         </p:txBody>
       </p:sp>
@@ -2096,8 +3034,8 @@
         </p:nvSpPr>
         <p:spPr>
           <a:xfrm>
-            <a:off x="7607808" y="2240280"/>
-            <a:ext cx="3154680" cy="1965960"/>
+            <a:off x="7844964" y="1772436"/>
+            <a:ext cx="3651538" cy="2473452"/>
           </a:xfrm>
           <a:prstGeom prst="roundRect">
             <a:avLst>
@@ -2125,7 +3063,37 @@
           <a:bodyPr/>
           <a:lstStyle/>
           <a:p>
-            <a:endParaRPr lang="en-IE"/>
+            <a:pPr marL="0" marR="0" lvl="0" indent="0" algn="l" defTabSz="914400" rtl="0" eaLnBrk="1" fontAlgn="auto" latinLnBrk="0" hangingPunct="1">
+              <a:lnSpc>
+                <a:spcPct val="100000"/>
+              </a:lnSpc>
+              <a:spcBef>
+                <a:spcPts val="0"/>
+              </a:spcBef>
+              <a:spcAft>
+                <a:spcPts val="0"/>
+              </a:spcAft>
+              <a:buClrTx/>
+              <a:buSzTx/>
+              <a:buFontTx/>
+              <a:buNone/>
+              <a:tabLst/>
+              <a:defRPr/>
+            </a:pPr>
+            <a:endParaRPr kumimoji="0" lang="en-IE" sz="1800" b="0" i="0" u="none" strike="noStrike" kern="1200" cap="none" spc="0" normalizeH="0" baseline="0" noProof="0">
+              <a:ln>
+                <a:noFill/>
+              </a:ln>
+              <a:solidFill>
+                <a:prstClr val="black"/>
+              </a:solidFill>
+              <a:effectLst/>
+              <a:uLnTx/>
+              <a:uFillTx/>
+              <a:latin typeface="Aptos"/>
+              <a:ea typeface="+mn-ea"/>
+              <a:cs typeface="+mn-cs"/>
+            </a:endParaRPr>
           </a:p>
         </p:txBody>
       </p:sp>
@@ -2137,8 +3105,8 @@
         </p:nvSpPr>
         <p:spPr>
           <a:xfrm>
-            <a:off x="7863840" y="2496312"/>
-            <a:ext cx="1078992" cy="1078992"/>
+            <a:off x="7881466" y="1814970"/>
+            <a:ext cx="1481329" cy="1984087"/>
           </a:xfrm>
           <a:prstGeom prst="ellipse">
             <a:avLst/>
@@ -2157,20 +3125,50 @@
           <a:bodyPr/>
           <a:lstStyle/>
           <a:p>
-            <a:endParaRPr lang="en-IE"/>
+            <a:pPr marL="0" marR="0" lvl="0" indent="0" algn="l" defTabSz="914400" rtl="0" eaLnBrk="1" fontAlgn="auto" latinLnBrk="0" hangingPunct="1">
+              <a:lnSpc>
+                <a:spcPct val="100000"/>
+              </a:lnSpc>
+              <a:spcBef>
+                <a:spcPts val="0"/>
+              </a:spcBef>
+              <a:spcAft>
+                <a:spcPts val="0"/>
+              </a:spcAft>
+              <a:buClrTx/>
+              <a:buSzTx/>
+              <a:buFontTx/>
+              <a:buNone/>
+              <a:tabLst/>
+              <a:defRPr/>
+            </a:pPr>
+            <a:endParaRPr kumimoji="0" lang="en-IE" sz="1800" b="0" i="0" u="none" strike="noStrike" kern="1200" cap="none" spc="0" normalizeH="0" baseline="0" noProof="0">
+              <a:ln>
+                <a:noFill/>
+              </a:ln>
+              <a:solidFill>
+                <a:prstClr val="black"/>
+              </a:solidFill>
+              <a:effectLst/>
+              <a:uLnTx/>
+              <a:uFillTx/>
+              <a:latin typeface="Aptos"/>
+              <a:ea typeface="+mn-ea"/>
+              <a:cs typeface="+mn-cs"/>
+            </a:endParaRPr>
           </a:p>
         </p:txBody>
       </p:sp>
       <p:sp>
         <p:nvSpPr>
-          <p:cNvPr id="27" name="Text 25"/>
+          <p:cNvPr id="28" name="Text 26"/>
           <p:cNvSpPr/>
           <p:nvPr/>
         </p:nvSpPr>
         <p:spPr>
           <a:xfrm>
-            <a:off x="8101584" y="2862072"/>
-            <a:ext cx="594360" cy="146304"/>
+            <a:off x="9221723" y="2178591"/>
+            <a:ext cx="2018971" cy="1209226"/>
           </a:xfrm>
           <a:prstGeom prst="rect">
             <a:avLst/>
@@ -2184,62 +3182,54 @@
           </a:bodyPr>
           <a:lstStyle/>
           <a:p>
-            <a:pPr marL="0" indent="0" algn="ctr">
+            <a:pPr marL="457200" marR="0" lvl="1" indent="0" algn="ctr" defTabSz="914400" rtl="0" eaLnBrk="1" fontAlgn="auto" latinLnBrk="0" hangingPunct="1">
+              <a:lnSpc>
+                <a:spcPct val="100000"/>
+              </a:lnSpc>
+              <a:spcBef>
+                <a:spcPts val="0"/>
+              </a:spcBef>
+              <a:spcAft>
+                <a:spcPts val="0"/>
+              </a:spcAft>
+              <a:buClrTx/>
+              <a:buSzTx/>
+              <a:buFontTx/>
               <a:buNone/>
+              <a:tabLst/>
+              <a:defRPr/>
             </a:pPr>
             <a:r>
-              <a:rPr lang="en-US" sz="900" dirty="0">
-                <a:solidFill>
-                  <a:srgbClr val="758198"/>
-                </a:solidFill>
-                <a:latin typeface="Aptos" pitchFamily="34" charset="0"/>
-                <a:ea typeface="Aptos" pitchFamily="34" charset="-122"/>
-                <a:cs typeface="Aptos" pitchFamily="34" charset="-120"/>
-              </a:rPr>
-              <a:t>Photo</a:t>
-            </a:r>
-            <a:endParaRPr lang="en-US" sz="900" dirty="0"/>
-          </a:p>
-        </p:txBody>
-      </p:sp>
-      <p:sp>
-        <p:nvSpPr>
-          <p:cNvPr id="28" name="Text 26"/>
-          <p:cNvSpPr/>
-          <p:nvPr/>
-        </p:nvSpPr>
-        <p:spPr>
-          <a:xfrm>
-            <a:off x="9089136" y="2679192"/>
-            <a:ext cx="1481328" cy="228600"/>
-          </a:xfrm>
-          <a:prstGeom prst="rect">
-            <a:avLst/>
-          </a:prstGeom>
-          <a:noFill/>
-          <a:ln/>
-        </p:spPr>
-        <p:txBody>
-          <a:bodyPr wrap="square" lIns="254" tIns="254" rIns="254" bIns="254" rtlCol="0" anchor="ctr">
-            <a:normAutofit fontScale="77500" lnSpcReduction="20000"/>
-          </a:bodyPr>
-          <a:lstStyle/>
-          <a:p>
-            <a:pPr marL="0" indent="0" algn="l">
-              <a:buNone/>
-            </a:pPr>
-            <a:r>
-              <a:rPr lang="en-US" sz="1600" b="1" dirty="0">
+              <a:rPr kumimoji="0" lang="en-US" sz="2400" b="1" i="0" u="none" strike="noStrike" kern="1200" cap="none" spc="0" normalizeH="0" baseline="0" noProof="0" dirty="0">
+                <a:ln>
+                  <a:noFill/>
+                </a:ln>
                 <a:solidFill>
                   <a:srgbClr val="143A9D"/>
                 </a:solidFill>
+                <a:effectLst/>
+                <a:uLnTx/>
+                <a:uFillTx/>
                 <a:latin typeface="Aptos" pitchFamily="34" charset="0"/>
                 <a:ea typeface="Aptos" pitchFamily="34" charset="-122"/>
                 <a:cs typeface="Aptos" pitchFamily="34" charset="-120"/>
               </a:rPr>
               <a:t>Maryna Hordiienko</a:t>
             </a:r>
-            <a:endParaRPr lang="en-US" sz="1600" dirty="0"/>
+            <a:endParaRPr kumimoji="0" lang="en-US" sz="2400" b="0" i="0" u="none" strike="noStrike" kern="1200" cap="none" spc="0" normalizeH="0" baseline="0" noProof="0" dirty="0">
+              <a:ln>
+                <a:noFill/>
+              </a:ln>
+              <a:solidFill>
+                <a:prstClr val="black"/>
+              </a:solidFill>
+              <a:effectLst/>
+              <a:uLnTx/>
+              <a:uFillTx/>
+              <a:latin typeface="Aptos"/>
+              <a:ea typeface="+mn-ea"/>
+              <a:cs typeface="+mn-cs"/>
+            </a:endParaRPr>
           </a:p>
         </p:txBody>
       </p:sp>
@@ -2251,8 +3241,8 @@
         </p:nvSpPr>
         <p:spPr>
           <a:xfrm>
-            <a:off x="9089136" y="3044952"/>
-            <a:ext cx="1481328" cy="365760"/>
+            <a:off x="9592056" y="3318614"/>
+            <a:ext cx="1883664" cy="365760"/>
           </a:xfrm>
           <a:prstGeom prst="rect">
             <a:avLst/>
@@ -2262,25 +3252,58 @@
         </p:spPr>
         <p:txBody>
           <a:bodyPr wrap="square" lIns="254" tIns="254" rIns="254" bIns="254" rtlCol="0" anchor="ctr">
-            <a:normAutofit/>
+            <a:noAutofit/>
           </a:bodyPr>
           <a:lstStyle/>
           <a:p>
-            <a:pPr marL="0" indent="0" algn="l">
+            <a:pPr marL="0" marR="0" lvl="0" indent="0" algn="l" defTabSz="914400" rtl="0" eaLnBrk="1" fontAlgn="auto" latinLnBrk="0" hangingPunct="1">
+              <a:lnSpc>
+                <a:spcPct val="100000"/>
+              </a:lnSpc>
+              <a:spcBef>
+                <a:spcPts val="0"/>
+              </a:spcBef>
+              <a:spcAft>
+                <a:spcPts val="0"/>
+              </a:spcAft>
+              <a:buClrTx/>
+              <a:buSzTx/>
+              <a:buFontTx/>
               <a:buNone/>
+              <a:tabLst/>
+              <a:defRPr/>
             </a:pPr>
             <a:r>
-              <a:rPr lang="en-US" sz="1230" dirty="0">
+              <a:rPr kumimoji="0" lang="en-US" sz="1400" b="0" i="0" u="none" strike="noStrike" kern="1200" cap="none" spc="0" normalizeH="0" baseline="0" noProof="0" dirty="0">
+                <a:ln>
+                  <a:noFill/>
+                </a:ln>
                 <a:solidFill>
                   <a:srgbClr val="53617A"/>
                 </a:solidFill>
+                <a:effectLst/>
+                <a:uLnTx/>
+                <a:uFillTx/>
                 <a:latin typeface="Aptos" pitchFamily="34" charset="0"/>
                 <a:ea typeface="Aptos" pitchFamily="34" charset="-122"/>
                 <a:cs typeface="Aptos" pitchFamily="34" charset="-120"/>
               </a:rPr>
               <a:t>Front-End, UI/UX/UD</a:t>
             </a:r>
-            <a:endParaRPr lang="en-US" sz="1230" dirty="0"/>
+            <a:endParaRPr kumimoji="0" lang="en-US" sz="1400" b="0" i="0" u="none" strike="noStrike" kern="1200" cap="none" spc="0" normalizeH="0" baseline="0" noProof="0" dirty="0">
+              <a:ln>
+                <a:noFill/>
+              </a:ln>
+              <a:solidFill>
+                <a:prstClr val="black"/>
+              </a:solidFill>
+              <a:effectLst/>
+              <a:uLnTx/>
+              <a:uFillTx/>
+              <a:latin typeface="Aptos"/>
+              <a:ea typeface="+mn-ea"/>
+              <a:cs typeface="+mn-cs"/>
+            </a:endParaRPr>
           </a:p>
         </p:txBody>
       </p:sp>
@@ -2292,8 +3315,8 @@
         </p:nvSpPr>
         <p:spPr>
           <a:xfrm>
-            <a:off x="7845552" y="3849624"/>
-            <a:ext cx="2679192" cy="0"/>
+            <a:off x="7903031" y="3864067"/>
+            <a:ext cx="3493839" cy="29026"/>
           </a:xfrm>
           <a:prstGeom prst="line">
             <a:avLst/>
@@ -2310,7 +3333,37 @@
           <a:bodyPr/>
           <a:lstStyle/>
           <a:p>
-            <a:endParaRPr lang="en-IE"/>
+            <a:pPr marL="0" marR="0" lvl="0" indent="0" algn="l" defTabSz="914400" rtl="0" eaLnBrk="1" fontAlgn="auto" latinLnBrk="0" hangingPunct="1">
+              <a:lnSpc>
+                <a:spcPct val="100000"/>
+              </a:lnSpc>
+              <a:spcBef>
+                <a:spcPts val="0"/>
+              </a:spcBef>
+              <a:spcAft>
+                <a:spcPts val="0"/>
+              </a:spcAft>
+              <a:buClrTx/>
+              <a:buSzTx/>
+              <a:buFontTx/>
+              <a:buNone/>
+              <a:tabLst/>
+              <a:defRPr/>
+            </a:pPr>
+            <a:endParaRPr kumimoji="0" lang="en-IE" sz="1800" b="0" i="0" u="none" strike="noStrike" kern="1200" cap="none" spc="0" normalizeH="0" baseline="0" noProof="0">
+              <a:ln>
+                <a:noFill/>
+              </a:ln>
+              <a:solidFill>
+                <a:prstClr val="black"/>
+              </a:solidFill>
+              <a:effectLst/>
+              <a:uLnTx/>
+              <a:uFillTx/>
+              <a:latin typeface="Aptos"/>
+              <a:ea typeface="+mn-ea"/>
+              <a:cs typeface="+mn-cs"/>
+            </a:endParaRPr>
           </a:p>
         </p:txBody>
       </p:sp>
@@ -2322,8 +3375,8 @@
         </p:nvSpPr>
         <p:spPr>
           <a:xfrm>
-            <a:off x="7863840" y="3959352"/>
-            <a:ext cx="2651760" cy="146304"/>
+            <a:off x="7844964" y="3956513"/>
+            <a:ext cx="3533030" cy="175987"/>
           </a:xfrm>
           <a:prstGeom prst="rect">
             <a:avLst/>
@@ -2333,25 +3386,58 @@
         </p:spPr>
         <p:txBody>
           <a:bodyPr wrap="square" lIns="254" tIns="254" rIns="254" bIns="254" rtlCol="0" anchor="ctr">
-            <a:normAutofit/>
+            <a:noAutofit/>
           </a:bodyPr>
           <a:lstStyle/>
           <a:p>
-            <a:pPr marL="0" indent="0" algn="ctr">
+            <a:pPr marL="0" marR="0" lvl="0" indent="0" algn="ctr" defTabSz="914400" rtl="0" eaLnBrk="1" fontAlgn="auto" latinLnBrk="0" hangingPunct="1">
+              <a:lnSpc>
+                <a:spcPct val="100000"/>
+              </a:lnSpc>
+              <a:spcBef>
+                <a:spcPts val="0"/>
+              </a:spcBef>
+              <a:spcAft>
+                <a:spcPts val="0"/>
+              </a:spcAft>
+              <a:buClrTx/>
+              <a:buSzTx/>
+              <a:buFontTx/>
               <a:buNone/>
+              <a:tabLst/>
+              <a:defRPr/>
             </a:pPr>
             <a:r>
-              <a:rPr lang="en-US" sz="880" dirty="0">
+              <a:rPr kumimoji="0" lang="en-US" sz="1200" b="0" i="0" u="none" strike="noStrike" kern="1200" cap="none" spc="0" normalizeH="0" baseline="0" noProof="0" dirty="0">
+                <a:ln>
+                  <a:noFill/>
+                </a:ln>
                 <a:solidFill>
                   <a:srgbClr val="758198"/>
                 </a:solidFill>
+                <a:effectLst/>
+                <a:uLnTx/>
+                <a:uFillTx/>
                 <a:latin typeface="Aptos" pitchFamily="34" charset="0"/>
                 <a:ea typeface="Aptos" pitchFamily="34" charset="-122"/>
                 <a:cs typeface="Aptos" pitchFamily="34" charset="-120"/>
               </a:rPr>
               <a:t>Team member 3</a:t>
             </a:r>
-            <a:endParaRPr lang="en-US" sz="880" dirty="0"/>
+            <a:endParaRPr kumimoji="0" lang="en-US" sz="1200" b="0" i="0" u="none" strike="noStrike" kern="1200" cap="none" spc="0" normalizeH="0" baseline="0" noProof="0" dirty="0">
+              <a:ln>
+                <a:noFill/>
+              </a:ln>
+              <a:solidFill>
+                <a:prstClr val="black"/>
+              </a:solidFill>
+              <a:effectLst/>
+              <a:uLnTx/>
+              <a:uFillTx/>
+              <a:latin typeface="Aptos"/>
+              <a:ea typeface="+mn-ea"/>
+              <a:cs typeface="+mn-cs"/>
+            </a:endParaRPr>
           </a:p>
         </p:txBody>
       </p:sp>
@@ -2392,7 +3478,37 @@
           <a:bodyPr/>
           <a:lstStyle/>
           <a:p>
-            <a:endParaRPr lang="en-IE"/>
+            <a:pPr marL="0" marR="0" lvl="0" indent="0" algn="l" defTabSz="914400" rtl="0" eaLnBrk="1" fontAlgn="auto" latinLnBrk="0" hangingPunct="1">
+              <a:lnSpc>
+                <a:spcPct val="100000"/>
+              </a:lnSpc>
+              <a:spcBef>
+                <a:spcPts val="0"/>
+              </a:spcBef>
+              <a:spcAft>
+                <a:spcPts val="0"/>
+              </a:spcAft>
+              <a:buClrTx/>
+              <a:buSzTx/>
+              <a:buFontTx/>
+              <a:buNone/>
+              <a:tabLst/>
+              <a:defRPr/>
+            </a:pPr>
+            <a:endParaRPr kumimoji="0" lang="en-IE" sz="1800" b="0" i="0" u="none" strike="noStrike" kern="1200" cap="none" spc="0" normalizeH="0" baseline="0" noProof="0">
+              <a:ln>
+                <a:noFill/>
+              </a:ln>
+              <a:solidFill>
+                <a:prstClr val="black"/>
+              </a:solidFill>
+              <a:effectLst/>
+              <a:uLnTx/>
+              <a:uFillTx/>
+              <a:latin typeface="Aptos"/>
+              <a:ea typeface="+mn-ea"/>
+              <a:cs typeface="+mn-cs"/>
+            </a:endParaRPr>
           </a:p>
         </p:txBody>
       </p:sp>
@@ -2422,7 +3538,37 @@
           <a:bodyPr/>
           <a:lstStyle/>
           <a:p>
-            <a:endParaRPr lang="en-IE"/>
+            <a:pPr marL="0" marR="0" lvl="0" indent="0" algn="l" defTabSz="914400" rtl="0" eaLnBrk="1" fontAlgn="auto" latinLnBrk="0" hangingPunct="1">
+              <a:lnSpc>
+                <a:spcPct val="100000"/>
+              </a:lnSpc>
+              <a:spcBef>
+                <a:spcPts val="0"/>
+              </a:spcBef>
+              <a:spcAft>
+                <a:spcPts val="0"/>
+              </a:spcAft>
+              <a:buClrTx/>
+              <a:buSzTx/>
+              <a:buFontTx/>
+              <a:buNone/>
+              <a:tabLst/>
+              <a:defRPr/>
+            </a:pPr>
+            <a:endParaRPr kumimoji="0" lang="en-IE" sz="1800" b="0" i="0" u="none" strike="noStrike" kern="1200" cap="none" spc="0" normalizeH="0" baseline="0" noProof="0">
+              <a:ln>
+                <a:noFill/>
+              </a:ln>
+              <a:solidFill>
+                <a:prstClr val="black"/>
+              </a:solidFill>
+              <a:effectLst/>
+              <a:uLnTx/>
+              <a:uFillTx/>
+              <a:latin typeface="Aptos"/>
+              <a:ea typeface="+mn-ea"/>
+              <a:cs typeface="+mn-cs"/>
+            </a:endParaRPr>
           </a:p>
         </p:txBody>
       </p:sp>
@@ -2452,7 +3598,37 @@
           <a:bodyPr/>
           <a:lstStyle/>
           <a:p>
-            <a:endParaRPr lang="en-IE"/>
+            <a:pPr marL="0" marR="0" lvl="0" indent="0" algn="l" defTabSz="914400" rtl="0" eaLnBrk="1" fontAlgn="auto" latinLnBrk="0" hangingPunct="1">
+              <a:lnSpc>
+                <a:spcPct val="100000"/>
+              </a:lnSpc>
+              <a:spcBef>
+                <a:spcPts val="0"/>
+              </a:spcBef>
+              <a:spcAft>
+                <a:spcPts val="0"/>
+              </a:spcAft>
+              <a:buClrTx/>
+              <a:buSzTx/>
+              <a:buFontTx/>
+              <a:buNone/>
+              <a:tabLst/>
+              <a:defRPr/>
+            </a:pPr>
+            <a:endParaRPr kumimoji="0" lang="en-IE" sz="1800" b="0" i="0" u="none" strike="noStrike" kern="1200" cap="none" spc="0" normalizeH="0" baseline="0" noProof="0">
+              <a:ln>
+                <a:noFill/>
+              </a:ln>
+              <a:solidFill>
+                <a:prstClr val="black"/>
+              </a:solidFill>
+              <a:effectLst/>
+              <a:uLnTx/>
+              <a:uFillTx/>
+              <a:latin typeface="Aptos"/>
+              <a:ea typeface="+mn-ea"/>
+              <a:cs typeface="+mn-cs"/>
+            </a:endParaRPr>
           </a:p>
         </p:txBody>
       </p:sp>
@@ -2479,21 +3655,54 @@
           </a:bodyPr>
           <a:lstStyle/>
           <a:p>
-            <a:pPr marL="0" indent="0" algn="l">
+            <a:pPr marL="0" marR="0" lvl="0" indent="0" algn="l" defTabSz="914400" rtl="0" eaLnBrk="1" fontAlgn="auto" latinLnBrk="0" hangingPunct="1">
+              <a:lnSpc>
+                <a:spcPct val="100000"/>
+              </a:lnSpc>
+              <a:spcBef>
+                <a:spcPts val="0"/>
+              </a:spcBef>
+              <a:spcAft>
+                <a:spcPts val="0"/>
+              </a:spcAft>
+              <a:buClrTx/>
+              <a:buSzTx/>
+              <a:buFontTx/>
               <a:buNone/>
+              <a:tabLst/>
+              <a:defRPr/>
             </a:pPr>
             <a:r>
-              <a:rPr lang="en-US" sz="900" b="1" dirty="0">
+              <a:rPr kumimoji="0" lang="en-US" sz="900" b="1" i="0" u="none" strike="noStrike" kern="1200" cap="none" spc="0" normalizeH="0" baseline="0" noProof="0" dirty="0">
+                <a:ln>
+                  <a:noFill/>
+                </a:ln>
                 <a:solidFill>
                   <a:srgbClr val="758198"/>
                 </a:solidFill>
+                <a:effectLst/>
+                <a:uLnTx/>
+                <a:uFillTx/>
                 <a:latin typeface="Aptos" pitchFamily="34" charset="0"/>
                 <a:ea typeface="Aptos" pitchFamily="34" charset="-122"/>
                 <a:cs typeface="Aptos" pitchFamily="34" charset="-120"/>
               </a:rPr>
               <a:t>GROUP</a:t>
             </a:r>
-            <a:endParaRPr lang="en-US" sz="900" dirty="0"/>
+            <a:endParaRPr kumimoji="0" lang="en-US" sz="900" b="0" i="0" u="none" strike="noStrike" kern="1200" cap="none" spc="0" normalizeH="0" baseline="0" noProof="0" dirty="0">
+              <a:ln>
+                <a:noFill/>
+              </a:ln>
+              <a:solidFill>
+                <a:prstClr val="black"/>
+              </a:solidFill>
+              <a:effectLst/>
+              <a:uLnTx/>
+              <a:uFillTx/>
+              <a:latin typeface="Aptos"/>
+              <a:ea typeface="+mn-ea"/>
+              <a:cs typeface="+mn-cs"/>
+            </a:endParaRPr>
           </a:p>
         </p:txBody>
       </p:sp>
@@ -2520,19 +3729,54 @@
           </a:bodyPr>
           <a:lstStyle/>
           <a:p>
-            <a:pPr marL="0" indent="0" algn="l">
+            <a:pPr marL="0" marR="0" lvl="0" indent="0" algn="l" defTabSz="914400" rtl="0" eaLnBrk="1" fontAlgn="auto" latinLnBrk="0" hangingPunct="1">
+              <a:lnSpc>
+                <a:spcPct val="100000"/>
+              </a:lnSpc>
+              <a:spcBef>
+                <a:spcPts val="0"/>
+              </a:spcBef>
+              <a:spcAft>
+                <a:spcPts val="0"/>
+              </a:spcAft>
+              <a:buClrTx/>
+              <a:buSzTx/>
+              <a:buFontTx/>
               <a:buNone/>
+              <a:tabLst/>
+              <a:defRPr/>
             </a:pPr>
             <a:r>
-              <a:rPr lang="en-IE" sz="1600" dirty="0">
+              <a:rPr kumimoji="0" lang="en-IE" sz="1600" b="0" i="0" u="none" strike="noStrike" kern="1200" cap="none" spc="0" normalizeH="0" baseline="0" noProof="0" dirty="0">
+                <a:ln>
+                  <a:noFill/>
+                </a:ln>
                 <a:solidFill>
                   <a:srgbClr val="53617A"/>
                 </a:solidFill>
+                <a:effectLst/>
+                <a:uLnTx/>
+                <a:uFillTx/>
                 <a:latin typeface="Aptos" pitchFamily="34" charset="0"/>
+                <a:ea typeface="+mn-ea"/>
+                <a:cs typeface="+mn-cs"/>
               </a:rPr>
               <a:t>Sd3a</a:t>
             </a:r>
-            <a:endParaRPr lang="en-US" sz="1600" dirty="0"/>
+            <a:endParaRPr kumimoji="0" lang="en-US" sz="1600" b="0" i="0" u="none" strike="noStrike" kern="1200" cap="none" spc="0" normalizeH="0" baseline="0" noProof="0" dirty="0">
+              <a:ln>
+                <a:noFill/>
+              </a:ln>
+              <a:solidFill>
+                <a:prstClr val="black"/>
+              </a:solidFill>
+              <a:effectLst/>
+              <a:uLnTx/>
+              <a:uFillTx/>
+              <a:latin typeface="Aptos"/>
+              <a:ea typeface="+mn-ea"/>
+              <a:cs typeface="+mn-cs"/>
+            </a:endParaRPr>
           </a:p>
         </p:txBody>
       </p:sp>
@@ -2559,21 +3803,54 @@
           </a:bodyPr>
           <a:lstStyle/>
           <a:p>
-            <a:pPr marL="0" indent="0" algn="l">
+            <a:pPr marL="0" marR="0" lvl="0" indent="0" algn="l" defTabSz="914400" rtl="0" eaLnBrk="1" fontAlgn="auto" latinLnBrk="0" hangingPunct="1">
+              <a:lnSpc>
+                <a:spcPct val="100000"/>
+              </a:lnSpc>
+              <a:spcBef>
+                <a:spcPts val="0"/>
+              </a:spcBef>
+              <a:spcAft>
+                <a:spcPts val="0"/>
+              </a:spcAft>
+              <a:buClrTx/>
+              <a:buSzTx/>
+              <a:buFontTx/>
               <a:buNone/>
+              <a:tabLst/>
+              <a:defRPr/>
             </a:pPr>
             <a:r>
-              <a:rPr lang="en-US" sz="900" b="1" dirty="0">
+              <a:rPr kumimoji="0" lang="en-US" sz="900" b="1" i="0" u="none" strike="noStrike" kern="1200" cap="none" spc="0" normalizeH="0" baseline="0" noProof="0" dirty="0">
+                <a:ln>
+                  <a:noFill/>
+                </a:ln>
                 <a:solidFill>
                   <a:srgbClr val="758198"/>
                 </a:solidFill>
+                <a:effectLst/>
+                <a:uLnTx/>
+                <a:uFillTx/>
                 <a:latin typeface="Aptos" pitchFamily="34" charset="0"/>
                 <a:ea typeface="Aptos" pitchFamily="34" charset="-122"/>
                 <a:cs typeface="Aptos" pitchFamily="34" charset="-120"/>
               </a:rPr>
               <a:t>COURSE</a:t>
             </a:r>
-            <a:endParaRPr lang="en-US" sz="900" dirty="0"/>
+            <a:endParaRPr kumimoji="0" lang="en-US" sz="900" b="0" i="0" u="none" strike="noStrike" kern="1200" cap="none" spc="0" normalizeH="0" baseline="0" noProof="0" dirty="0">
+              <a:ln>
+                <a:noFill/>
+              </a:ln>
+              <a:solidFill>
+                <a:prstClr val="black"/>
+              </a:solidFill>
+              <a:effectLst/>
+              <a:uLnTx/>
+              <a:uFillTx/>
+              <a:latin typeface="Aptos"/>
+              <a:ea typeface="+mn-ea"/>
+              <a:cs typeface="+mn-cs"/>
+            </a:endParaRPr>
           </a:p>
         </p:txBody>
       </p:sp>
@@ -2600,38 +3877,104 @@
           </a:bodyPr>
           <a:lstStyle/>
           <a:p>
-            <a:pPr marL="0" indent="0" algn="l">
+            <a:pPr marL="0" marR="0" lvl="0" indent="0" algn="l" defTabSz="914400" rtl="0" eaLnBrk="1" fontAlgn="auto" latinLnBrk="0" hangingPunct="1">
+              <a:lnSpc>
+                <a:spcPct val="100000"/>
+              </a:lnSpc>
+              <a:spcBef>
+                <a:spcPts val="0"/>
+              </a:spcBef>
+              <a:spcAft>
+                <a:spcPts val="0"/>
+              </a:spcAft>
+              <a:buClrTx/>
+              <a:buSzTx/>
+              <a:buFontTx/>
               <a:buNone/>
+              <a:tabLst/>
+              <a:defRPr/>
             </a:pPr>
             <a:r>
-              <a:rPr lang="en-US" sz="1340" dirty="0">
+              <a:rPr kumimoji="0" lang="en-US" sz="1340" b="0" i="0" u="none" strike="noStrike" kern="1200" cap="none" spc="0" normalizeH="0" baseline="0" noProof="0" dirty="0">
+                <a:ln>
+                  <a:noFill/>
+                </a:ln>
                 <a:solidFill>
                   <a:srgbClr val="53617A"/>
                 </a:solidFill>
+                <a:effectLst/>
+                <a:uLnTx/>
+                <a:uFillTx/>
                 <a:latin typeface="Aptos" pitchFamily="34" charset="0"/>
                 <a:ea typeface="Aptos" pitchFamily="34" charset="-122"/>
                 <a:cs typeface="Aptos" pitchFamily="34" charset="-120"/>
               </a:rPr>
               <a:t>BSc (Hons) Computing in</a:t>
             </a:r>
-            <a:endParaRPr lang="en-US" sz="1340" dirty="0"/>
+            <a:endParaRPr kumimoji="0" lang="en-US" sz="1340" b="0" i="0" u="none" strike="noStrike" kern="1200" cap="none" spc="0" normalizeH="0" baseline="0" noProof="0" dirty="0">
+              <a:ln>
+                <a:noFill/>
+              </a:ln>
+              <a:solidFill>
+                <a:prstClr val="black"/>
+              </a:solidFill>
+              <a:effectLst/>
+              <a:uLnTx/>
+              <a:uFillTx/>
+              <a:latin typeface="Aptos"/>
+              <a:ea typeface="+mn-ea"/>
+              <a:cs typeface="+mn-cs"/>
+            </a:endParaRPr>
           </a:p>
           <a:p>
-            <a:pPr marL="0" indent="0" algn="l">
+            <a:pPr marL="0" marR="0" lvl="0" indent="0" algn="l" defTabSz="914400" rtl="0" eaLnBrk="1" fontAlgn="auto" latinLnBrk="0" hangingPunct="1">
+              <a:lnSpc>
+                <a:spcPct val="100000"/>
+              </a:lnSpc>
+              <a:spcBef>
+                <a:spcPts val="0"/>
+              </a:spcBef>
+              <a:spcAft>
+                <a:spcPts val="0"/>
+              </a:spcAft>
+              <a:buClrTx/>
+              <a:buSzTx/>
+              <a:buFontTx/>
               <a:buNone/>
+              <a:tabLst/>
+              <a:defRPr/>
             </a:pPr>
             <a:r>
-              <a:rPr lang="en-US" sz="1340" dirty="0">
+              <a:rPr kumimoji="0" lang="en-US" sz="1340" b="0" i="0" u="none" strike="noStrike" kern="1200" cap="none" spc="0" normalizeH="0" baseline="0" noProof="0" dirty="0">
+                <a:ln>
+                  <a:noFill/>
+                </a:ln>
                 <a:solidFill>
                   <a:srgbClr val="53617A"/>
                 </a:solidFill>
+                <a:effectLst/>
+                <a:uLnTx/>
+                <a:uFillTx/>
                 <a:latin typeface="Aptos" pitchFamily="34" charset="0"/>
                 <a:ea typeface="Aptos" pitchFamily="34" charset="-122"/>
                 <a:cs typeface="Aptos" pitchFamily="34" charset="-120"/>
               </a:rPr>
               <a:t>Software Development</a:t>
             </a:r>
-            <a:endParaRPr lang="en-US" sz="1340" dirty="0"/>
+            <a:endParaRPr kumimoji="0" lang="en-US" sz="1340" b="0" i="0" u="none" strike="noStrike" kern="1200" cap="none" spc="0" normalizeH="0" baseline="0" noProof="0" dirty="0">
+              <a:ln>
+                <a:noFill/>
+              </a:ln>
+              <a:solidFill>
+                <a:prstClr val="black"/>
+              </a:solidFill>
+              <a:effectLst/>
+              <a:uLnTx/>
+              <a:uFillTx/>
+              <a:latin typeface="Aptos"/>
+              <a:ea typeface="+mn-ea"/>
+              <a:cs typeface="+mn-cs"/>
+            </a:endParaRPr>
           </a:p>
         </p:txBody>
       </p:sp>
@@ -2658,21 +4001,54 @@
           </a:bodyPr>
           <a:lstStyle/>
           <a:p>
-            <a:pPr marL="0" indent="0" algn="l">
+            <a:pPr marL="0" marR="0" lvl="0" indent="0" algn="l" defTabSz="914400" rtl="0" eaLnBrk="1" fontAlgn="auto" latinLnBrk="0" hangingPunct="1">
+              <a:lnSpc>
+                <a:spcPct val="100000"/>
+              </a:lnSpc>
+              <a:spcBef>
+                <a:spcPts val="0"/>
+              </a:spcBef>
+              <a:spcAft>
+                <a:spcPts val="0"/>
+              </a:spcAft>
+              <a:buClrTx/>
+              <a:buSzTx/>
+              <a:buFontTx/>
               <a:buNone/>
+              <a:tabLst/>
+              <a:defRPr/>
             </a:pPr>
             <a:r>
-              <a:rPr lang="en-US" sz="900" b="1" dirty="0">
+              <a:rPr kumimoji="0" lang="en-US" sz="900" b="1" i="0" u="none" strike="noStrike" kern="1200" cap="none" spc="0" normalizeH="0" baseline="0" noProof="0" dirty="0">
+                <a:ln>
+                  <a:noFill/>
+                </a:ln>
                 <a:solidFill>
                   <a:srgbClr val="758198"/>
                 </a:solidFill>
+                <a:effectLst/>
+                <a:uLnTx/>
+                <a:uFillTx/>
                 <a:latin typeface="Aptos" pitchFamily="34" charset="0"/>
                 <a:ea typeface="Aptos" pitchFamily="34" charset="-122"/>
                 <a:cs typeface="Aptos" pitchFamily="34" charset="-120"/>
               </a:rPr>
               <a:t>ASSESSMENT THEME</a:t>
             </a:r>
-            <a:endParaRPr lang="en-US" sz="900" dirty="0"/>
+            <a:endParaRPr kumimoji="0" lang="en-US" sz="900" b="0" i="0" u="none" strike="noStrike" kern="1200" cap="none" spc="0" normalizeH="0" baseline="0" noProof="0" dirty="0">
+              <a:ln>
+                <a:noFill/>
+              </a:ln>
+              <a:solidFill>
+                <a:prstClr val="black"/>
+              </a:solidFill>
+              <a:effectLst/>
+              <a:uLnTx/>
+              <a:uFillTx/>
+              <a:latin typeface="Aptos"/>
+              <a:ea typeface="+mn-ea"/>
+              <a:cs typeface="+mn-cs"/>
+            </a:endParaRPr>
           </a:p>
         </p:txBody>
       </p:sp>
@@ -2699,38 +4075,104 @@
           </a:bodyPr>
           <a:lstStyle/>
           <a:p>
-            <a:pPr marL="0" indent="0" algn="l">
+            <a:pPr marL="0" marR="0" lvl="0" indent="0" algn="l" defTabSz="914400" rtl="0" eaLnBrk="1" fontAlgn="auto" latinLnBrk="0" hangingPunct="1">
+              <a:lnSpc>
+                <a:spcPct val="100000"/>
+              </a:lnSpc>
+              <a:spcBef>
+                <a:spcPts val="0"/>
+              </a:spcBef>
+              <a:spcAft>
+                <a:spcPts val="0"/>
+              </a:spcAft>
+              <a:buClrTx/>
+              <a:buSzTx/>
+              <a:buFontTx/>
               <a:buNone/>
+              <a:tabLst/>
+              <a:defRPr/>
             </a:pPr>
             <a:r>
-              <a:rPr lang="en-US" sz="1340" dirty="0">
+              <a:rPr kumimoji="0" lang="en-US" sz="1340" b="0" i="0" u="none" strike="noStrike" kern="1200" cap="none" spc="0" normalizeH="0" baseline="0" noProof="0" dirty="0">
+                <a:ln>
+                  <a:noFill/>
+                </a:ln>
                 <a:solidFill>
                   <a:srgbClr val="53617A"/>
                 </a:solidFill>
+                <a:effectLst/>
+                <a:uLnTx/>
+                <a:uFillTx/>
                 <a:latin typeface="Aptos" pitchFamily="34" charset="0"/>
                 <a:ea typeface="Aptos" pitchFamily="34" charset="-122"/>
                 <a:cs typeface="Aptos" pitchFamily="34" charset="-120"/>
               </a:rPr>
               <a:t>Smart Temperature Monitoring for</a:t>
             </a:r>
-            <a:endParaRPr lang="en-US" sz="1340" dirty="0"/>
+            <a:endParaRPr kumimoji="0" lang="en-US" sz="1340" b="0" i="0" u="none" strike="noStrike" kern="1200" cap="none" spc="0" normalizeH="0" baseline="0" noProof="0" dirty="0">
+              <a:ln>
+                <a:noFill/>
+              </a:ln>
+              <a:solidFill>
+                <a:prstClr val="black"/>
+              </a:solidFill>
+              <a:effectLst/>
+              <a:uLnTx/>
+              <a:uFillTx/>
+              <a:latin typeface="Aptos"/>
+              <a:ea typeface="+mn-ea"/>
+              <a:cs typeface="+mn-cs"/>
+            </a:endParaRPr>
           </a:p>
           <a:p>
-            <a:pPr marL="0" indent="0" algn="l">
+            <a:pPr marL="0" marR="0" lvl="0" indent="0" algn="l" defTabSz="914400" rtl="0" eaLnBrk="1" fontAlgn="auto" latinLnBrk="0" hangingPunct="1">
+              <a:lnSpc>
+                <a:spcPct val="100000"/>
+              </a:lnSpc>
+              <a:spcBef>
+                <a:spcPts val="0"/>
+              </a:spcBef>
+              <a:spcAft>
+                <a:spcPts val="0"/>
+              </a:spcAft>
+              <a:buClrTx/>
+              <a:buSzTx/>
+              <a:buFontTx/>
               <a:buNone/>
+              <a:tabLst/>
+              <a:defRPr/>
             </a:pPr>
             <a:r>
-              <a:rPr lang="en-US" sz="1340" dirty="0">
+              <a:rPr kumimoji="0" lang="en-US" sz="1340" b="0" i="0" u="none" strike="noStrike" kern="1200" cap="none" spc="0" normalizeH="0" baseline="0" noProof="0" dirty="0">
+                <a:ln>
+                  <a:noFill/>
+                </a:ln>
                 <a:solidFill>
                   <a:srgbClr val="53617A"/>
                 </a:solidFill>
+                <a:effectLst/>
+                <a:uLnTx/>
+                <a:uFillTx/>
                 <a:latin typeface="Aptos" pitchFamily="34" charset="0"/>
                 <a:ea typeface="Aptos" pitchFamily="34" charset="-122"/>
                 <a:cs typeface="Aptos" pitchFamily="34" charset="-120"/>
               </a:rPr>
               <a:t>a Controlled Drug Box</a:t>
             </a:r>
-            <a:endParaRPr lang="en-US" sz="1340" dirty="0"/>
+            <a:endParaRPr kumimoji="0" lang="en-US" sz="1340" b="0" i="0" u="none" strike="noStrike" kern="1200" cap="none" spc="0" normalizeH="0" baseline="0" noProof="0" dirty="0">
+              <a:ln>
+                <a:noFill/>
+              </a:ln>
+              <a:solidFill>
+                <a:prstClr val="black"/>
+              </a:solidFill>
+              <a:effectLst/>
+              <a:uLnTx/>
+              <a:uFillTx/>
+              <a:latin typeface="Aptos"/>
+              <a:ea typeface="+mn-ea"/>
+              <a:cs typeface="+mn-cs"/>
+            </a:endParaRPr>
           </a:p>
         </p:txBody>
       </p:sp>
@@ -2764,7 +4206,37 @@
           <a:bodyPr/>
           <a:lstStyle/>
           <a:p>
-            <a:endParaRPr lang="en-IE"/>
+            <a:pPr marL="0" marR="0" lvl="0" indent="0" algn="l" defTabSz="914400" rtl="0" eaLnBrk="1" fontAlgn="auto" latinLnBrk="0" hangingPunct="1">
+              <a:lnSpc>
+                <a:spcPct val="100000"/>
+              </a:lnSpc>
+              <a:spcBef>
+                <a:spcPts val="0"/>
+              </a:spcBef>
+              <a:spcAft>
+                <a:spcPts val="0"/>
+              </a:spcAft>
+              <a:buClrTx/>
+              <a:buSzTx/>
+              <a:buFontTx/>
+              <a:buNone/>
+              <a:tabLst/>
+              <a:defRPr/>
+            </a:pPr>
+            <a:endParaRPr kumimoji="0" lang="en-IE" sz="1800" b="0" i="0" u="none" strike="noStrike" kern="1200" cap="none" spc="0" normalizeH="0" baseline="0" noProof="0">
+              <a:ln>
+                <a:noFill/>
+              </a:ln>
+              <a:solidFill>
+                <a:prstClr val="black"/>
+              </a:solidFill>
+              <a:effectLst/>
+              <a:uLnTx/>
+              <a:uFillTx/>
+              <a:latin typeface="Aptos"/>
+              <a:ea typeface="+mn-ea"/>
+              <a:cs typeface="+mn-cs"/>
+            </a:endParaRPr>
           </a:p>
         </p:txBody>
       </p:sp>
@@ -2791,21 +4263,54 @@
           </a:bodyPr>
           <a:lstStyle/>
           <a:p>
-            <a:pPr marL="0" indent="0" algn="l">
+            <a:pPr marL="0" marR="0" lvl="0" indent="0" algn="l" defTabSz="914400" rtl="0" eaLnBrk="1" fontAlgn="auto" latinLnBrk="0" hangingPunct="1">
+              <a:lnSpc>
+                <a:spcPct val="100000"/>
+              </a:lnSpc>
+              <a:spcBef>
+                <a:spcPts val="0"/>
+              </a:spcBef>
+              <a:spcAft>
+                <a:spcPts val="0"/>
+              </a:spcAft>
+              <a:buClrTx/>
+              <a:buSzTx/>
+              <a:buFontTx/>
               <a:buNone/>
+              <a:tabLst/>
+              <a:defRPr/>
             </a:pPr>
             <a:r>
-              <a:rPr lang="en-US" sz="860" b="1" dirty="0">
+              <a:rPr kumimoji="0" lang="en-US" sz="860" b="1" i="0" u="none" strike="noStrike" kern="1200" cap="none" spc="0" normalizeH="0" baseline="0" noProof="0" dirty="0">
+                <a:ln>
+                  <a:noFill/>
+                </a:ln>
                 <a:solidFill>
                   <a:srgbClr val="758198"/>
                 </a:solidFill>
+                <a:effectLst/>
+                <a:uLnTx/>
+                <a:uFillTx/>
                 <a:latin typeface="Aptos" pitchFamily="34" charset="0"/>
                 <a:ea typeface="Aptos" pitchFamily="34" charset="-122"/>
                 <a:cs typeface="Aptos" pitchFamily="34" charset="-120"/>
               </a:rPr>
               <a:t>MODULE</a:t>
             </a:r>
-            <a:endParaRPr lang="en-US" sz="860" dirty="0"/>
+            <a:endParaRPr kumimoji="0" lang="en-US" sz="860" b="0" i="0" u="none" strike="noStrike" kern="1200" cap="none" spc="0" normalizeH="0" baseline="0" noProof="0" dirty="0">
+              <a:ln>
+                <a:noFill/>
+              </a:ln>
+              <a:solidFill>
+                <a:prstClr val="black"/>
+              </a:solidFill>
+              <a:effectLst/>
+              <a:uLnTx/>
+              <a:uFillTx/>
+              <a:latin typeface="Aptos"/>
+              <a:ea typeface="+mn-ea"/>
+              <a:cs typeface="+mn-cs"/>
+            </a:endParaRPr>
           </a:p>
         </p:txBody>
       </p:sp>
@@ -2832,21 +4337,54 @@
           </a:bodyPr>
           <a:lstStyle/>
           <a:p>
-            <a:pPr marL="0" indent="0" algn="l">
+            <a:pPr marL="0" marR="0" lvl="0" indent="0" algn="l" defTabSz="914400" rtl="0" eaLnBrk="1" fontAlgn="auto" latinLnBrk="0" hangingPunct="1">
+              <a:lnSpc>
+                <a:spcPct val="100000"/>
+              </a:lnSpc>
+              <a:spcBef>
+                <a:spcPts val="0"/>
+              </a:spcBef>
+              <a:spcAft>
+                <a:spcPts val="0"/>
+              </a:spcAft>
+              <a:buClrTx/>
+              <a:buSzTx/>
+              <a:buFontTx/>
               <a:buNone/>
+              <a:tabLst/>
+              <a:defRPr/>
             </a:pPr>
             <a:r>
-              <a:rPr lang="en-US" sz="1520" b="1" dirty="0">
+              <a:rPr kumimoji="0" lang="en-US" sz="1520" b="1" i="0" u="none" strike="noStrike" kern="1200" cap="none" spc="0" normalizeH="0" baseline="0" noProof="0" dirty="0">
+                <a:ln>
+                  <a:noFill/>
+                </a:ln>
                 <a:solidFill>
                   <a:srgbClr val="143A9D"/>
                 </a:solidFill>
+                <a:effectLst/>
+                <a:uLnTx/>
+                <a:uFillTx/>
                 <a:latin typeface="Aptos" pitchFamily="34" charset="0"/>
                 <a:ea typeface="Aptos" pitchFamily="34" charset="-122"/>
                 <a:cs typeface="Aptos" pitchFamily="34" charset="-120"/>
               </a:rPr>
               <a:t>Universal Design Project</a:t>
             </a:r>
-            <a:endParaRPr lang="en-US" sz="1520" dirty="0"/>
+            <a:endParaRPr kumimoji="0" lang="en-US" sz="1520" b="0" i="0" u="none" strike="noStrike" kern="1200" cap="none" spc="0" normalizeH="0" baseline="0" noProof="0" dirty="0">
+              <a:ln>
+                <a:noFill/>
+              </a:ln>
+              <a:solidFill>
+                <a:prstClr val="black"/>
+              </a:solidFill>
+              <a:effectLst/>
+              <a:uLnTx/>
+              <a:uFillTx/>
+              <a:latin typeface="Aptos"/>
+              <a:ea typeface="+mn-ea"/>
+              <a:cs typeface="+mn-cs"/>
+            </a:endParaRPr>
           </a:p>
         </p:txBody>
       </p:sp>
@@ -2858,7 +4396,7 @@
         </p:nvSpPr>
         <p:spPr>
           <a:xfrm>
-            <a:off x="7863840" y="6035040"/>
+            <a:off x="7948248" y="6035040"/>
             <a:ext cx="3017520" cy="201168"/>
           </a:xfrm>
           <a:prstGeom prst="rect">
@@ -2873,21 +4411,54 @@
           </a:bodyPr>
           <a:lstStyle/>
           <a:p>
-            <a:pPr marL="0" indent="0" algn="r">
+            <a:pPr marL="0" marR="0" lvl="0" indent="0" algn="r" defTabSz="914400" rtl="0" eaLnBrk="1" fontAlgn="auto" latinLnBrk="0" hangingPunct="1">
+              <a:lnSpc>
+                <a:spcPct val="100000"/>
+              </a:lnSpc>
+              <a:spcBef>
+                <a:spcPts val="0"/>
+              </a:spcBef>
+              <a:spcAft>
+                <a:spcPts val="0"/>
+              </a:spcAft>
+              <a:buClrTx/>
+              <a:buSzTx/>
+              <a:buFontTx/>
               <a:buNone/>
+              <a:tabLst/>
+              <a:defRPr/>
             </a:pPr>
             <a:r>
-              <a:rPr lang="en-US" sz="1150" dirty="0">
+              <a:rPr kumimoji="0" lang="en-US" sz="1150" b="0" i="0" u="none" strike="noStrike" kern="1200" cap="none" spc="0" normalizeH="0" baseline="0" noProof="0" dirty="0">
+                <a:ln>
+                  <a:noFill/>
+                </a:ln>
                 <a:solidFill>
                   <a:srgbClr val="758198"/>
                 </a:solidFill>
+                <a:effectLst/>
+                <a:uLnTx/>
+                <a:uFillTx/>
                 <a:latin typeface="Aptos" pitchFamily="34" charset="0"/>
                 <a:ea typeface="Aptos" pitchFamily="34" charset="-122"/>
                 <a:cs typeface="Aptos" pitchFamily="34" charset="-120"/>
               </a:rPr>
-              <a:t>Prepared for group presentation</a:t>
+              <a:t>09/10/2026</a:t>
             </a:r>
-            <a:endParaRPr lang="en-US" sz="1150" dirty="0"/>
+            <a:endParaRPr kumimoji="0" lang="en-US" sz="1150" b="0" i="0" u="none" strike="noStrike" kern="1200" cap="none" spc="0" normalizeH="0" baseline="0" noProof="0" dirty="0">
+              <a:ln>
+                <a:noFill/>
+              </a:ln>
+              <a:solidFill>
+                <a:prstClr val="black"/>
+              </a:solidFill>
+              <a:effectLst/>
+              <a:uLnTx/>
+              <a:uFillTx/>
+              <a:latin typeface="Aptos"/>
+              <a:ea typeface="+mn-ea"/>
+              <a:cs typeface="+mn-cs"/>
+            </a:endParaRPr>
           </a:p>
         </p:txBody>
       </p:sp>
@@ -2921,10 +4492,304 @@
           <a:bodyPr/>
           <a:lstStyle/>
           <a:p>
-            <a:endParaRPr lang="en-IE"/>
+            <a:pPr marL="0" marR="0" lvl="0" indent="0" algn="l" defTabSz="914400" rtl="0" eaLnBrk="1" fontAlgn="auto" latinLnBrk="0" hangingPunct="1">
+              <a:lnSpc>
+                <a:spcPct val="100000"/>
+              </a:lnSpc>
+              <a:spcBef>
+                <a:spcPts val="0"/>
+              </a:spcBef>
+              <a:spcAft>
+                <a:spcPts val="0"/>
+              </a:spcAft>
+              <a:buClrTx/>
+              <a:buSzTx/>
+              <a:buFontTx/>
+              <a:buNone/>
+              <a:tabLst/>
+              <a:defRPr/>
+            </a:pPr>
+            <a:endParaRPr kumimoji="0" lang="en-IE" sz="1800" b="0" i="0" u="none" strike="noStrike" kern="1200" cap="none" spc="0" normalizeH="0" baseline="0" noProof="0">
+              <a:ln>
+                <a:noFill/>
+              </a:ln>
+              <a:solidFill>
+                <a:prstClr val="black"/>
+              </a:solidFill>
+              <a:effectLst/>
+              <a:uLnTx/>
+              <a:uFillTx/>
+              <a:latin typeface="Aptos"/>
+              <a:ea typeface="+mn-ea"/>
+              <a:cs typeface="+mn-cs"/>
+            </a:endParaRPr>
           </a:p>
         </p:txBody>
       </p:sp>
+      <p:pic>
+        <p:nvPicPr>
+          <p:cNvPr id="47" name="Picture 46">
+            <a:extLst>
+              <a:ext uri="{FF2B5EF4-FFF2-40B4-BE49-F238E27FC236}">
+                <a16:creationId xmlns:a16="http://schemas.microsoft.com/office/drawing/2014/main" id="{3E8DA742-7331-1CE7-DB6C-96EB7B267FBE}"/>
+              </a:ext>
+            </a:extLst>
+          </p:cNvPr>
+          <p:cNvPicPr>
+            <a:picLocks noChangeAspect="1"/>
+          </p:cNvPicPr>
+          <p:nvPr/>
+        </p:nvPicPr>
+        <p:blipFill>
+          <a:blip r:embed="rId3"/>
+          <a:stretch>
+            <a:fillRect/>
+          </a:stretch>
+        </p:blipFill>
+        <p:spPr>
+          <a:xfrm>
+            <a:off x="8194685" y="2018839"/>
+            <a:ext cx="932948" cy="1658574"/>
+          </a:xfrm>
+          <a:prstGeom prst="rect">
+            <a:avLst/>
+          </a:prstGeom>
+          <a:effectLst>
+            <a:softEdge rad="63500"/>
+          </a:effectLst>
+        </p:spPr>
+      </p:pic>
+      <p:pic>
+        <p:nvPicPr>
+          <p:cNvPr id="51" name="Picture 50">
+            <a:extLst>
+              <a:ext uri="{FF2B5EF4-FFF2-40B4-BE49-F238E27FC236}">
+                <a16:creationId xmlns:a16="http://schemas.microsoft.com/office/drawing/2014/main" id="{839B47B3-859B-B5F3-7353-D96C9996B338}"/>
+              </a:ext>
+            </a:extLst>
+          </p:cNvPr>
+          <p:cNvPicPr>
+            <a:picLocks noChangeAspect="1"/>
+          </p:cNvPicPr>
+          <p:nvPr/>
+        </p:nvPicPr>
+        <p:blipFill>
+          <a:blip r:embed="rId4"/>
+          <a:stretch>
+            <a:fillRect/>
+          </a:stretch>
+        </p:blipFill>
+        <p:spPr>
+          <a:xfrm>
+            <a:off x="4734399" y="2035648"/>
+            <a:ext cx="972325" cy="1650978"/>
+          </a:xfrm>
+          <a:prstGeom prst="rect">
+            <a:avLst/>
+          </a:prstGeom>
+          <a:effectLst>
+            <a:softEdge rad="63500"/>
+          </a:effectLst>
+        </p:spPr>
+      </p:pic>
+      <p:sp>
+        <p:nvSpPr>
+          <p:cNvPr id="53" name="Shape 7">
+            <a:extLst>
+              <a:ext uri="{FF2B5EF4-FFF2-40B4-BE49-F238E27FC236}">
+                <a16:creationId xmlns:a16="http://schemas.microsoft.com/office/drawing/2014/main" id="{FFEA8D85-73A5-58CF-8233-C89E1596AD89}"/>
+              </a:ext>
+            </a:extLst>
+          </p:cNvPr>
+          <p:cNvSpPr/>
+          <p:nvPr/>
+        </p:nvSpPr>
+        <p:spPr>
+          <a:xfrm>
+            <a:off x="633965" y="438912"/>
+            <a:ext cx="2987059" cy="548640"/>
+          </a:xfrm>
+          <a:prstGeom prst="roundRect">
+            <a:avLst>
+              <a:gd name="adj" fmla="val 42857"/>
+            </a:avLst>
+          </a:prstGeom>
+          <a:solidFill>
+            <a:srgbClr val="ECE9FB"/>
+          </a:solidFill>
+          <a:ln w="10160">
+            <a:solidFill>
+              <a:srgbClr val="DAD3EF"/>
+            </a:solidFill>
+            <a:prstDash val="solid"/>
+          </a:ln>
+        </p:spPr>
+        <p:txBody>
+          <a:bodyPr/>
+          <a:lstStyle/>
+          <a:p>
+            <a:pPr marL="0" marR="0" lvl="0" indent="0" algn="l" defTabSz="914400" rtl="0" eaLnBrk="1" fontAlgn="auto" latinLnBrk="0" hangingPunct="1">
+              <a:lnSpc>
+                <a:spcPct val="100000"/>
+              </a:lnSpc>
+              <a:spcBef>
+                <a:spcPts val="0"/>
+              </a:spcBef>
+              <a:spcAft>
+                <a:spcPts val="0"/>
+              </a:spcAft>
+              <a:buClrTx/>
+              <a:buSzTx/>
+              <a:buFontTx/>
+              <a:buNone/>
+              <a:tabLst/>
+              <a:defRPr/>
+            </a:pPr>
+            <a:endParaRPr kumimoji="0" lang="en-IE" sz="1800" b="0" i="0" u="none" strike="noStrike" kern="1200" cap="none" spc="0" normalizeH="0" baseline="0" noProof="0" dirty="0">
+              <a:ln>
+                <a:noFill/>
+              </a:ln>
+              <a:solidFill>
+                <a:prstClr val="black"/>
+              </a:solidFill>
+              <a:effectLst/>
+              <a:uLnTx/>
+              <a:uFillTx/>
+              <a:latin typeface="Aptos"/>
+              <a:ea typeface="+mn-ea"/>
+              <a:cs typeface="+mn-cs"/>
+            </a:endParaRPr>
+          </a:p>
+        </p:txBody>
+      </p:sp>
+      <p:sp>
+        <p:nvSpPr>
+          <p:cNvPr id="54" name="Text 8">
+            <a:extLst>
+              <a:ext uri="{FF2B5EF4-FFF2-40B4-BE49-F238E27FC236}">
+                <a16:creationId xmlns:a16="http://schemas.microsoft.com/office/drawing/2014/main" id="{F662F7B4-D230-A756-54BF-36F899ED1EB6}"/>
+              </a:ext>
+            </a:extLst>
+          </p:cNvPr>
+          <p:cNvSpPr/>
+          <p:nvPr/>
+        </p:nvSpPr>
+        <p:spPr>
+          <a:xfrm>
+            <a:off x="1173825" y="542775"/>
+            <a:ext cx="2041468" cy="380122"/>
+          </a:xfrm>
+          <a:prstGeom prst="rect">
+            <a:avLst/>
+          </a:prstGeom>
+          <a:noFill/>
+          <a:ln/>
+        </p:spPr>
+        <p:txBody>
+          <a:bodyPr wrap="square" lIns="254" tIns="254" rIns="254" bIns="254" rtlCol="0" anchor="ctr"/>
+          <a:lstStyle/>
+          <a:p>
+            <a:pPr marL="0" marR="0" lvl="0" indent="0" algn="l" defTabSz="914400" rtl="0" eaLnBrk="1" fontAlgn="auto" latinLnBrk="0" hangingPunct="1">
+              <a:lnSpc>
+                <a:spcPct val="100000"/>
+              </a:lnSpc>
+              <a:spcBef>
+                <a:spcPts val="0"/>
+              </a:spcBef>
+              <a:spcAft>
+                <a:spcPts val="0"/>
+              </a:spcAft>
+              <a:buClrTx/>
+              <a:buSzTx/>
+              <a:buFontTx/>
+              <a:buNone/>
+              <a:tabLst/>
+              <a:defRPr/>
+            </a:pPr>
+            <a:r>
+              <a:rPr kumimoji="0" lang="en-US" sz="2000" b="1" i="0" u="none" strike="noStrike" kern="1200" cap="none" spc="0" normalizeH="0" baseline="0" noProof="0" dirty="0">
+                <a:ln>
+                  <a:noFill/>
+                </a:ln>
+                <a:solidFill>
+                  <a:srgbClr val="143A9D"/>
+                </a:solidFill>
+                <a:effectLst/>
+                <a:uLnTx/>
+                <a:uFillTx/>
+                <a:latin typeface="Aptos" pitchFamily="34" charset="0"/>
+                <a:ea typeface="Aptos" pitchFamily="34" charset="-122"/>
+                <a:cs typeface="Aptos" pitchFamily="34" charset="-120"/>
+              </a:rPr>
+              <a:t>App: </a:t>
+            </a:r>
+            <a:r>
+              <a:rPr kumimoji="0" lang="en-US" sz="2000" b="0" i="0" u="none" strike="noStrike" kern="1200" cap="none" spc="0" normalizeH="0" baseline="0" noProof="0" dirty="0">
+                <a:ln>
+                  <a:noFill/>
+                </a:ln>
+                <a:solidFill>
+                  <a:srgbClr val="143A9D"/>
+                </a:solidFill>
+                <a:effectLst/>
+                <a:uLnTx/>
+                <a:uFillTx/>
+                <a:latin typeface="Aptos" pitchFamily="34" charset="0"/>
+                <a:ea typeface="Aptos" pitchFamily="34" charset="-122"/>
+                <a:cs typeface="Aptos" pitchFamily="34" charset="-120"/>
+              </a:rPr>
+              <a:t>TempSafe</a:t>
+            </a:r>
+            <a:endParaRPr kumimoji="0" lang="en-US" sz="2000" b="0" i="0" u="none" strike="noStrike" kern="1200" cap="none" spc="0" normalizeH="0" baseline="0" noProof="0" dirty="0">
+              <a:ln>
+                <a:noFill/>
+              </a:ln>
+              <a:solidFill>
+                <a:prstClr val="black"/>
+              </a:solidFill>
+              <a:effectLst/>
+              <a:uLnTx/>
+              <a:uFillTx/>
+              <a:latin typeface="Aptos"/>
+              <a:ea typeface="+mn-ea"/>
+              <a:cs typeface="+mn-cs"/>
+            </a:endParaRPr>
+          </a:p>
+        </p:txBody>
+      </p:sp>
+      <p:pic>
+        <p:nvPicPr>
+          <p:cNvPr id="13" name="Picture 12">
+            <a:extLst>
+              <a:ext uri="{FF2B5EF4-FFF2-40B4-BE49-F238E27FC236}">
+                <a16:creationId xmlns:a16="http://schemas.microsoft.com/office/drawing/2014/main" id="{2A2F1614-3928-E6A8-30CD-6AD0AD3A05C1}"/>
+              </a:ext>
+            </a:extLst>
+          </p:cNvPr>
+          <p:cNvPicPr>
+            <a:picLocks noChangeAspect="1"/>
+          </p:cNvPicPr>
+          <p:nvPr/>
+        </p:nvPicPr>
+        <p:blipFill>
+          <a:blip r:embed="rId5"/>
+          <a:stretch>
+            <a:fillRect/>
+          </a:stretch>
+        </p:blipFill>
+        <p:spPr>
+          <a:xfrm>
+            <a:off x="1112897" y="2004653"/>
+            <a:ext cx="880775" cy="1596544"/>
+          </a:xfrm>
+          <a:prstGeom prst="rect">
+            <a:avLst/>
+          </a:prstGeom>
+          <a:effectLst>
+            <a:softEdge rad="63500"/>
+          </a:effectLst>
+        </p:spPr>
+      </p:pic>
     </p:spTree>
   </p:cSld>
   <p:clrMapOvr>
@@ -3381,7 +5246,7 @@
           </p:spPr>
           <p:txBody>
             <a:bodyPr wrap="square" lIns="0" tIns="0" rIns="0" bIns="0" rtlCol="0" anchor="t">
-              <a:normAutofit lnSpcReduction="10000"/>
+              <a:normAutofit/>
             </a:bodyPr>
             <a:lstStyle/>
             <a:p>
@@ -10313,6 +12178,301 @@
 </file>
 
 <file path=ppt/theme/theme2.xml><?xml version="1.0" encoding="utf-8"?>
+<a:theme xmlns:a="http://schemas.openxmlformats.org/drawingml/2006/main" name="1_Office Theme">
+  <a:themeElements>
+    <a:clrScheme name="Office">
+      <a:dk1>
+        <a:sysClr val="windowText" lastClr="000000"/>
+      </a:dk1>
+      <a:lt1>
+        <a:sysClr val="window" lastClr="FFFFFF"/>
+      </a:lt1>
+      <a:dk2>
+        <a:srgbClr val="44546A"/>
+      </a:dk2>
+      <a:lt2>
+        <a:srgbClr val="E7E6E6"/>
+      </a:lt2>
+      <a:accent1>
+        <a:srgbClr val="4472C4"/>
+      </a:accent1>
+      <a:accent2>
+        <a:srgbClr val="ED7D31"/>
+      </a:accent2>
+      <a:accent3>
+        <a:srgbClr val="A5A5A5"/>
+      </a:accent3>
+      <a:accent4>
+        <a:srgbClr val="FFC000"/>
+      </a:accent4>
+      <a:accent5>
+        <a:srgbClr val="5B9BD5"/>
+      </a:accent5>
+      <a:accent6>
+        <a:srgbClr val="70AD47"/>
+      </a:accent6>
+      <a:hlink>
+        <a:srgbClr val="0563C1"/>
+      </a:hlink>
+      <a:folHlink>
+        <a:srgbClr val="954F72"/>
+      </a:folHlink>
+    </a:clrScheme>
+    <a:fontScheme name="Office">
+      <a:majorFont>
+        <a:latin typeface="Aptos Display"/>
+        <a:ea typeface=""/>
+        <a:cs typeface=""/>
+        <a:font script="Jpan" typeface="游ゴシック Light"/>
+        <a:font script="Hang" typeface="맑은 고딕"/>
+        <a:font script="Hans" typeface="等线 Light"/>
+        <a:font script="Hant" typeface="新細明體"/>
+        <a:font script="Arab" typeface="Times New Roman"/>
+        <a:font script="Hebr" typeface="Times New Roman"/>
+        <a:font script="Thai" typeface="Angsana New"/>
+        <a:font script="Ethi" typeface="Nyala"/>
+        <a:font script="Beng" typeface="Vrinda"/>
+        <a:font script="Gujr" typeface="Shruti"/>
+        <a:font script="Khmr" typeface="MoolBoran"/>
+        <a:font script="Knda" typeface="Tunga"/>
+        <a:font script="Guru" typeface="Raavi"/>
+        <a:font script="Cans" typeface="Euphemia"/>
+        <a:font script="Cher" typeface="Plantagenet Cherokee"/>
+        <a:font script="Yiii" typeface="Microsoft Yi Baiti"/>
+        <a:font script="Tibt" typeface="Microsoft Himalaya"/>
+        <a:font script="Thaa" typeface="MV Boli"/>
+        <a:font script="Deva" typeface="Mangal"/>
+        <a:font script="Telu" typeface="Gautami"/>
+        <a:font script="Taml" typeface="Latha"/>
+        <a:font script="Syrc" typeface="Estrangelo Edessa"/>
+        <a:font script="Orya" typeface="Kalinga"/>
+        <a:font script="Mlym" typeface="Kartika"/>
+        <a:font script="Laoo" typeface="DokChampa"/>
+        <a:font script="Sinh" typeface="Iskoola Pota"/>
+        <a:font script="Mong" typeface="Mongolian Baiti"/>
+        <a:font script="Viet" typeface="Times New Roman"/>
+        <a:font script="Uigh" typeface="Microsoft Uighur"/>
+        <a:font script="Geor" typeface="Sylfaen"/>
+        <a:font script="Armn" typeface="Arial"/>
+        <a:font script="Bugi" typeface="Leelawadee UI"/>
+        <a:font script="Bopo" typeface="Microsoft JhengHei"/>
+        <a:font script="Java" typeface="Javanese Text"/>
+        <a:font script="Lisu" typeface="Segoe UI"/>
+        <a:font script="Mymr" typeface="Myanmar Text"/>
+        <a:font script="Nkoo" typeface="Ebrima"/>
+        <a:font script="Olck" typeface="Nirmala UI"/>
+        <a:font script="Osma" typeface="Ebrima"/>
+        <a:font script="Phag" typeface="Phagspa"/>
+        <a:font script="Syrn" typeface="Estrangelo Edessa"/>
+        <a:font script="Syrj" typeface="Estrangelo Edessa"/>
+        <a:font script="Syre" typeface="Estrangelo Edessa"/>
+        <a:font script="Sora" typeface="Nirmala UI"/>
+        <a:font script="Tale" typeface="Microsoft Tai Le"/>
+        <a:font script="Talu" typeface="Microsoft New Tai Lue"/>
+        <a:font script="Tfng" typeface="Ebrima"/>
+      </a:majorFont>
+      <a:minorFont>
+        <a:latin typeface="Aptos"/>
+        <a:ea typeface=""/>
+        <a:cs typeface=""/>
+        <a:font script="Jpan" typeface="游ゴシック"/>
+        <a:font script="Hang" typeface="맑은 고딕"/>
+        <a:font script="Hans" typeface="等线"/>
+        <a:font script="Hant" typeface="新細明體"/>
+        <a:font script="Arab" typeface="Arial"/>
+        <a:font script="Hebr" typeface="Arial"/>
+        <a:font script="Thai" typeface="Cordia New"/>
+        <a:font script="Ethi" typeface="Nyala"/>
+        <a:font script="Beng" typeface="Vrinda"/>
+        <a:font script="Gujr" typeface="Shruti"/>
+        <a:font script="Khmr" typeface="DaunPenh"/>
+        <a:font script="Knda" typeface="Tunga"/>
+        <a:font script="Guru" typeface="Raavi"/>
+        <a:font script="Cans" typeface="Euphemia"/>
+        <a:font script="Cher" typeface="Plantagenet Cherokee"/>
+        <a:font script="Yiii" typeface="Microsoft Yi Baiti"/>
+        <a:font script="Tibt" typeface="Microsoft Himalaya"/>
+        <a:font script="Thaa" typeface="MV Boli"/>
+        <a:font script="Deva" typeface="Mangal"/>
+        <a:font script="Telu" typeface="Gautami"/>
+        <a:font script="Taml" typeface="Latha"/>
+        <a:font script="Syrc" typeface="Estrangelo Edessa"/>
+        <a:font script="Orya" typeface="Kalinga"/>
+        <a:font script="Mlym" typeface="Kartika"/>
+        <a:font script="Laoo" typeface="DokChampa"/>
+        <a:font script="Sinh" typeface="Iskoola Pota"/>
+        <a:font script="Mong" typeface="Mongolian Baiti"/>
+        <a:font script="Viet" typeface="Arial"/>
+        <a:font script="Uigh" typeface="Microsoft Uighur"/>
+        <a:font script="Geor" typeface="Sylfaen"/>
+        <a:font script="Armn" typeface="Arial"/>
+        <a:font script="Bugi" typeface="Leelawadee UI"/>
+        <a:font script="Bopo" typeface="Microsoft JhengHei"/>
+        <a:font script="Java" typeface="Javanese Text"/>
+        <a:font script="Lisu" typeface="Segoe UI"/>
+        <a:font script="Mymr" typeface="Myanmar Text"/>
+        <a:font script="Nkoo" typeface="Ebrima"/>
+        <a:font script="Olck" typeface="Nirmala UI"/>
+        <a:font script="Osma" typeface="Ebrima"/>
+        <a:font script="Phag" typeface="Phagspa"/>
+        <a:font script="Syrn" typeface="Estrangelo Edessa"/>
+        <a:font script="Syrj" typeface="Estrangelo Edessa"/>
+        <a:font script="Syre" typeface="Estrangelo Edessa"/>
+        <a:font script="Sora" typeface="Nirmala UI"/>
+        <a:font script="Tale" typeface="Microsoft Tai Le"/>
+        <a:font script="Talu" typeface="Microsoft New Tai Lue"/>
+        <a:font script="Tfng" typeface="Ebrima"/>
+      </a:minorFont>
+    </a:fontScheme>
+    <a:fmtScheme name="Office">
+      <a:fillStyleLst>
+        <a:solidFill>
+          <a:schemeClr val="phClr"/>
+        </a:solidFill>
+        <a:gradFill rotWithShape="1">
+          <a:gsLst>
+            <a:gs pos="0">
+              <a:schemeClr val="phClr">
+                <a:lumMod val="110000"/>
+                <a:satMod val="105000"/>
+                <a:tint val="67000"/>
+              </a:schemeClr>
+            </a:gs>
+            <a:gs pos="50000">
+              <a:schemeClr val="phClr">
+                <a:lumMod val="105000"/>
+                <a:satMod val="103000"/>
+                <a:tint val="73000"/>
+              </a:schemeClr>
+            </a:gs>
+            <a:gs pos="100000">
+              <a:schemeClr val="phClr">
+                <a:lumMod val="105000"/>
+                <a:satMod val="109000"/>
+                <a:tint val="81000"/>
+              </a:schemeClr>
+            </a:gs>
+          </a:gsLst>
+          <a:lin ang="5400000" scaled="0"/>
+        </a:gradFill>
+        <a:gradFill rotWithShape="1">
+          <a:gsLst>
+            <a:gs pos="0">
+              <a:schemeClr val="phClr">
+                <a:satMod val="103000"/>
+                <a:lumMod val="102000"/>
+                <a:tint val="94000"/>
+              </a:schemeClr>
+            </a:gs>
+            <a:gs pos="50000">
+              <a:schemeClr val="phClr">
+                <a:satMod val="110000"/>
+                <a:lumMod val="100000"/>
+                <a:shade val="100000"/>
+              </a:schemeClr>
+            </a:gs>
+            <a:gs pos="100000">
+              <a:schemeClr val="phClr">
+                <a:lumMod val="99000"/>
+                <a:satMod val="120000"/>
+                <a:shade val="78000"/>
+              </a:schemeClr>
+            </a:gs>
+          </a:gsLst>
+          <a:lin ang="5400000" scaled="0"/>
+        </a:gradFill>
+      </a:fillStyleLst>
+      <a:lnStyleLst>
+        <a:ln w="6350" cap="flat" cmpd="sng" algn="ctr">
+          <a:solidFill>
+            <a:schemeClr val="phClr"/>
+          </a:solidFill>
+          <a:prstDash val="solid"/>
+          <a:miter lim="800000"/>
+        </a:ln>
+        <a:ln w="12700" cap="flat" cmpd="sng" algn="ctr">
+          <a:solidFill>
+            <a:schemeClr val="phClr"/>
+          </a:solidFill>
+          <a:prstDash val="solid"/>
+          <a:miter lim="800000"/>
+        </a:ln>
+        <a:ln w="19050" cap="flat" cmpd="sng" algn="ctr">
+          <a:solidFill>
+            <a:schemeClr val="phClr"/>
+          </a:solidFill>
+          <a:prstDash val="solid"/>
+          <a:miter lim="800000"/>
+        </a:ln>
+      </a:lnStyleLst>
+      <a:effectStyleLst>
+        <a:effectStyle>
+          <a:effectLst/>
+        </a:effectStyle>
+        <a:effectStyle>
+          <a:effectLst/>
+        </a:effectStyle>
+        <a:effectStyle>
+          <a:effectLst>
+            <a:outerShdw blurRad="57150" dist="19050" dir="5400000" algn="ctr" rotWithShape="0">
+              <a:srgbClr val="000000">
+                <a:alpha val="63000"/>
+              </a:srgbClr>
+            </a:outerShdw>
+          </a:effectLst>
+        </a:effectStyle>
+      </a:effectStyleLst>
+      <a:bgFillStyleLst>
+        <a:solidFill>
+          <a:schemeClr val="phClr"/>
+        </a:solidFill>
+        <a:solidFill>
+          <a:schemeClr val="phClr">
+            <a:tint val="95000"/>
+            <a:satMod val="170000"/>
+          </a:schemeClr>
+        </a:solidFill>
+        <a:gradFill rotWithShape="1">
+          <a:gsLst>
+            <a:gs pos="0">
+              <a:schemeClr val="phClr">
+                <a:tint val="93000"/>
+                <a:satMod val="150000"/>
+                <a:shade val="98000"/>
+                <a:lumMod val="102000"/>
+              </a:schemeClr>
+            </a:gs>
+            <a:gs pos="50000">
+              <a:schemeClr val="phClr">
+                <a:tint val="98000"/>
+                <a:satMod val="130000"/>
+                <a:shade val="90000"/>
+                <a:lumMod val="103000"/>
+              </a:schemeClr>
+            </a:gs>
+            <a:gs pos="100000">
+              <a:schemeClr val="phClr">
+                <a:shade val="63000"/>
+                <a:satMod val="120000"/>
+              </a:schemeClr>
+            </a:gs>
+          </a:gsLst>
+          <a:lin ang="5400000" scaled="0"/>
+        </a:gradFill>
+      </a:bgFillStyleLst>
+    </a:fmtScheme>
+  </a:themeElements>
+  <a:objectDefaults/>
+  <a:extraClrSchemeLst/>
+  <a:extLst>
+    <a:ext uri="{05A4C25C-085E-4340-85A3-A5531E510DB2}">
+      <thm15:themeFamily xmlns:thm15="http://schemas.microsoft.com/office/thememl/2012/main" name="Office Theme" id="{62F939B6-93AF-4DB8-9C6B-D6C7DFDC589F}" vid="{4A3C46E8-61CC-4603-A589-7422A47A8E4A}"/>
+    </a:ext>
+  </a:extLst>
+</a:theme>
+</file>
+
+<file path=ppt/theme/theme3.xml><?xml version="1.0" encoding="utf-8"?>
 <a:theme xmlns:a="http://schemas.openxmlformats.org/drawingml/2006/main" name="Office Theme">
   <a:themeElements>
     <a:clrScheme name="Office">

</xml_diff>

<commit_message>
Add closing thank-you and questions slide
</commit_message>
<xml_diff>
--- a/docs/presentation/TempSafe_Elevator_Pitch.pptx
+++ b/docs/presentation/TempSafe_Elevator_Pitch.pptx
@@ -6,13 +6,14 @@
     <p:sldMasterId id="2147483651" r:id="rId2"/>
   </p:sldMasterIdLst>
   <p:notesMasterIdLst>
-    <p:notesMasterId r:id="rId7"/>
+    <p:notesMasterId r:id="rId8"/>
   </p:notesMasterIdLst>
   <p:sldIdLst>
     <p:sldId id="260" r:id="rId3"/>
     <p:sldId id="256" r:id="rId4"/>
     <p:sldId id="257" r:id="rId5"/>
     <p:sldId id="259" r:id="rId6"/>
+    <p:sldId id="261" r:id="rId7"/>
   </p:sldIdLst>
   <p:sldSz cx="12192000" cy="6858000"/>
   <p:notesSz cx="6858000" cy="12192000"/>
@@ -1625,7 +1626,7 @@
           <a:bodyPr/>
           <a:lstStyle/>
           <a:p>
-            <a:pPr marL="0" marR="0" lvl="0" indent="0" algn="l" defTabSz="914400" rtl="0" eaLnBrk="1" fontAlgn="auto" latinLnBrk="0" hangingPunct="1">
+            <a:pPr marL="0" marR="0" lvl="0" indent="0" algn="ctr" defTabSz="914400" rtl="0" eaLnBrk="1" fontAlgn="auto" latinLnBrk="0" hangingPunct="1">
               <a:lnSpc>
                 <a:spcPct val="100000"/>
               </a:lnSpc>
@@ -1753,7 +1754,7 @@
           <a:bodyPr/>
           <a:lstStyle/>
           <a:p>
-            <a:pPr marL="0" marR="0" lvl="0" indent="0" algn="l" defTabSz="914400" rtl="0" eaLnBrk="1" fontAlgn="auto" latinLnBrk="0" hangingPunct="1">
+            <a:pPr marL="0" marR="0" lvl="0" indent="0" algn="ctr" defTabSz="914400" rtl="0" eaLnBrk="1" fontAlgn="auto" latinLnBrk="0" hangingPunct="1">
               <a:lnSpc>
                 <a:spcPct val="100000"/>
               </a:lnSpc>
@@ -1770,7 +1771,7 @@
               <a:tabLst/>
               <a:defRPr/>
             </a:pPr>
-            <a:endParaRPr kumimoji="0" lang="en-IE" sz="1800" b="0" i="0" u="none" strike="noStrike" kern="1200" cap="none" spc="0" normalizeH="0" baseline="0" noProof="0">
+            <a:endParaRPr kumimoji="0" lang="en-IE" sz="1800" b="0" i="0" u="none" strike="noStrike" kern="1200" cap="none" spc="0" normalizeH="0" baseline="0" noProof="0" dirty="0">
               <a:ln>
                 <a:noFill/>
               </a:ln>
@@ -1795,7 +1796,7 @@
         </p:nvSpPr>
         <p:spPr>
           <a:xfrm>
-            <a:off x="9262872" y="475698"/>
+            <a:off x="9262872" y="518718"/>
             <a:ext cx="566928" cy="182880"/>
           </a:xfrm>
           <a:prstGeom prst="rect">
@@ -1810,7 +1811,7 @@
           </a:bodyPr>
           <a:lstStyle/>
           <a:p>
-            <a:pPr marL="0" marR="0" lvl="0" indent="0" algn="l" defTabSz="914400" rtl="0" eaLnBrk="1" fontAlgn="auto" latinLnBrk="0" hangingPunct="1">
+            <a:pPr marL="0" marR="0" lvl="0" indent="0" algn="ctr" defTabSz="914400" rtl="0" eaLnBrk="1" fontAlgn="auto" latinLnBrk="0" hangingPunct="1">
               <a:lnSpc>
                 <a:spcPct val="100000"/>
               </a:lnSpc>
@@ -1869,7 +1870,7 @@
         </p:nvSpPr>
         <p:spPr>
           <a:xfrm>
-            <a:off x="7824182" y="462096"/>
+            <a:off x="7737645" y="534319"/>
             <a:ext cx="3617382" cy="507562"/>
           </a:xfrm>
           <a:prstGeom prst="rect">
@@ -1884,7 +1885,7 @@
           </a:bodyPr>
           <a:lstStyle/>
           <a:p>
-            <a:pPr marL="0" marR="0" lvl="0" indent="0" algn="l" defTabSz="914400" rtl="0" eaLnBrk="1" fontAlgn="auto" latinLnBrk="0" hangingPunct="1">
+            <a:pPr marL="0" marR="0" lvl="0" indent="0" algn="ctr" defTabSz="914400" rtl="0" eaLnBrk="1" fontAlgn="auto" latinLnBrk="0" hangingPunct="1">
               <a:lnSpc>
                 <a:spcPct val="100000"/>
               </a:lnSpc>
@@ -1958,7 +1959,7 @@
           </a:bodyPr>
           <a:lstStyle/>
           <a:p>
-            <a:pPr marL="0" marR="0" lvl="0" indent="0" algn="l" defTabSz="914400" rtl="0" eaLnBrk="1" fontAlgn="auto" latinLnBrk="0" hangingPunct="1">
+            <a:pPr marL="0" marR="0" lvl="0" indent="0" algn="ctr" defTabSz="914400" rtl="0" eaLnBrk="1" fontAlgn="auto" latinLnBrk="0" hangingPunct="1">
               <a:lnSpc>
                 <a:spcPct val="100000"/>
               </a:lnSpc>
@@ -2039,7 +2040,7 @@
           <a:bodyPr/>
           <a:lstStyle/>
           <a:p>
-            <a:pPr marL="0" marR="0" lvl="0" indent="0" algn="l" defTabSz="914400" rtl="0" eaLnBrk="1" fontAlgn="auto" latinLnBrk="0" hangingPunct="1">
+            <a:pPr marL="0" marR="0" lvl="0" indent="0" algn="ctr" defTabSz="914400" rtl="0" eaLnBrk="1" fontAlgn="auto" latinLnBrk="0" hangingPunct="1">
               <a:lnSpc>
                 <a:spcPct val="100000"/>
               </a:lnSpc>
@@ -2081,7 +2082,7 @@
         </p:nvSpPr>
         <p:spPr>
           <a:xfrm>
-            <a:off x="4480560" y="566077"/>
+            <a:off x="4480559" y="533731"/>
             <a:ext cx="2041468" cy="343752"/>
           </a:xfrm>
           <a:prstGeom prst="rect">
@@ -2094,7 +2095,7 @@
           <a:bodyPr wrap="square" lIns="254" tIns="254" rIns="254" bIns="254" rtlCol="0" anchor="ctr"/>
           <a:lstStyle/>
           <a:p>
-            <a:pPr marL="0" marR="0" lvl="0" indent="0" algn="l" defTabSz="914400" rtl="0" eaLnBrk="1" fontAlgn="auto" latinLnBrk="0" hangingPunct="1">
+            <a:pPr marL="0" marR="0" lvl="0" indent="0" algn="ctr" defTabSz="914400" rtl="0" eaLnBrk="1" fontAlgn="auto" latinLnBrk="0" hangingPunct="1">
               <a:lnSpc>
                 <a:spcPct val="100000"/>
               </a:lnSpc>
@@ -2199,7 +2200,7 @@
           <a:bodyPr/>
           <a:lstStyle/>
           <a:p>
-            <a:pPr marL="0" marR="0" lvl="0" indent="0" algn="l" defTabSz="914400" rtl="0" eaLnBrk="1" fontAlgn="auto" latinLnBrk="0" hangingPunct="1">
+            <a:pPr marL="0" marR="0" lvl="0" indent="0" algn="ctr" defTabSz="914400" rtl="0" eaLnBrk="1" fontAlgn="auto" latinLnBrk="0" hangingPunct="1">
               <a:lnSpc>
                 <a:spcPct val="100000"/>
               </a:lnSpc>
@@ -2261,7 +2262,7 @@
           <a:bodyPr/>
           <a:lstStyle/>
           <a:p>
-            <a:pPr marL="0" marR="0" lvl="0" indent="0" algn="l" defTabSz="914400" rtl="0" eaLnBrk="1" fontAlgn="auto" latinLnBrk="0" hangingPunct="1">
+            <a:pPr marL="0" marR="0" lvl="0" indent="0" algn="ctr" defTabSz="914400" rtl="0" eaLnBrk="1" fontAlgn="auto" latinLnBrk="0" hangingPunct="1">
               <a:lnSpc>
                 <a:spcPct val="100000"/>
               </a:lnSpc>
@@ -2469,7 +2470,7 @@
           <a:bodyPr/>
           <a:lstStyle/>
           <a:p>
-            <a:pPr marL="0" marR="0" lvl="0" indent="0" algn="l" defTabSz="914400" rtl="0" eaLnBrk="1" fontAlgn="auto" latinLnBrk="0" hangingPunct="1">
+            <a:pPr marL="0" marR="0" lvl="0" indent="0" algn="ctr" defTabSz="914400" rtl="0" eaLnBrk="1" fontAlgn="auto" latinLnBrk="0" hangingPunct="1">
               <a:lnSpc>
                 <a:spcPct val="100000"/>
               </a:lnSpc>
@@ -2511,7 +2512,7 @@
         </p:nvSpPr>
         <p:spPr>
           <a:xfrm>
-            <a:off x="1079497" y="3959352"/>
+            <a:off x="877640" y="3948660"/>
             <a:ext cx="3130989" cy="212563"/>
           </a:xfrm>
           <a:prstGeom prst="rect">
@@ -2614,7 +2615,7 @@
           <a:bodyPr/>
           <a:lstStyle/>
           <a:p>
-            <a:pPr marL="0" marR="0" lvl="0" indent="0" algn="l" defTabSz="914400" rtl="0" eaLnBrk="1" fontAlgn="auto" latinLnBrk="0" hangingPunct="1">
+            <a:pPr marL="0" marR="0" lvl="0" indent="0" algn="ctr" defTabSz="914400" rtl="0" eaLnBrk="1" fontAlgn="auto" latinLnBrk="0" hangingPunct="1">
               <a:lnSpc>
                 <a:spcPct val="100000"/>
               </a:lnSpc>
@@ -2676,7 +2677,7 @@
           <a:bodyPr/>
           <a:lstStyle/>
           <a:p>
-            <a:pPr marL="0" marR="0" lvl="0" indent="0" algn="l" defTabSz="914400" rtl="0" eaLnBrk="1" fontAlgn="auto" latinLnBrk="0" hangingPunct="1">
+            <a:pPr marL="0" marR="0" lvl="0" indent="0" algn="ctr" defTabSz="914400" rtl="0" eaLnBrk="1" fontAlgn="auto" latinLnBrk="0" hangingPunct="1">
               <a:lnSpc>
                 <a:spcPct val="100000"/>
               </a:lnSpc>
@@ -2792,7 +2793,7 @@
         </p:nvSpPr>
         <p:spPr>
           <a:xfrm>
-            <a:off x="5985597" y="3293503"/>
+            <a:off x="5839039" y="3335662"/>
             <a:ext cx="1781381" cy="365759"/>
           </a:xfrm>
           <a:prstGeom prst="rect">
@@ -2807,7 +2808,7 @@
           </a:bodyPr>
           <a:lstStyle/>
           <a:p>
-            <a:pPr marL="0" marR="0" lvl="0" indent="0" algn="l" defTabSz="914400" rtl="0" eaLnBrk="1" fontAlgn="auto" latinLnBrk="0" hangingPunct="1">
+            <a:pPr marL="0" marR="0" lvl="0" indent="0" algn="ctr" defTabSz="914400" rtl="0" eaLnBrk="1" fontAlgn="auto" latinLnBrk="0" hangingPunct="1">
               <a:lnSpc>
                 <a:spcPct val="100000"/>
               </a:lnSpc>
@@ -2918,7 +2919,7 @@
           <a:bodyPr/>
           <a:lstStyle/>
           <a:p>
-            <a:pPr marL="0" marR="0" lvl="0" indent="0" algn="l" defTabSz="914400" rtl="0" eaLnBrk="1" fontAlgn="auto" latinLnBrk="0" hangingPunct="1">
+            <a:pPr marL="0" marR="0" lvl="0" indent="0" algn="ctr" defTabSz="914400" rtl="0" eaLnBrk="1" fontAlgn="auto" latinLnBrk="0" hangingPunct="1">
               <a:lnSpc>
                 <a:spcPct val="100000"/>
               </a:lnSpc>
@@ -2960,7 +2961,7 @@
         </p:nvSpPr>
         <p:spPr>
           <a:xfrm>
-            <a:off x="4768596" y="3959352"/>
+            <a:off x="4676972" y="3980290"/>
             <a:ext cx="2651760" cy="146304"/>
           </a:xfrm>
           <a:prstGeom prst="rect">
@@ -3063,7 +3064,7 @@
           <a:bodyPr/>
           <a:lstStyle/>
           <a:p>
-            <a:pPr marL="0" marR="0" lvl="0" indent="0" algn="l" defTabSz="914400" rtl="0" eaLnBrk="1" fontAlgn="auto" latinLnBrk="0" hangingPunct="1">
+            <a:pPr marL="0" marR="0" lvl="0" indent="0" algn="ctr" defTabSz="914400" rtl="0" eaLnBrk="1" fontAlgn="auto" latinLnBrk="0" hangingPunct="1">
               <a:lnSpc>
                 <a:spcPct val="100000"/>
               </a:lnSpc>
@@ -3125,7 +3126,7 @@
           <a:bodyPr/>
           <a:lstStyle/>
           <a:p>
-            <a:pPr marL="0" marR="0" lvl="0" indent="0" algn="l" defTabSz="914400" rtl="0" eaLnBrk="1" fontAlgn="auto" latinLnBrk="0" hangingPunct="1">
+            <a:pPr marL="0" marR="0" lvl="0" indent="0" algn="ctr" defTabSz="914400" rtl="0" eaLnBrk="1" fontAlgn="auto" latinLnBrk="0" hangingPunct="1">
               <a:lnSpc>
                 <a:spcPct val="100000"/>
               </a:lnSpc>
@@ -3256,7 +3257,7 @@
           </a:bodyPr>
           <a:lstStyle/>
           <a:p>
-            <a:pPr marL="0" marR="0" lvl="0" indent="0" algn="l" defTabSz="914400" rtl="0" eaLnBrk="1" fontAlgn="auto" latinLnBrk="0" hangingPunct="1">
+            <a:pPr marL="0" marR="0" lvl="0" indent="0" algn="ctr" defTabSz="914400" rtl="0" eaLnBrk="1" fontAlgn="auto" latinLnBrk="0" hangingPunct="1">
               <a:lnSpc>
                 <a:spcPct val="100000"/>
               </a:lnSpc>
@@ -3333,7 +3334,7 @@
           <a:bodyPr/>
           <a:lstStyle/>
           <a:p>
-            <a:pPr marL="0" marR="0" lvl="0" indent="0" algn="l" defTabSz="914400" rtl="0" eaLnBrk="1" fontAlgn="auto" latinLnBrk="0" hangingPunct="1">
+            <a:pPr marL="0" marR="0" lvl="0" indent="0" algn="ctr" defTabSz="914400" rtl="0" eaLnBrk="1" fontAlgn="auto" latinLnBrk="0" hangingPunct="1">
               <a:lnSpc>
                 <a:spcPct val="100000"/>
               </a:lnSpc>
@@ -3375,7 +3376,7 @@
         </p:nvSpPr>
         <p:spPr>
           <a:xfrm>
-            <a:off x="7844964" y="3956513"/>
+            <a:off x="7776826" y="3966245"/>
             <a:ext cx="3533030" cy="175987"/>
           </a:xfrm>
           <a:prstGeom prst="rect">
@@ -3478,7 +3479,7 @@
           <a:bodyPr/>
           <a:lstStyle/>
           <a:p>
-            <a:pPr marL="0" marR="0" lvl="0" indent="0" algn="l" defTabSz="914400" rtl="0" eaLnBrk="1" fontAlgn="auto" latinLnBrk="0" hangingPunct="1">
+            <a:pPr marL="0" marR="0" lvl="0" indent="0" defTabSz="914400" rtl="0" eaLnBrk="1" fontAlgn="auto" latinLnBrk="0" hangingPunct="1">
               <a:lnSpc>
                 <a:spcPct val="100000"/>
               </a:lnSpc>
@@ -3538,7 +3539,7 @@
           <a:bodyPr/>
           <a:lstStyle/>
           <a:p>
-            <a:pPr marL="0" marR="0" lvl="0" indent="0" algn="l" defTabSz="914400" rtl="0" eaLnBrk="1" fontAlgn="auto" latinLnBrk="0" hangingPunct="1">
+            <a:pPr marL="0" marR="0" lvl="0" indent="0" defTabSz="914400" rtl="0" eaLnBrk="1" fontAlgn="auto" latinLnBrk="0" hangingPunct="1">
               <a:lnSpc>
                 <a:spcPct val="100000"/>
               </a:lnSpc>
@@ -3598,7 +3599,7 @@
           <a:bodyPr/>
           <a:lstStyle/>
           <a:p>
-            <a:pPr marL="0" marR="0" lvl="0" indent="0" algn="l" defTabSz="914400" rtl="0" eaLnBrk="1" fontAlgn="auto" latinLnBrk="0" hangingPunct="1">
+            <a:pPr marL="0" marR="0" lvl="0" indent="0" defTabSz="914400" rtl="0" eaLnBrk="1" fontAlgn="auto" latinLnBrk="0" hangingPunct="1">
               <a:lnSpc>
                 <a:spcPct val="100000"/>
               </a:lnSpc>
@@ -3655,7 +3656,7 @@
           </a:bodyPr>
           <a:lstStyle/>
           <a:p>
-            <a:pPr marL="0" marR="0" lvl="0" indent="0" algn="l" defTabSz="914400" rtl="0" eaLnBrk="1" fontAlgn="auto" latinLnBrk="0" hangingPunct="1">
+            <a:pPr marL="0" marR="0" lvl="0" indent="0" defTabSz="914400" rtl="0" eaLnBrk="1" fontAlgn="auto" latinLnBrk="0" hangingPunct="1">
               <a:lnSpc>
                 <a:spcPct val="100000"/>
               </a:lnSpc>
@@ -3729,7 +3730,7 @@
           </a:bodyPr>
           <a:lstStyle/>
           <a:p>
-            <a:pPr marL="0" marR="0" lvl="0" indent="0" algn="l" defTabSz="914400" rtl="0" eaLnBrk="1" fontAlgn="auto" latinLnBrk="0" hangingPunct="1">
+            <a:pPr marL="0" marR="0" lvl="0" indent="0" defTabSz="914400" rtl="0" eaLnBrk="1" fontAlgn="auto" latinLnBrk="0" hangingPunct="1">
               <a:lnSpc>
                 <a:spcPct val="100000"/>
               </a:lnSpc>
@@ -3803,7 +3804,7 @@
           </a:bodyPr>
           <a:lstStyle/>
           <a:p>
-            <a:pPr marL="0" marR="0" lvl="0" indent="0" algn="l" defTabSz="914400" rtl="0" eaLnBrk="1" fontAlgn="auto" latinLnBrk="0" hangingPunct="1">
+            <a:pPr marL="0" marR="0" lvl="0" indent="0" defTabSz="914400" rtl="0" eaLnBrk="1" fontAlgn="auto" latinLnBrk="0" hangingPunct="1">
               <a:lnSpc>
                 <a:spcPct val="100000"/>
               </a:lnSpc>
@@ -3877,7 +3878,7 @@
           </a:bodyPr>
           <a:lstStyle/>
           <a:p>
-            <a:pPr marL="0" marR="0" lvl="0" indent="0" algn="l" defTabSz="914400" rtl="0" eaLnBrk="1" fontAlgn="auto" latinLnBrk="0" hangingPunct="1">
+            <a:pPr marL="0" marR="0" lvl="0" indent="0" defTabSz="914400" rtl="0" eaLnBrk="1" fontAlgn="auto" latinLnBrk="0" hangingPunct="1">
               <a:lnSpc>
                 <a:spcPct val="100000"/>
               </a:lnSpc>
@@ -3927,7 +3928,7 @@
             </a:endParaRPr>
           </a:p>
           <a:p>
-            <a:pPr marL="0" marR="0" lvl="0" indent="0" algn="l" defTabSz="914400" rtl="0" eaLnBrk="1" fontAlgn="auto" latinLnBrk="0" hangingPunct="1">
+            <a:pPr marL="0" marR="0" lvl="0" indent="0" defTabSz="914400" rtl="0" eaLnBrk="1" fontAlgn="auto" latinLnBrk="0" hangingPunct="1">
               <a:lnSpc>
                 <a:spcPct val="100000"/>
               </a:lnSpc>
@@ -4001,7 +4002,7 @@
           </a:bodyPr>
           <a:lstStyle/>
           <a:p>
-            <a:pPr marL="0" marR="0" lvl="0" indent="0" algn="l" defTabSz="914400" rtl="0" eaLnBrk="1" fontAlgn="auto" latinLnBrk="0" hangingPunct="1">
+            <a:pPr marL="0" marR="0" lvl="0" indent="0" defTabSz="914400" rtl="0" eaLnBrk="1" fontAlgn="auto" latinLnBrk="0" hangingPunct="1">
               <a:lnSpc>
                 <a:spcPct val="100000"/>
               </a:lnSpc>
@@ -4075,7 +4076,7 @@
           </a:bodyPr>
           <a:lstStyle/>
           <a:p>
-            <a:pPr marL="0" marR="0" lvl="0" indent="0" algn="l" defTabSz="914400" rtl="0" eaLnBrk="1" fontAlgn="auto" latinLnBrk="0" hangingPunct="1">
+            <a:pPr marL="0" marR="0" lvl="0" indent="0" defTabSz="914400" rtl="0" eaLnBrk="1" fontAlgn="auto" latinLnBrk="0" hangingPunct="1">
               <a:lnSpc>
                 <a:spcPct val="100000"/>
               </a:lnSpc>
@@ -4125,7 +4126,7 @@
             </a:endParaRPr>
           </a:p>
           <a:p>
-            <a:pPr marL="0" marR="0" lvl="0" indent="0" algn="l" defTabSz="914400" rtl="0" eaLnBrk="1" fontAlgn="auto" latinLnBrk="0" hangingPunct="1">
+            <a:pPr marL="0" marR="0" lvl="0" indent="0" defTabSz="914400" rtl="0" eaLnBrk="1" fontAlgn="auto" latinLnBrk="0" hangingPunct="1">
               <a:lnSpc>
                 <a:spcPct val="100000"/>
               </a:lnSpc>
@@ -4206,7 +4207,7 @@
           <a:bodyPr/>
           <a:lstStyle/>
           <a:p>
-            <a:pPr marL="0" marR="0" lvl="0" indent="0" algn="l" defTabSz="914400" rtl="0" eaLnBrk="1" fontAlgn="auto" latinLnBrk="0" hangingPunct="1">
+            <a:pPr marL="0" marR="0" lvl="0" indent="0" algn="ctr" defTabSz="914400" rtl="0" eaLnBrk="1" fontAlgn="auto" latinLnBrk="0" hangingPunct="1">
               <a:lnSpc>
                 <a:spcPct val="100000"/>
               </a:lnSpc>
@@ -4248,7 +4249,7 @@
         </p:nvSpPr>
         <p:spPr>
           <a:xfrm>
-            <a:off x="987552" y="6062472"/>
+            <a:off x="975842" y="6093203"/>
             <a:ext cx="640080" cy="118872"/>
           </a:xfrm>
           <a:prstGeom prst="rect">
@@ -4263,7 +4264,7 @@
           </a:bodyPr>
           <a:lstStyle/>
           <a:p>
-            <a:pPr marL="0" marR="0" lvl="0" indent="0" algn="l" defTabSz="914400" rtl="0" eaLnBrk="1" fontAlgn="auto" latinLnBrk="0" hangingPunct="1">
+            <a:pPr marL="0" marR="0" lvl="0" indent="0" algn="ctr" defTabSz="914400" rtl="0" eaLnBrk="1" fontAlgn="auto" latinLnBrk="0" hangingPunct="1">
               <a:lnSpc>
                 <a:spcPct val="100000"/>
               </a:lnSpc>
@@ -4322,7 +4323,7 @@
         </p:nvSpPr>
         <p:spPr>
           <a:xfrm>
-            <a:off x="1901952" y="6016752"/>
+            <a:off x="1901952" y="6044184"/>
             <a:ext cx="3337560" cy="210312"/>
           </a:xfrm>
           <a:prstGeom prst="rect">
@@ -4337,7 +4338,7 @@
           </a:bodyPr>
           <a:lstStyle/>
           <a:p>
-            <a:pPr marL="0" marR="0" lvl="0" indent="0" algn="l" defTabSz="914400" rtl="0" eaLnBrk="1" fontAlgn="auto" latinLnBrk="0" hangingPunct="1">
+            <a:pPr marL="0" marR="0" lvl="0" indent="0" algn="ctr" defTabSz="914400" rtl="0" eaLnBrk="1" fontAlgn="auto" latinLnBrk="0" hangingPunct="1">
               <a:lnSpc>
                 <a:spcPct val="100000"/>
               </a:lnSpc>
@@ -4396,8 +4397,8 @@
         </p:nvSpPr>
         <p:spPr>
           <a:xfrm>
-            <a:off x="7948248" y="6035040"/>
-            <a:ext cx="3017520" cy="201168"/>
+            <a:off x="10086453" y="6034030"/>
+            <a:ext cx="886347" cy="210312"/>
           </a:xfrm>
           <a:prstGeom prst="rect">
             <a:avLst/>
@@ -4411,7 +4412,7 @@
           </a:bodyPr>
           <a:lstStyle/>
           <a:p>
-            <a:pPr marL="0" marR="0" lvl="0" indent="0" algn="r" defTabSz="914400" rtl="0" eaLnBrk="1" fontAlgn="auto" latinLnBrk="0" hangingPunct="1">
+            <a:pPr marL="0" marR="0" lvl="0" indent="0" algn="ctr" defTabSz="914400" rtl="0" eaLnBrk="1" fontAlgn="auto" latinLnBrk="0" hangingPunct="1">
               <a:lnSpc>
                 <a:spcPct val="100000"/>
               </a:lnSpc>
@@ -4628,7 +4629,7 @@
           <a:bodyPr/>
           <a:lstStyle/>
           <a:p>
-            <a:pPr marL="0" marR="0" lvl="0" indent="0" algn="l" defTabSz="914400" rtl="0" eaLnBrk="1" fontAlgn="auto" latinLnBrk="0" hangingPunct="1">
+            <a:pPr marL="0" marR="0" lvl="0" indent="0" algn="ctr" defTabSz="914400" rtl="0" eaLnBrk="1" fontAlgn="auto" latinLnBrk="0" hangingPunct="1">
               <a:lnSpc>
                 <a:spcPct val="100000"/>
               </a:lnSpc>
@@ -4676,7 +4677,7 @@
         </p:nvSpPr>
         <p:spPr>
           <a:xfrm>
-            <a:off x="1173825" y="542775"/>
+            <a:off x="1190527" y="511537"/>
             <a:ext cx="2041468" cy="380122"/>
           </a:xfrm>
           <a:prstGeom prst="rect">
@@ -4689,7 +4690,7 @@
           <a:bodyPr wrap="square" lIns="254" tIns="254" rIns="254" bIns="254" rtlCol="0" anchor="ctr"/>
           <a:lstStyle/>
           <a:p>
-            <a:pPr marL="0" marR="0" lvl="0" indent="0" algn="l" defTabSz="914400" rtl="0" eaLnBrk="1" fontAlgn="auto" latinLnBrk="0" hangingPunct="1">
+            <a:pPr marL="0" marR="0" lvl="0" indent="0" algn="ctr" defTabSz="914400" rtl="0" eaLnBrk="1" fontAlgn="auto" latinLnBrk="0" hangingPunct="1">
               <a:lnSpc>
                 <a:spcPct val="100000"/>
               </a:lnSpc>
@@ -5137,7 +5138,7 @@
           </p:nvSpPr>
           <p:spPr>
             <a:xfrm>
-              <a:off x="4041648" y="4133088"/>
+              <a:off x="4021891" y="4198169"/>
               <a:ext cx="420624" cy="411480"/>
             </a:xfrm>
             <a:prstGeom prst="rect">
@@ -5383,7 +5384,7 @@
           </p:nvSpPr>
           <p:spPr>
             <a:xfrm>
-              <a:off x="6797860" y="4142233"/>
+              <a:off x="6815220" y="4142233"/>
               <a:ext cx="420624" cy="411480"/>
             </a:xfrm>
             <a:prstGeom prst="rect">
@@ -5618,7 +5619,7 @@
           </p:nvSpPr>
           <p:spPr>
             <a:xfrm>
-              <a:off x="9515975" y="4134729"/>
+              <a:off x="9500499" y="4179617"/>
               <a:ext cx="420624" cy="411480"/>
             </a:xfrm>
             <a:prstGeom prst="rect">
@@ -8856,10 +8857,10 @@
                 <a:ea typeface="Arial"/>
                 <a:cs typeface="Arial"/>
               </a:rPr>
-              <a:t>Mobile</a:t>
+              <a:t>A</a:t>
             </a:r>
             <a:r>
-              <a:rPr sz="1650" b="1" dirty="0">
+              <a:rPr sz="1650" b="1" dirty="0" err="1">
                 <a:solidFill>
                   <a:srgbClr val="182D86"/>
                 </a:solidFill>
@@ -8867,8 +8868,16 @@
                 <a:ea typeface="Arial"/>
                 <a:cs typeface="Arial"/>
               </a:rPr>
-              <a:t> application</a:t>
+              <a:t>pplication</a:t>
             </a:r>
+            <a:endParaRPr sz="1650" b="1" dirty="0">
+              <a:solidFill>
+                <a:srgbClr val="182D86"/>
+              </a:solidFill>
+              <a:latin typeface="Arial"/>
+              <a:ea typeface="Arial"/>
+              <a:cs typeface="Arial"/>
+            </a:endParaRPr>
           </a:p>
         </p:txBody>
       </p:sp>
@@ -11855,6 +11864,344 @@
 </p:sld>
 </file>
 
+<file path=ppt/slides/slide5.xml><?xml version="1.0" encoding="utf-8"?>
+<p:sld xmlns:a="http://schemas.openxmlformats.org/drawingml/2006/main" xmlns:r="http://schemas.openxmlformats.org/officeDocument/2006/relationships" xmlns:p="http://schemas.openxmlformats.org/presentationml/2006/main">
+  <p:cSld>
+    <p:bg>
+      <p:bgPr>
+        <a:solidFill>
+          <a:srgbClr val="FFFFFF"/>
+        </a:solidFill>
+        <a:effectLst/>
+      </p:bgPr>
+    </p:bg>
+    <p:spTree>
+      <p:nvGrpSpPr>
+        <p:cNvPr id="1" name=""/>
+        <p:cNvGrpSpPr/>
+        <p:nvPr/>
+      </p:nvGrpSpPr>
+      <p:grpSpPr>
+        <a:xfrm>
+          <a:off x="0" y="0"/>
+          <a:ext cx="0" cy="0"/>
+          <a:chOff x="0" y="0"/>
+          <a:chExt cx="0" cy="0"/>
+        </a:xfrm>
+      </p:grpSpPr>
+      <p:sp>
+        <p:nvSpPr>
+          <p:cNvPr id="6" name="Rounded Rectangle 5">
+            <a:extLst>
+              <a:ext uri="{FF2B5EF4-FFF2-40B4-BE49-F238E27FC236}">
+                <a16:creationId xmlns:a16="http://schemas.microsoft.com/office/drawing/2014/main" id="{54FFD8F9-D07A-4A27-AAE1-D9C6D1D32800}"/>
+              </a:ext>
+            </a:extLst>
+          </p:cNvPr>
+          <p:cNvSpPr>
+            <a:spLocks noGrp="1"/>
+          </p:cNvSpPr>
+          <p:nvPr/>
+        </p:nvSpPr>
+        <p:spPr>
+          <a:xfrm>
+            <a:off x="109728" y="91440"/>
+            <a:ext cx="11969496" cy="6675120"/>
+          </a:xfrm>
+          <a:prstGeom prst="roundRect">
+            <a:avLst>
+              <a:gd name="adj" fmla="val 1712"/>
+            </a:avLst>
+          </a:prstGeom>
+          <a:solidFill>
+            <a:srgbClr val="FFFFFF"/>
+          </a:solidFill>
+          <a:ln w="12668">
+            <a:solidFill>
+              <a:srgbClr val="E3DDF0"/>
+            </a:solidFill>
+          </a:ln>
+        </p:spPr>
+        <p:txBody>
+          <a:bodyPr/>
+          <a:lstStyle/>
+          <a:p>
+            <a:endParaRPr lang="en-IE"/>
+          </a:p>
+        </p:txBody>
+      </p:sp>
+      <p:sp>
+        <p:nvSpPr>
+          <p:cNvPr id="2" name="Brand">
+            <a:extLst>
+              <a:ext uri="{FF2B5EF4-FFF2-40B4-BE49-F238E27FC236}">
+                <a16:creationId xmlns:a16="http://schemas.microsoft.com/office/drawing/2014/main" id="{E2A86228-6B54-4D27-892B-E5ED2828B8BA}"/>
+              </a:ext>
+            </a:extLst>
+          </p:cNvPr>
+          <p:cNvSpPr>
+            <a:spLocks noGrp="1"/>
+          </p:cNvSpPr>
+          <p:nvPr/>
+        </p:nvSpPr>
+        <p:spPr>
+          <a:xfrm>
+            <a:off x="1333500" y="1323975"/>
+            <a:ext cx="9525000" cy="457200"/>
+          </a:xfrm>
+          <a:prstGeom prst="rect">
+            <a:avLst/>
+          </a:prstGeom>
+          <a:noFill/>
+          <a:ln w="0">
+            <a:noFill/>
+          </a:ln>
+        </p:spPr>
+        <p:txBody>
+          <a:bodyPr anchor="ctr"/>
+          <a:lstStyle>
+            <a:defPPr algn="ctr">
+              <a:defRPr lang="en-GB" sz="2250" b="1">
+                <a:solidFill>
+                  <a:srgbClr val="7B6FA8"/>
+                </a:solidFill>
+                <a:latin typeface="Aptos Display"/>
+              </a:defRPr>
+            </a:defPPr>
+          </a:lstStyle>
+          <a:p>
+            <a:pPr algn="ctr">
+              <a:defRPr lang="en-GB" sz="2250" b="1">
+                <a:solidFill>
+                  <a:srgbClr val="7B6FA8"/>
+                </a:solidFill>
+                <a:latin typeface="Aptos Display"/>
+              </a:defRPr>
+            </a:pPr>
+            <a:r>
+              <a:rPr lang="en-GB" sz="2250" b="1">
+                <a:solidFill>
+                  <a:srgbClr val="7B6FA8"/>
+                </a:solidFill>
+                <a:latin typeface="Aptos Display"/>
+              </a:rPr>
+              <a:t>TempSafe</a:t>
+            </a:r>
+          </a:p>
+        </p:txBody>
+      </p:sp>
+      <p:sp>
+        <p:nvSpPr>
+          <p:cNvPr id="3" name="Thank you">
+            <a:extLst>
+              <a:ext uri="{FF2B5EF4-FFF2-40B4-BE49-F238E27FC236}">
+                <a16:creationId xmlns:a16="http://schemas.microsoft.com/office/drawing/2014/main" id="{665B4FB2-C55F-4976-A6B7-51C5B2B06E12}"/>
+              </a:ext>
+            </a:extLst>
+          </p:cNvPr>
+          <p:cNvSpPr>
+            <a:spLocks noGrp="1"/>
+          </p:cNvSpPr>
+          <p:nvPr/>
+        </p:nvSpPr>
+        <p:spPr>
+          <a:xfrm>
+            <a:off x="1143000" y="2209800"/>
+            <a:ext cx="9906000" cy="1638300"/>
+          </a:xfrm>
+          <a:prstGeom prst="rect">
+            <a:avLst/>
+          </a:prstGeom>
+          <a:noFill/>
+          <a:ln w="0">
+            <a:noFill/>
+          </a:ln>
+        </p:spPr>
+        <p:txBody>
+          <a:bodyPr anchor="ctr"/>
+          <a:lstStyle>
+            <a:defPPr algn="ctr">
+              <a:defRPr lang="en-GB" sz="5100" b="1">
+                <a:solidFill>
+                  <a:srgbClr val="142C86"/>
+                </a:solidFill>
+                <a:latin typeface="Aptos Display"/>
+              </a:defRPr>
+            </a:defPPr>
+          </a:lstStyle>
+          <a:p>
+            <a:pPr algn="ctr">
+              <a:defRPr lang="en-GB" sz="5100" b="1">
+                <a:solidFill>
+                  <a:srgbClr val="142C86"/>
+                </a:solidFill>
+                <a:latin typeface="Aptos Display"/>
+              </a:defRPr>
+            </a:pPr>
+            <a:r>
+              <a:rPr lang="en-GB" sz="5100" b="1">
+                <a:solidFill>
+                  <a:srgbClr val="142C86"/>
+                </a:solidFill>
+                <a:latin typeface="Aptos Display"/>
+              </a:rPr>
+              <a:t>Thank you for</a:t>
+            </a:r>
+          </a:p>
+          <a:p>
+            <a:pPr algn="ctr">
+              <a:defRPr lang="en-GB" sz="5100" b="1">
+                <a:solidFill>
+                  <a:srgbClr val="142C86"/>
+                </a:solidFill>
+                <a:latin typeface="Aptos Display"/>
+              </a:defRPr>
+            </a:pPr>
+            <a:r>
+              <a:rPr lang="en-GB" sz="5100" b="1">
+                <a:solidFill>
+                  <a:srgbClr val="142C86"/>
+                </a:solidFill>
+                <a:latin typeface="Aptos Display"/>
+              </a:rPr>
+              <a:t>your attention</a:t>
+            </a:r>
+          </a:p>
+        </p:txBody>
+      </p:sp>
+      <p:sp>
+        <p:nvSpPr>
+          <p:cNvPr id="4" name="Questions">
+            <a:extLst>
+              <a:ext uri="{FF2B5EF4-FFF2-40B4-BE49-F238E27FC236}">
+                <a16:creationId xmlns:a16="http://schemas.microsoft.com/office/drawing/2014/main" id="{6BA01AB6-26EF-45DD-8071-791BC100B912}"/>
+              </a:ext>
+            </a:extLst>
+          </p:cNvPr>
+          <p:cNvSpPr>
+            <a:spLocks noGrp="1"/>
+          </p:cNvSpPr>
+          <p:nvPr/>
+        </p:nvSpPr>
+        <p:spPr>
+          <a:xfrm>
+            <a:off x="1905000" y="4324350"/>
+            <a:ext cx="8382000" cy="542925"/>
+          </a:xfrm>
+          <a:prstGeom prst="rect">
+            <a:avLst/>
+          </a:prstGeom>
+          <a:noFill/>
+          <a:ln w="0">
+            <a:noFill/>
+          </a:ln>
+        </p:spPr>
+        <p:txBody>
+          <a:bodyPr anchor="ctr"/>
+          <a:lstStyle>
+            <a:defPPr algn="ctr">
+              <a:defRPr lang="en-GB" sz="2550" b="1">
+                <a:solidFill>
+                  <a:srgbClr val="1D3D9C"/>
+                </a:solidFill>
+                <a:latin typeface="Aptos"/>
+              </a:defRPr>
+            </a:defPPr>
+          </a:lstStyle>
+          <a:p>
+            <a:pPr algn="ctr">
+              <a:defRPr lang="en-GB" sz="2550" b="1">
+                <a:solidFill>
+                  <a:srgbClr val="1D3D9C"/>
+                </a:solidFill>
+                <a:latin typeface="Aptos"/>
+              </a:defRPr>
+            </a:pPr>
+            <a:r>
+              <a:rPr lang="en-GB" sz="2550" b="1">
+                <a:solidFill>
+                  <a:srgbClr val="1D3D9C"/>
+                </a:solidFill>
+                <a:latin typeface="Aptos"/>
+              </a:rPr>
+              <a:t>Any questions?</a:t>
+            </a:r>
+          </a:p>
+        </p:txBody>
+      </p:sp>
+      <p:sp>
+        <p:nvSpPr>
+          <p:cNvPr id="5" name="Invitation">
+            <a:extLst>
+              <a:ext uri="{FF2B5EF4-FFF2-40B4-BE49-F238E27FC236}">
+                <a16:creationId xmlns:a16="http://schemas.microsoft.com/office/drawing/2014/main" id="{22D2E916-FE63-4445-BE90-23EB325E5F22}"/>
+              </a:ext>
+            </a:extLst>
+          </p:cNvPr>
+          <p:cNvSpPr>
+            <a:spLocks noGrp="1"/>
+          </p:cNvSpPr>
+          <p:nvPr/>
+        </p:nvSpPr>
+        <p:spPr>
+          <a:xfrm>
+            <a:off x="1905000" y="4924425"/>
+            <a:ext cx="8382000" cy="428625"/>
+          </a:xfrm>
+          <a:prstGeom prst="rect">
+            <a:avLst/>
+          </a:prstGeom>
+          <a:noFill/>
+          <a:ln w="0">
+            <a:noFill/>
+          </a:ln>
+        </p:spPr>
+        <p:txBody>
+          <a:bodyPr anchor="ctr"/>
+          <a:lstStyle>
+            <a:defPPr algn="ctr">
+              <a:defRPr lang="en-GB" sz="1800" b="0">
+                <a:solidFill>
+                  <a:srgbClr val="5E6373"/>
+                </a:solidFill>
+                <a:latin typeface="Aptos"/>
+              </a:defRPr>
+            </a:defPPr>
+          </a:lstStyle>
+          <a:p>
+            <a:pPr algn="ctr">
+              <a:defRPr lang="en-GB" sz="1800" b="0">
+                <a:solidFill>
+                  <a:srgbClr val="5E6373"/>
+                </a:solidFill>
+                <a:latin typeface="Aptos"/>
+              </a:defRPr>
+            </a:pPr>
+            <a:r>
+              <a:rPr lang="en-GB" sz="1800" b="0">
+                <a:solidFill>
+                  <a:srgbClr val="5E6373"/>
+                </a:solidFill>
+                <a:latin typeface="Aptos"/>
+              </a:rPr>
+              <a:t>We’re happy to answer them.</a:t>
+            </a:r>
+          </a:p>
+        </p:txBody>
+      </p:sp>
+    </p:spTree>
+    <p:extLst>
+      <p:ext uri="{BB962C8B-B14F-4D97-AF65-F5344CB8AC3E}">
+        <p14:creationId xmlns:p14="http://schemas.microsoft.com/office/powerpoint/2010/main" val="1155991747"/>
+      </p:ext>
+    </p:extLst>
+  </p:cSld>
+  <p:clrMapOvr>
+    <a:masterClrMapping/>
+  </p:clrMapOvr>
+</p:sld>
+</file>
+
 <file path=ppt/theme/theme1.xml><?xml version="1.0" encoding="utf-8"?>
 <a:theme xmlns:a="http://schemas.openxmlformats.org/drawingml/2006/main" name="Office Theme">
   <a:themeElements>

</xml_diff>

<commit_message>
Clarify web application scope and planned PWA
</commit_message>
<xml_diff>
--- a/docs/presentation/TempSafe_Elevator_Pitch.pptx
+++ b/docs/presentation/TempSafe_Elevator_Pitch.pptx
@@ -783,7 +783,8 @@
           <a:lstStyle/>
           <a:p>
             <a:r>
-              <a:t>Planned student prototype, demonstrated on a bench with no medicines. One physical box, with multiple users assigned to the same box ID. The existing SCD-41 provides the temperature measurement for this release. Its humidity and CO2 capabilities are outside the application scope. The photographed white dome module is not the temperature sensor used for this project. The physical LED is single-colour and lights for Warning or Alert, with distinct blinking for sensor failure. Application colours are separate. Phone notifications are Must Have and require connectivity, permission and a delivery channel to be selected and tested. Buzzer is Should Have. During an outage the Pi stores sample attempts locally and uploads them with original times after reconnection. Shannon follows her service procedures; the prototype makes no clinical decisions. Hardware: Raspberry Pi 400 powered from mains and connected over Wi-Fi. A separate computer accesses it using https://connect.raspberrypi.com/devices for remote desktop or shell access. This development access is separate from the TempSafe application and device data flow. The simple plastic or wooden box is still to be selected; the image illustrates a plastic option. Source: https://www.raspberrypi.com/documentation/services/connect.html and https://www.adafruit.com/product/5190. Image: generated using OpenAI image generation on 8 October 2026 as a concept illustration, not a photo of completed hardware. Device observations are published to a cloud MQTT broker over TLS. The ingestion worker stores them in MySQL and acknowledges committed sample IDs; the browser accesses FastAPI over HTTPS. This pub-sub design follows the IoT G-CA1 brief. Sources: project functional requirements, hardware parts list and initial test plan in this repository.</a:t>
+              <a:t>Planned student prototype, demonstrated on a bench with no medicines. One physical box, with multiple users assigned to the same box ID. The existing SCD-41 provides the temperature measurement for this release. Its humidity and CO2 capabilities are outside the application scope. The photographed white dome module is not the temperature sensor used for this project. The physical LED is single-colour and lights for Warning or Alert, with distinct blinking for sensor failure. Application colours are separate. Phone notifications are Must Have and require connectivity, permission and a delivery channel to be selected and tested. Buzzer is Should Have. During an outage the Pi stores sample attempts locally and uploads them with original times after reconnection. Shannon follows her service procedures; the prototype makes no clinical decisions. Hardware: Raspberry Pi 400 powered from mains and connected over Wi-Fi. A separate computer accesses it using https://connect.raspberrypi.com/devices for remote desktop or shell access. This development access is separate from the TempSafe application and device data flow. The simple plastic or wooden box is still to be selected; the image illustrates a plastic option. Source: https://www.raspberrypi.com/documentation/services/connect.html and https://www.adafruit.com/product/5190. Image: generated using OpenAI image generation on 8 October 2026 as a concept illustration, not a photo of completed hardware. Device observations are published to a cloud MQTT broker over TLS. The ingestion worker stores them in MySQL and acknowledges committed sample IDs; the browser accesses FastAPI over HTTPS. This pub-sub design follows the IoT G-CA1 brief. Sources: project functional requirements, hardware parts list and initial test plan in this repository.
+TempSafe is planned as a responsive web application with a Python/FastAPI backend and an HTML, CSS and JavaScript frontend. Planned Progressive Web App (PWA) support would add a home-screen icon and standalone launch on supported phones. PWA installation and Web Push require browser/platform testing. A separate native mobile application is a possible future extension outside this prototype. Phone mock-ups show the responsive web interface, not a native mobile application. On iOS/iPadOS, the proposed Web Push channel requires home-screen installation.</a:t>
             </a:r>
           </a:p>
         </p:txBody>
@@ -865,7 +866,8 @@
 This is the proposed interface journey using synthetic demonstration data. The application is not yet implemented.
 One: she is with a patient. At 14:04 she gets a quiet warning at 24 degrees. At 14:05 the box goes above 25: the single-colour LED remains lit and the optional buzzer sounds if implemented, and she gets one urgent alert. Repeated unchanged states are suppressed; delivery requires connectivity, permission and supported Web Push.
 Two: when she has a free second, one glance at the app tells her everything: Alert, freshness and the latest temperature; an optional estimated excursion summary can show 12 minutes and a maximum of 27.4 degrees. The status is never just colour: there is always an icon, a word and the temperature.
-Three: after the call she opens the web dashboard. She sees the temperature over time and the recorded observations, including gaps and errors. If implemented, the estimated summary can show a period from 14:05 to 14:23 and a maximum of 27.4 degrees; it does not prove continuous exposure. With this she can follow her service's policy and seek the appropriate review of the medicine. TempSafe gives her the facts; Shannon makes the decision.</a:t>
+Three: after the call she opens the web dashboard. She sees the temperature over time and the recorded observations, including gaps and errors. If implemented, the estimated summary can show a period from 14:05 to 14:23 and a maximum of 27.4 degrees; it does not prove continuous exposure. With this she can follow her service's policy and seek the appropriate review of the medicine. TempSafe gives her the facts; Shannon makes the decision.
+TempSafe is planned as a responsive web application with a Python/FastAPI backend and an HTML, CSS and JavaScript frontend. Planned Progressive Web App (PWA) support would add a home-screen icon and standalone launch on supported phones. PWA installation and Web Push require browser/platform testing. A separate native mobile application is a possible future extension outside this prototype. Phone mock-ups show the responsive web interface, not a native mobile application. On iOS/iPadOS, the proposed Web Push channel requires home-screen installation.</a:t>
             </a:r>
           </a:p>
         </p:txBody>
@@ -4708,7 +4710,7 @@
               <a:defRPr/>
             </a:pPr>
             <a:r>
-              <a:rPr kumimoji="0" lang="en-US" sz="2000" b="1" i="0" u="none" strike="noStrike" kern="1200" cap="none" spc="0" normalizeH="0" baseline="0" noProof="0" dirty="0">
+              <a:rPr kumimoji="0" lang="en-US" sz="1700" b="1" i="0" u="none" strike="noStrike" kern="1200" cap="none" spc="0" normalizeH="0" baseline="0" noProof="0" dirty="0">
                 <a:ln>
                   <a:noFill/>
                 </a:ln>
@@ -4722,26 +4724,9 @@
                 <a:ea typeface="Aptos" pitchFamily="34" charset="-122"/>
                 <a:cs typeface="Aptos" pitchFamily="34" charset="-120"/>
               </a:rPr>
-              <a:t>App: </a:t>
+              <a:t>Web app: TempSafe</a:t>
             </a:r>
-            <a:r>
-              <a:rPr kumimoji="0" lang="en-US" sz="2000" b="0" i="0" u="none" strike="noStrike" kern="1200" cap="none" spc="0" normalizeH="0" baseline="0" noProof="0" dirty="0">
-                <a:ln>
-                  <a:noFill/>
-                </a:ln>
-                <a:solidFill>
-                  <a:srgbClr val="143A9D"/>
-                </a:solidFill>
-                <a:effectLst/>
-                <a:uLnTx/>
-                <a:uFillTx/>
-                <a:latin typeface="Aptos" pitchFamily="34" charset="0"/>
-                <a:ea typeface="Aptos" pitchFamily="34" charset="-122"/>
-                <a:cs typeface="Aptos" pitchFamily="34" charset="-120"/>
-              </a:rPr>
-              <a:t>TempSafe</a:t>
-            </a:r>
-            <a:endParaRPr kumimoji="0" lang="en-US" sz="2000" b="0" i="0" u="none" strike="noStrike" kern="1200" cap="none" spc="0" normalizeH="0" baseline="0" noProof="0" dirty="0">
+            <a:endParaRPr kumimoji="0" lang="en-US" sz="1700" b="0" i="0" u="none" strike="noStrike" kern="1200" cap="none" spc="0" normalizeH="0" baseline="0" noProof="0" dirty="0">
               <a:ln>
                 <a:noFill/>
               </a:ln>
@@ -4832,7 +4817,7 @@
         </p:nvSpPr>
         <p:spPr>
           <a:xfrm>
-            <a:off x="81225" y="98503"/>
+            <a:off x="89408" y="182880"/>
             <a:ext cx="11930888" cy="6583680"/>
           </a:xfrm>
           <a:prstGeom prst="roundRect">
@@ -5372,7 +5357,7 @@
             <a:bodyPr/>
             <a:lstStyle/>
             <a:p>
-              <a:endParaRPr lang="en-IE"/>
+              <a:endParaRPr lang="en-IE" dirty="0"/>
             </a:p>
           </p:txBody>
         </p:sp>
@@ -5531,9 +5516,9 @@
         <p:grpSpPr>
           <a:xfrm>
             <a:off x="9400032" y="4040241"/>
-            <a:ext cx="2423160" cy="1691640"/>
+            <a:ext cx="2331720" cy="1691640"/>
             <a:chOff x="9400032" y="4040241"/>
-            <a:chExt cx="2423160" cy="1691640"/>
+            <a:chExt cx="2331720" cy="1691640"/>
           </a:xfrm>
         </p:grpSpPr>
         <p:sp>
@@ -5701,8 +5686,8 @@
           </p:nvSpPr>
           <p:spPr>
             <a:xfrm>
-              <a:off x="9582911" y="4790223"/>
-              <a:ext cx="2240281" cy="918973"/>
+              <a:off x="9582912" y="4790223"/>
+              <a:ext cx="2130552" cy="918973"/>
             </a:xfrm>
             <a:prstGeom prst="rect">
               <a:avLst/>
@@ -8263,7 +8248,7 @@
                 <a:ea typeface="Arial"/>
                 <a:cs typeface="Arial"/>
               </a:rPr>
-              <a:t>Check the app</a:t>
+              <a:t>Open web app</a:t>
             </a:r>
           </a:p>
         </p:txBody>
@@ -8857,18 +8842,7 @@
                 <a:ea typeface="Arial"/>
                 <a:cs typeface="Arial"/>
               </a:rPr>
-              <a:t>A</a:t>
-            </a:r>
-            <a:r>
-              <a:rPr sz="1650" b="1" dirty="0" err="1">
-                <a:solidFill>
-                  <a:srgbClr val="182D86"/>
-                </a:solidFill>
-                <a:latin typeface="Arial"/>
-                <a:ea typeface="Arial"/>
-                <a:cs typeface="Arial"/>
-              </a:rPr>
-              <a:t>pplication</a:t>
+              <a:t>Web application</a:t>
             </a:r>
             <a:endParaRPr sz="1650" b="1" dirty="0">
               <a:solidFill>
@@ -10361,7 +10335,7 @@
                 <a:ea typeface="Aptos" pitchFamily="34" charset="-122"/>
                 <a:cs typeface="Aptos" pitchFamily="34" charset="-120"/>
               </a:rPr>
-              <a:t>Early UI concepts: optional summaries; red LED wording superseded</a:t>
+              <a:t>Web application concept · home-screen access planned</a:t>
             </a:r>
             <a:endParaRPr lang="en-US" sz="1800" dirty="0"/>
           </a:p>

</xml_diff>

<commit_message>
Update elevator pitch presentation
</commit_message>
<xml_diff>
--- a/docs/presentation/TempSafe_Elevator_Pitch.pptx
+++ b/docs/presentation/TempSafe_Elevator_Pitch.pptx
@@ -6029,6 +6029,66 @@
               </a:rPr>
               <a:t>.</a:t>
             </a:r>
+          </a:p>
+        </p:txBody>
+      </p:sp>
+      <p:sp>
+        <p:nvSpPr>
+          <p:cNvPr id="35" name="Shape 7">
+            <a:extLst>
+              <a:ext uri="{FF2B5EF4-FFF2-40B4-BE49-F238E27FC236}">
+                <a16:creationId xmlns:a16="http://schemas.microsoft.com/office/drawing/2014/main" id="{1AFE1865-5EC8-B5BD-C6FF-2398D122DF0B}"/>
+              </a:ext>
+            </a:extLst>
+          </p:cNvPr>
+          <p:cNvSpPr/>
+          <p:nvPr/>
+        </p:nvSpPr>
+        <p:spPr>
+          <a:xfrm>
+            <a:off x="7855527" y="381097"/>
+            <a:ext cx="3901371" cy="548640"/>
+          </a:xfrm>
+          <a:prstGeom prst="roundRect">
+            <a:avLst>
+              <a:gd name="adj" fmla="val 42857"/>
+            </a:avLst>
+          </a:prstGeom>
+          <a:solidFill>
+            <a:srgbClr val="ECE9FB"/>
+          </a:solidFill>
+          <a:ln w="10160">
+            <a:solidFill>
+              <a:srgbClr val="DAD3EF"/>
+            </a:solidFill>
+            <a:prstDash val="solid"/>
+          </a:ln>
+        </p:spPr>
+        <p:txBody>
+          <a:bodyPr/>
+          <a:lstStyle/>
+          <a:p>
+            <a:pPr lvl="0" algn="ctr">
+              <a:defRPr/>
+            </a:pPr>
+            <a:r>
+              <a:rPr lang="en-IE" dirty="0"/>
+              <a:t>Designed for Advanced Paramedics </a:t>
+            </a:r>
+            <a:endParaRPr kumimoji="0" lang="en-IE" sz="1800" b="0" i="0" u="none" strike="noStrike" kern="1200" cap="none" spc="0" normalizeH="0" baseline="0" noProof="0" dirty="0">
+              <a:ln>
+                <a:noFill/>
+              </a:ln>
+              <a:solidFill>
+                <a:prstClr val="black"/>
+              </a:solidFill>
+              <a:effectLst/>
+              <a:uLnTx/>
+              <a:uFillTx/>
+              <a:latin typeface="Aptos"/>
+              <a:ea typeface="+mn-ea"/>
+              <a:cs typeface="+mn-cs"/>
+            </a:endParaRPr>
           </a:p>
         </p:txBody>
       </p:sp>

</xml_diff>